<commit_message>
Grup bilgisi + GitHub linki; gemini-proExtended yeniden puanlama
- isimler eklendi (Murat Ozdemir 255129022, Can Bozbuga, Ahmet Ates)
- gemini-proExtended tam yanitla yeniden puanlandi (27->28)
- sunum + siralama tablosu guncellendi

Co-Authored-By: Claude Opus 4.8 <noreply@anthropic.com>
</commit_message>
<xml_diff>
--- a/report/QMOOD_jsoup_sunum.pptx
+++ b/report/QMOOD_jsoup_sunum.pptx
@@ -2185,7 +2185,7 @@
         <p:spPr>
           <a:xfrm>
             <a:off x="731520" y="5852160"/>
-            <a:ext cx="10424160" cy="365760"/>
+            <a:ext cx="10698480" cy="365760"/>
           </a:xfrm>
           <a:prstGeom prst="rect">
             <a:avLst/>
@@ -2209,7 +2209,7 @@
                 <a:ea typeface="Calibri" pitchFamily="34" charset="-122"/>
                 <a:cs typeface="Calibri" pitchFamily="34" charset="-120"/>
               </a:rPr>
-              <a:t>Grup: &lt;isimler / numaralar&gt;      Tarih: 2026-06-10</a:t>
+              <a:t>Grup: Murat Özdemir (255129022) · Can Bozbuğa · Ahmet Ateş      Tarih: 2026-06-10</a:t>
             </a:r>
             <a:endParaRPr lang="en-US" sz="1300" dirty="0"/>
           </a:p>

</xml_diff>

<commit_message>
Grup bilgisi guncellendi: ogrenci numaralari + Mustafa Can Bozbuga tam adi
Co-Authored-By: Claude Opus 4.8 <noreply@anthropic.com>
</commit_message>
<xml_diff>
--- a/report/QMOOD_jsoup_sunum.pptx
+++ b/report/QMOOD_jsoup_sunum.pptx
@@ -2185,7 +2185,7 @@
         <p:spPr>
           <a:xfrm>
             <a:off x="731520" y="5852160"/>
-            <a:ext cx="10698480" cy="365760"/>
+            <a:ext cx="10881360" cy="365760"/>
           </a:xfrm>
           <a:prstGeom prst="rect">
             <a:avLst/>
@@ -2201,7 +2201,7 @@
               <a:buNone/>
             </a:pPr>
             <a:r>
-              <a:rPr lang="en-US" sz="1300" dirty="0">
+              <a:rPr lang="en-US" sz="1200" dirty="0">
                 <a:solidFill>
                   <a:srgbClr val="CADCFC"/>
                 </a:solidFill>
@@ -2209,9 +2209,9 @@
                 <a:ea typeface="Calibri" pitchFamily="34" charset="-122"/>
                 <a:cs typeface="Calibri" pitchFamily="34" charset="-120"/>
               </a:rPr>
-              <a:t>Grup: Murat Özdemir (255129022) · Can Bozbuğa · Ahmet Ateş      Tarih: 2026-06-10</a:t>
-            </a:r>
-            <a:endParaRPr lang="en-US" sz="1300" dirty="0"/>
+              <a:t>Grup: Murat Özdemir (255129022) · Mustafa Can Bozbuğa (255129050) · Ahmet Ateş (255129005)      Tarih: 2026-06-10</a:t>
+            </a:r>
+            <a:endParaRPr lang="en-US" sz="1200" dirty="0"/>
           </a:p>
         </p:txBody>
       </p:sp>

</xml_diff>

<commit_message>
Sunum tam Turkce karakterli hale getirildi
Co-Authored-By: Claude Opus 4.8 <noreply@anthropic.com>
</commit_message>
<xml_diff>
--- a/report/QMOOD_jsoup_sunum.pptx
+++ b/report/QMOOD_jsoup_sunum.pptx
@@ -2016,7 +2016,7 @@
                 <a:ea typeface="Calibri" pitchFamily="34" charset="-122"/>
                 <a:cs typeface="Calibri" pitchFamily="34" charset="-120"/>
               </a:rPr>
-              <a:t>YAZILIM MIMARILERI VE TASARIM YONTEMLERI</a:t>
+              <a:t>YAZILIM MİMARİLERİ VE TASARIM YÖNTEMLERİ</a:t>
             </a:r>
             <a:endParaRPr lang="en-US" sz="1400" dirty="0"/>
           </a:p>
@@ -2058,7 +2058,7 @@
                 <a:ea typeface="Georgia" pitchFamily="34" charset="-122"/>
                 <a:cs typeface="Georgia" pitchFamily="34" charset="-120"/>
               </a:rPr>
-              <a:t>QMOOD Tabanli Yazilim Kalitesi Analizi</a:t>
+              <a:t>QMOOD Tabanlı Yazılım Kalitesi Analizi</a:t>
             </a:r>
             <a:endParaRPr lang="en-US" sz="4000" dirty="0"/>
           </a:p>
@@ -2078,7 +2078,7 @@
                 <a:ea typeface="Georgia" pitchFamily="34" charset="-122"/>
                 <a:cs typeface="Georgia" pitchFamily="34" charset="-120"/>
               </a:rPr>
-              <a:t>ve LLM Destekli Degerlendirme</a:t>
+              <a:t>ve LLM Destekli Değerlendirme</a:t>
             </a:r>
             <a:endParaRPr lang="en-US" sz="4000" dirty="0"/>
           </a:p>
@@ -2131,7 +2131,7 @@
                 <a:ea typeface="Calibri" pitchFamily="34" charset="-122"/>
                 <a:cs typeface="Calibri" pitchFamily="34" charset="-120"/>
               </a:rPr>
-              <a:t>jsoup (Java HTML Parser) — 11 surum (1.14.1 → 1.22.2)</a:t>
+              <a:t>jsoup (Java HTML Parser) — 11 sürüm (1.14.1 → 1.22.2)</a:t>
             </a:r>
             <a:endParaRPr lang="en-US" sz="1700" dirty="0"/>
           </a:p>
@@ -2170,7 +2170,7 @@
                 <a:ea typeface="Calibri" pitchFamily="34" charset="-122"/>
                 <a:cs typeface="Calibri" pitchFamily="34" charset="-120"/>
               </a:rPr>
-              <a:t>17 LLM yapilandirmasi  ·  kendi yazdigimiz metrik cikarici  ·  6 kalite niteligi</a:t>
+              <a:t>17 LLM yapılandırması  ·  kendi yazdığımız metrik çıkarıcı  ·  6 kalite niteliği</a:t>
             </a:r>
             <a:endParaRPr lang="en-US" sz="1400" dirty="0"/>
           </a:p>
@@ -2280,7 +2280,7 @@
                 <a:ea typeface="Calibri" pitchFamily="34" charset="-122"/>
                 <a:cs typeface="Calibri" pitchFamily="34" charset="-120"/>
               </a:rPr>
-              <a:t>LLM DESTEKLI DEGERLENDIRME</a:t>
+              <a:t>LLM DESTEKLİ DEĞERLENDİRME</a:t>
             </a:r>
             <a:endParaRPr lang="en-US" sz="1400" dirty="0"/>
           </a:p>
@@ -2319,7 +2319,7 @@
                 <a:ea typeface="Georgia" pitchFamily="34" charset="-122"/>
                 <a:cs typeface="Georgia" pitchFamily="34" charset="-120"/>
               </a:rPr>
-              <a:t>17 LLM Yapilandirmasi, Tek Ortak Prompt</a:t>
+              <a:t>17 LLM Yapılandırması, Tek Ortak Prompt</a:t>
             </a:r>
             <a:endParaRPr lang="en-US" sz="3200" dirty="0"/>
           </a:p>
@@ -2988,7 +2988,7 @@
                 <a:ea typeface="Calibri" pitchFamily="34" charset="-122"/>
                 <a:cs typeface="Calibri" pitchFamily="34" charset="-120"/>
               </a:rPr>
-              <a:t>Ayni prompt (01_full_evolution_prompt.txt) — rol atama, denklem gomme, sayisal-kanit zorunlulugu, yapilandirilmis 5 baslik.</a:t>
+              <a:t>Aynı prompt (01_full_evolution_prompt.txt) — rol atama, denklem gömme, sayısal-kanıt zorunluluğu, yapılandırılmış 5 başlık.</a:t>
             </a:r>
             <a:endParaRPr lang="en-US" sz="1350" dirty="0"/>
           </a:p>
@@ -3059,7 +3059,7 @@
                 <a:ea typeface="Calibri" pitchFamily="34" charset="-122"/>
                 <a:cs typeface="Calibri" pitchFamily="34" charset="-120"/>
               </a:rPr>
-              <a:t>LLM KARSILASTIRMA</a:t>
+              <a:t>LLM KARŞILAŞTIRMA</a:t>
             </a:r>
             <a:endParaRPr lang="en-US" sz="1200" dirty="0"/>
           </a:p>
@@ -3098,7 +3098,7 @@
                 <a:ea typeface="Georgia" pitchFamily="34" charset="-122"/>
                 <a:cs typeface="Georgia" pitchFamily="34" charset="-120"/>
               </a:rPr>
-              <a:t>Elestirel Puanlama — Siralama (40 uzerinden)</a:t>
+              <a:t>Eleştirel Puanlama — Sıralama (40 üzerinden)</a:t>
             </a:r>
             <a:endParaRPr lang="en-US" sz="3000" dirty="0"/>
           </a:p>
@@ -3168,7 +3168,7 @@
                 <a:ea typeface="Georgia" pitchFamily="34" charset="-122"/>
                 <a:cs typeface="Georgia" pitchFamily="34" charset="-120"/>
               </a:rPr>
-              <a:t>8 kriter x 5 puan</a:t>
+              <a:t>8 kriter × 5 puan</a:t>
             </a:r>
             <a:endParaRPr lang="en-US" sz="1400" dirty="0"/>
           </a:p>
@@ -3210,7 +3210,7 @@
                 <a:ea typeface="Calibri" pitchFamily="34" charset="-122"/>
                 <a:cs typeface="Calibri" pitchFamily="34" charset="-120"/>
               </a:rPr>
-              <a:t>Sayisal kanit · Denklem dogrulugu · DSC-artefakt farkindaligi · zamansal granulerlik · halusinasyon direnci · refactoring somutlugu · sinirlama farkindaligi · analitik derinlik</a:t>
+              <a:t>Sayısal kanıt · Denklem doğruluğu · DSC-artefakt farkındalığı · zamansal granülerlik · halüsinasyon direnci · refactoring somutluğu · sınırlama farkındalığı · analitik derinlik</a:t>
             </a:r>
             <a:endParaRPr lang="en-US" sz="1250" dirty="0"/>
           </a:p>
@@ -3267,7 +3267,7 @@
                 <a:ea typeface="Calibri" pitchFamily="34" charset="-122"/>
                 <a:cs typeface="Calibri" pitchFamily="34" charset="-120"/>
               </a:rPr>
-              <a:t>En zayif grup: Gemini Flash kademesi</a:t>
+              <a:t>En zayıf grup: Gemini Flash kademesi</a:t>
             </a:r>
             <a:endParaRPr lang="en-US" sz="1400" dirty="0"/>
           </a:p>
@@ -3338,7 +3338,7 @@
                 <a:ea typeface="Calibri" pitchFamily="34" charset="-122"/>
                 <a:cs typeface="Calibri" pitchFamily="34" charset="-120"/>
               </a:rPr>
-              <a:t>LLM KARSILASTIRMA</a:t>
+              <a:t>LLM KARŞILAŞTIRMA</a:t>
             </a:r>
             <a:endParaRPr lang="en-US" sz="1200" dirty="0"/>
           </a:p>
@@ -3377,7 +3377,7 @@
                 <a:ea typeface="Georgia" pitchFamily="34" charset="-122"/>
                 <a:cs typeface="Georgia" pitchFamily="34" charset="-120"/>
               </a:rPr>
-              <a:t>Elestirel Bulgular</a:t>
+              <a:t>Eleştirel Bulgular</a:t>
             </a:r>
             <a:endParaRPr lang="en-US" sz="3000" dirty="0"/>
           </a:p>
@@ -3439,7 +3439,7 @@
                 <a:ea typeface="Calibri" pitchFamily="34" charset="-122"/>
                 <a:cs typeface="Calibri" pitchFamily="34" charset="-120"/>
               </a:rPr>
-              <a:t>Uzlasi yuksek.  </a:t>
+              <a:t>Uzlaşı yüksek.  </a:t>
             </a:r>
             <a:pPr indent="0" marL="0">
               <a:lnSpc>
@@ -3456,7 +3456,7 @@
                 <a:ea typeface="Calibri" pitchFamily="34" charset="-122"/>
                 <a:cs typeface="Calibri" pitchFamily="34" charset="-120"/>
               </a:rPr>
-              <a:t>17 modelin tamami 'dis kalite artiyor, ic kalite geriliyor' anlatisinda birlesti — bizim analizimizle ortusuyor.</a:t>
+              <a:t>17 modelin tamamı 'dış kalite artıyor, iç kalite geriliyor' anlatısında birleşti — bizim analizimizle örtüşüyor.</a:t>
             </a:r>
             <a:endParaRPr lang="en-US" sz="1500" dirty="0"/>
           </a:p>
@@ -3518,7 +3518,7 @@
                 <a:ea typeface="Calibri" pitchFamily="34" charset="-122"/>
                 <a:cs typeface="Calibri" pitchFamily="34" charset="-120"/>
               </a:rPr>
-              <a:t>Metrik halusinasyonu YOK.  </a:t>
+              <a:t>Metrik halüsinasyonu YOK.  </a:t>
             </a:r>
             <a:pPr indent="0" marL="0">
               <a:lnSpc>
@@ -3535,7 +3535,7 @@
                 <a:ea typeface="Calibri" pitchFamily="34" charset="-122"/>
                 <a:cs typeface="Calibri" pitchFamily="34" charset="-120"/>
               </a:rPr>
-              <a:t>Hicbir model sayisal deger uydurmadi (sayisal-kanit kuralinin basarisi).</a:t>
+              <a:t>Hiçbir model sayısal değer uydurmadı (sayısal-kanıt kuralının başarısı).</a:t>
             </a:r>
             <a:endParaRPr lang="en-US" sz="1500" dirty="0"/>
           </a:p>
@@ -3597,7 +3597,7 @@
                 <a:ea typeface="Calibri" pitchFamily="34" charset="-122"/>
                 <a:cs typeface="Calibri" pitchFamily="34" charset="-120"/>
               </a:rPr>
-              <a:t>Sinif adi halusinasyonu.  </a:t>
+              <a:t>Sınıf adı halüsinasyonu.  </a:t>
             </a:r>
             <a:pPr indent="0" marL="0">
               <a:lnSpc>
@@ -3614,7 +3614,7 @@
                 <a:ea typeface="Calibri" pitchFamily="34" charset="-122"/>
                 <a:cs typeface="Calibri" pitchFamily="34" charset="-120"/>
               </a:rPr>
-              <a:t>Bazi modeller toplu veriden turetilemeyecek sinif adlarini (Parser, Element...) refactoring hedefi gosterdi.</a:t>
+              <a:t>Bazı modeller toplu veriden türetilemeyecek sınıf adlarını (Parser, Element...) refactoring hedefi gösterdi.</a:t>
             </a:r>
             <a:endParaRPr lang="en-US" sz="1500" dirty="0"/>
           </a:p>
@@ -3676,7 +3676,7 @@
                 <a:ea typeface="Calibri" pitchFamily="34" charset="-122"/>
                 <a:cs typeface="Calibri" pitchFamily="34" charset="-120"/>
               </a:rPr>
-              <a:t>Ayirt edici: DSC-artefakt.  </a:t>
+              <a:t>Ayırt edici: DSC-artefakt.  </a:t>
             </a:r>
             <a:pPr indent="0" marL="0">
               <a:lnSpc>
@@ -3693,7 +3693,7 @@
                 <a:ea typeface="Calibri" pitchFamily="34" charset="-122"/>
                 <a:cs typeface="Calibri" pitchFamily="34" charset="-120"/>
               </a:rPr>
-              <a:t>En guclu yanit, Reusability +%27'nin tamaminin boyut kaynakli oldugunu sayisal ayristirdi (kalite bileseni 1.969→1.958).</a:t>
+              <a:t>En güçlü yanıt, Reusability +%27'nin tamamının boyut kaynaklı olduğunu sayısal ayrıştırdı (kalite bileşeni 1.969→1.958).</a:t>
             </a:r>
             <a:endParaRPr lang="en-US" sz="1500" dirty="0"/>
           </a:p>
@@ -3755,7 +3755,7 @@
                 <a:ea typeface="Calibri" pitchFamily="34" charset="-122"/>
                 <a:cs typeface="Calibri" pitchFamily="34" charset="-120"/>
               </a:rPr>
-              <a:t>Kademe &gt; saglayici.  </a:t>
+              <a:t>Kademe &gt; sağlayıcı.  </a:t>
             </a:r>
             <a:pPr indent="0" marL="0">
               <a:lnSpc>
@@ -3772,7 +3772,7 @@
                 <a:ea typeface="Calibri" pitchFamily="34" charset="-122"/>
                 <a:cs typeface="Calibri" pitchFamily="34" charset="-120"/>
               </a:rPr>
-              <a:t>Ust kademe reasoning modlari belirgin derin; ayni ailede Flash &lt;&lt; Pro.</a:t>
+              <a:t>Üst kademe reasoning modları belirgin derin; aynı ailede Flash &lt;&lt; Pro.</a:t>
             </a:r>
             <a:endParaRPr lang="en-US" sz="1500" dirty="0"/>
           </a:p>
@@ -3863,7 +3863,7 @@
                 <a:ea typeface="Calibri" pitchFamily="34" charset="-122"/>
                 <a:cs typeface="Calibri" pitchFamily="34" charset="-120"/>
               </a:rPr>
-              <a:t>SONUC VE GELECEK CALISMALAR</a:t>
+              <a:t>SONUÇ VE GELECEK ÇALIŞMALAR</a:t>
             </a:r>
             <a:endParaRPr lang="en-US" sz="1400" dirty="0"/>
           </a:p>
@@ -3902,7 +3902,7 @@
                 <a:ea typeface="Georgia" pitchFamily="34" charset="-122"/>
                 <a:cs typeface="Georgia" pitchFamily="34" charset="-120"/>
               </a:rPr>
-              <a:t>Sonuc</a:t>
+              <a:t>Sonuç</a:t>
             </a:r>
             <a:endParaRPr lang="en-US" sz="3400" dirty="0"/>
           </a:p>
@@ -3947,7 +3947,7 @@
                 <a:ea typeface="Calibri" pitchFamily="34" charset="-122"/>
                 <a:cs typeface="Calibri" pitchFamily="34" charset="-120"/>
               </a:rPr>
-              <a:t>jsoup, 1.14→1.22 boyunca olgun ve kontrollu yonetilen bir kutuphane: yeniden kullanilabilirlik ve esneklik artarken anlasilabilirlik kademeli azaldi; cohesion en belirgin teknik borc egilimi. QMOOD bu cift yonlu evrimi nicel olarak yakalayabildi.</a:t>
+              <a:t>jsoup, 1.14→1.22 boyunca olgun ve kontrollü yönetilen bir kütüphane: yeniden kullanılabilirlik ve esneklik artarken anlaşılabilirlik kademeli azaldı; cohesion en belirgin teknik borç eğilimi. QMOOD bu çift yönlü evrimi nicel olarak yakalayabildi.</a:t>
             </a:r>
             <a:endParaRPr lang="en-US" sz="1650" dirty="0"/>
           </a:p>
@@ -3967,7 +3967,7 @@
                 <a:ea typeface="Calibri" pitchFamily="34" charset="-122"/>
                 <a:cs typeface="Calibri" pitchFamily="34" charset="-120"/>
               </a:rPr>
-              <a:t>LLM'ler nitelikte uzlasti; ayrisma derinlikte oldu — ust kademe reasoning modlari, ciktiyi sinif duzeyi veriyle capraz dogrulama kosuluyla guvenilir yorum uretti.</a:t>
+              <a:t>LLM'ler nitelikte uzlaştı; ayrışma derinlikte oldu — üst kademe reasoning modları, çıktıyı sınıf düzeyi veriyle çapraz doğrulama koşuluyla güvenilir yorum üretti.</a:t>
             </a:r>
             <a:endParaRPr lang="en-US" sz="1650" dirty="0"/>
           </a:p>
@@ -4006,7 +4006,7 @@
                 <a:ea typeface="Georgia" pitchFamily="34" charset="-122"/>
                 <a:cs typeface="Georgia" pitchFamily="34" charset="-120"/>
               </a:rPr>
-              <a:t>Gelecek calismalar</a:t>
+              <a:t>Gelecek çalışmalar</a:t>
             </a:r>
             <a:endParaRPr lang="en-US" sz="1900" dirty="0"/>
           </a:p>
@@ -4046,7 +4046,7 @@
                 <a:ea typeface="Calibri" pitchFamily="34" charset="-122"/>
                 <a:cs typeface="Calibri" pitchFamily="34" charset="-120"/>
               </a:rPr>
-              <a:t>Coklu proje karsilastirmasi (C# + Java)</a:t>
+              <a:t>Çoklu proje karşılaştırması (C# + Java)</a:t>
             </a:r>
             <a:endParaRPr lang="en-US" sz="1500" dirty="0"/>
           </a:p>
@@ -4064,7 +4064,7 @@
                 <a:ea typeface="Calibri" pitchFamily="34" charset="-122"/>
                 <a:cs typeface="Calibri" pitchFamily="34" charset="-120"/>
               </a:rPr>
-              <a:t>LLM yanitlarinin API ile otomatik, cok-tekrarli toplanmasi + istatistik anlamlilik testi</a:t>
+              <a:t>LLM yanıtlarının API ile otomatik, çok-tekrarlı toplanması + istatistik anlamlılık testi</a:t>
             </a:r>
             <a:endParaRPr lang="en-US" sz="1500" dirty="0"/>
           </a:p>
@@ -4082,7 +4082,7 @@
                 <a:ea typeface="Calibri" pitchFamily="34" charset="-122"/>
                 <a:cs typeface="Calibri" pitchFamily="34" charset="-120"/>
               </a:rPr>
-              <a:t>Metrik egilimleri ile gercek hata/commit kayitlari arasindaki korelasyon</a:t>
+              <a:t>Metrik eğilimleri ile gerçek hata/commit kayıtları arasındaki korelasyon</a:t>
             </a:r>
             <a:endParaRPr lang="en-US" sz="1500" dirty="0"/>
           </a:p>
@@ -4153,7 +4153,7 @@
                 <a:ea typeface="Calibri" pitchFamily="34" charset="-122"/>
                 <a:cs typeface="Calibri" pitchFamily="34" charset="-120"/>
               </a:rPr>
-              <a:t>GIRIS</a:t>
+              <a:t>GIRIŞ</a:t>
             </a:r>
             <a:endParaRPr lang="en-US" sz="1200" dirty="0"/>
           </a:p>
@@ -4192,7 +4192,7 @@
                 <a:ea typeface="Georgia" pitchFamily="34" charset="-122"/>
                 <a:cs typeface="Georgia" pitchFamily="34" charset="-120"/>
               </a:rPr>
-              <a:t>Amac ve Kapsam</a:t>
+              <a:t>Amaç ve Kapsam</a:t>
             </a:r>
             <a:endParaRPr lang="en-US" sz="3000" dirty="0"/>
           </a:p>
@@ -4251,7 +4251,7 @@
                 <a:ea typeface="Georgia" pitchFamily="34" charset="-122"/>
                 <a:cs typeface="Georgia" pitchFamily="34" charset="-120"/>
               </a:rPr>
-              <a:t>Amac</a:t>
+              <a:t>Amaç</a:t>
             </a:r>
             <a:endParaRPr lang="en-US" sz="1900" dirty="0"/>
           </a:p>
@@ -4290,7 +4290,7 @@
                 <a:ea typeface="Calibri" pitchFamily="34" charset="-122"/>
                 <a:cs typeface="Calibri" pitchFamily="34" charset="-120"/>
               </a:rPr>
-              <a:t>jsoup'un 11 surumunu QMOOD modeliyle analiz edip kalite evrimini olcmek; ayni metrikleri &gt;=3 LLM'e verip yorum yeteneklerini kiyaslamak.</a:t>
+              <a:t>jsoup'un 11 sürümünü QMOOD modeliyle analiz edip kalite evrimini ölçmek; aynı metrikleri ≥3 LLM'e verip yorum yeteneklerini kıyaslamak.</a:t>
             </a:r>
             <a:endParaRPr lang="en-US" sz="1550" dirty="0"/>
           </a:p>
@@ -4388,7 +4388,7 @@
                 <a:ea typeface="Calibri" pitchFamily="34" charset="-122"/>
                 <a:cs typeface="Calibri" pitchFamily="34" charset="-120"/>
               </a:rPr>
-              <a:t>Tek/surekli git gecmisi, zengin kalitim-polimorfizm (Node→Element...), yonetilebilir boyut (~250 sinif), duzenli surum yayini.</a:t>
+              <a:t>Tek/sürekli git geçmişi, zengin kalıtım-polimorfizm (Node→Element...), yönetilebilir boyut (~250 sınıf), düzenli sürüm yayını.</a:t>
             </a:r>
             <a:endParaRPr lang="en-US" sz="1550" dirty="0"/>
           </a:p>
@@ -4447,7 +4447,7 @@
                 <a:ea typeface="Georgia" pitchFamily="34" charset="-122"/>
                 <a:cs typeface="Georgia" pitchFamily="34" charset="-120"/>
               </a:rPr>
-              <a:t>Ozgunluk</a:t>
+              <a:t>Özgünlük</a:t>
             </a:r>
             <a:endParaRPr lang="en-US" sz="1900" dirty="0"/>
           </a:p>
@@ -4486,7 +4486,7 @@
                 <a:ea typeface="Calibri" pitchFamily="34" charset="-122"/>
                 <a:cs typeface="Calibri" pitchFamily="34" charset="-120"/>
               </a:rPr>
-              <a:t>Hicbir hazir arac yok: metrikler javalang ile kendi cozumleyicimizle cikarildi (yonerge: hazir sonuc kullanimi yasak).</a:t>
+              <a:t>Hiçbir hazır araç yok: metrikler javalang ile kendi çözümleyicimizle çıkarıldı (yönerge: hazır sonuç kullanımı yasak).</a:t>
             </a:r>
             <a:endParaRPr lang="en-US" sz="1550" dirty="0"/>
           </a:p>
@@ -4557,7 +4557,7 @@
                 <a:ea typeface="Calibri" pitchFamily="34" charset="-122"/>
                 <a:cs typeface="Calibri" pitchFamily="34" charset="-120"/>
               </a:rPr>
-              <a:t>YONTEM</a:t>
+              <a:t>YÖNTEM</a:t>
             </a:r>
             <a:endParaRPr lang="en-US" sz="1200" dirty="0"/>
           </a:p>
@@ -4596,7 +4596,7 @@
                 <a:ea typeface="Georgia" pitchFamily="34" charset="-122"/>
                 <a:cs typeface="Georgia" pitchFamily="34" charset="-120"/>
               </a:rPr>
-              <a:t>QMOOD Modeli: Metrik → Tasarim Ozelligi → Kalite</a:t>
+              <a:t>QMOOD Modeli: Metrik → Tasarım Özelliği → Kalite</a:t>
             </a:r>
             <a:endParaRPr lang="en-US" sz="3000" dirty="0"/>
           </a:p>
@@ -4638,7 +4638,7 @@
                 <a:ea typeface="Calibri" pitchFamily="34" charset="-122"/>
                 <a:cs typeface="Calibri" pitchFamily="34" charset="-120"/>
               </a:rPr>
-              <a:t>Tasarim metrikleri (sistem duzeyi)
+              <a:t>Tasarım metrikleri (sistem düzeyi)
 </a:t>
             </a:r>
             <a:endParaRPr lang="en-US" sz="1600" dirty="0"/>
@@ -4659,7 +4659,7 @@
                 <a:ea typeface="Calibri" pitchFamily="34" charset="-122"/>
                 <a:cs typeface="Calibri" pitchFamily="34" charset="-120"/>
               </a:rPr>
-              <a:t>DSC boyut · NOH hiyerarsi · ANA soyutlama · DAM kapsulleme · DCC coupling · CAM cohesion · MOA kompozisyon · MFA kalitim · NOP polimorfizm · CIS mesajlasma · NOM karmasiklik</a:t>
+              <a:t>DSC boyut · NOH hiyerarşi · ANA soyutlama · DAM kapsülleme · DCC coupling · CAM cohesion · MOA kompozisyon · MFA kalıtım · NOP polimorfizm · CIS mesajlaşma · NOM karmaşıklık</a:t>
             </a:r>
             <a:endParaRPr lang="en-US" sz="1600" dirty="0"/>
           </a:p>
@@ -4701,7 +4701,7 @@
                 <a:ea typeface="Calibri" pitchFamily="34" charset="-122"/>
                 <a:cs typeface="Calibri" pitchFamily="34" charset="-120"/>
               </a:rPr>
-              <a:t>6 Kalite Niteligi
+              <a:t>6 Kalite Niteliği
 </a:t>
             </a:r>
             <a:endParaRPr lang="en-US" sz="1600" dirty="0"/>
@@ -5001,7 +5001,7 @@
                 <a:ea typeface="Calibri" pitchFamily="34" charset="-122"/>
                 <a:cs typeface="Calibri" pitchFamily="34" charset="-120"/>
               </a:rPr>
-              <a:t>YONTEM</a:t>
+              <a:t>YÖNTEM</a:t>
             </a:r>
             <a:endParaRPr lang="en-US" sz="1200" dirty="0"/>
           </a:p>
@@ -5040,7 +5040,7 @@
                 <a:ea typeface="Georgia" pitchFamily="34" charset="-122"/>
                 <a:cs typeface="Georgia" pitchFamily="34" charset="-120"/>
               </a:rPr>
-              <a:t>Metrik Cikarim Pipeline'i (kendi gelistirdigimiz)</a:t>
+              <a:t>Metrik Çıkarım Pipeline'ı (kendi geliştirdiğimiz)</a:t>
             </a:r>
             <a:endParaRPr lang="en-US" sz="3000" dirty="0"/>
           </a:p>
@@ -5211,7 +5211,7 @@
                 <a:ea typeface="Calibri" pitchFamily="34" charset="-122"/>
                 <a:cs typeface="Calibri" pitchFamily="34" charset="-120"/>
               </a:rPr>
-              <a:t>11 surumu git archive ile indir</a:t>
+              <a:t>11 sürümü git archive ile indir</a:t>
             </a:r>
             <a:endParaRPr lang="en-US" sz="1150" dirty="0"/>
           </a:p>
@@ -5553,7 +5553,7 @@
                 <a:ea typeface="Calibri" pitchFamily="34" charset="-122"/>
                 <a:cs typeface="Calibri" pitchFamily="34" charset="-120"/>
               </a:rPr>
-              <a:t>Sistem duzeyi QMOOD + kalite</a:t>
+              <a:t>Sistem düzeyi QMOOD + kalite</a:t>
             </a:r>
             <a:endParaRPr lang="en-US" sz="1150" dirty="0"/>
           </a:p>
@@ -5724,7 +5724,7 @@
                 <a:ea typeface="Calibri" pitchFamily="34" charset="-122"/>
                 <a:cs typeface="Calibri" pitchFamily="34" charset="-120"/>
               </a:rPr>
-              <a:t>CSV tablolari uret</a:t>
+              <a:t>CSV tabloları üret</a:t>
             </a:r>
             <a:endParaRPr lang="en-US" sz="1150" dirty="0"/>
           </a:p>
@@ -6066,7 +6066,7 @@
                 <a:ea typeface="Calibri" pitchFamily="34" charset="-122"/>
                 <a:cs typeface="Calibri" pitchFamily="34" charset="-120"/>
               </a:rPr>
-              <a:t>Prompt + karsilastirma</a:t>
+              <a:t>Prompt + karşılaştırma</a:t>
             </a:r>
             <a:endParaRPr lang="en-US" sz="1150" dirty="0"/>
           </a:p>
@@ -6105,7 +6105,7 @@
                 <a:ea typeface="Calibri" pitchFamily="34" charset="-122"/>
                 <a:cs typeface="Calibri" pitchFamily="34" charset="-120"/>
               </a:rPr>
-              <a:t>144 → 184 sinif  ·  73 → 91 dosya  ·  cozumlenemeyen dosya = 0</a:t>
+              <a:t>144 → 184 sınıf  ·  73 → 91 dosya  ·  çözümlenemeyen dosya = 0</a:t>
             </a:r>
             <a:endParaRPr lang="en-US" sz="1500" dirty="0"/>
           </a:p>
@@ -6176,7 +6176,7 @@
                 <a:ea typeface="Calibri" pitchFamily="34" charset="-122"/>
                 <a:cs typeface="Calibri" pitchFamily="34" charset="-120"/>
               </a:rPr>
-              <a:t>ANALIZ SURECI</a:t>
+              <a:t>ANALIZ SÜRECI</a:t>
             </a:r>
             <a:endParaRPr lang="en-US" sz="1200" dirty="0"/>
           </a:p>
@@ -6215,7 +6215,7 @@
                 <a:ea typeface="Georgia" pitchFamily="34" charset="-122"/>
                 <a:cs typeface="Georgia" pitchFamily="34" charset="-120"/>
               </a:rPr>
-              <a:t>Veri Seti: Tasarim Boyutu Buyumesi</a:t>
+              <a:t>Veri Seti: Tasarım Boyutu Büyümesi</a:t>
             </a:r>
             <a:endParaRPr lang="en-US" sz="3000" dirty="0"/>
           </a:p>
@@ -6358,7 +6358,7 @@
                 <a:ea typeface="Calibri" pitchFamily="34" charset="-122"/>
                 <a:cs typeface="Calibri" pitchFamily="34" charset="-120"/>
               </a:rPr>
-              <a:t>DSC (sinif sayisi) buyumesi</a:t>
+              <a:t>DSC (sınıf sayısı) büyümesi</a:t>
             </a:r>
             <a:endParaRPr lang="en-US" sz="1250" dirty="0"/>
           </a:p>
@@ -6487,7 +6487,7 @@
                 <a:ea typeface="Calibri" pitchFamily="34" charset="-122"/>
                 <a:cs typeface="Calibri" pitchFamily="34" charset="-120"/>
               </a:rPr>
-              <a:t>analiz edilen surum</a:t>
+              <a:t>analiz edilen sürüm</a:t>
             </a:r>
             <a:endParaRPr lang="en-US" sz="1250" dirty="0"/>
           </a:p>
@@ -6616,7 +6616,7 @@
                 <a:ea typeface="Calibri" pitchFamily="34" charset="-122"/>
                 <a:cs typeface="Calibri" pitchFamily="34" charset="-120"/>
               </a:rPr>
-              <a:t>NOM (ort. metot/sinif)</a:t>
+              <a:t>NOM (ort. metot/sınıf)</a:t>
             </a:r>
             <a:endParaRPr lang="en-US" sz="1250" dirty="0"/>
           </a:p>
@@ -6704,7 +6704,7 @@
                 <a:ea typeface="Calibri" pitchFamily="34" charset="-122"/>
                 <a:cs typeface="Calibri" pitchFamily="34" charset="-120"/>
               </a:rPr>
-              <a:t>SONUCLAR</a:t>
+              <a:t>SONUÇLAR</a:t>
             </a:r>
             <a:endParaRPr lang="en-US" sz="1200" dirty="0"/>
           </a:p>
@@ -6813,7 +6813,7 @@
                 <a:ea typeface="Calibri" pitchFamily="34" charset="-122"/>
                 <a:cs typeface="Calibri" pitchFamily="34" charset="-120"/>
               </a:rPr>
-              <a:t>Pozitif nitelikler artiyor (Reusability +%9, Flexibility +%8); </a:t>
+              <a:t>Pozitif nitelikler artıyor (Reusability +%9, Flexibility +%8); </a:t>
             </a:r>
             <a:pPr algn="ctr" indent="0" marL="0">
               <a:buNone/>
@@ -6827,7 +6827,7 @@
                 <a:ea typeface="Calibri" pitchFamily="34" charset="-122"/>
                 <a:cs typeface="Calibri" pitchFamily="34" charset="-120"/>
               </a:rPr>
-              <a:t>Understandability tek yonlu kotulesiyor (-%20). </a:t>
+              <a:t>Understandability tek yönlü kötüleşiyor (-%20). </a:t>
             </a:r>
             <a:pPr algn="ctr" indent="0" marL="0">
               <a:buNone/>
@@ -6841,7 +6841,7 @@
                 <a:ea typeface="Calibri" pitchFamily="34" charset="-122"/>
                 <a:cs typeface="Calibri" pitchFamily="34" charset="-120"/>
               </a:rPr>
-              <a:t>Cift yonlu evrim.</a:t>
+              <a:t>Çift yönlü evrim.</a:t>
             </a:r>
             <a:endParaRPr lang="en-US" sz="1450" dirty="0"/>
           </a:p>
@@ -6912,7 +6912,7 @@
                 <a:ea typeface="Calibri" pitchFamily="34" charset="-122"/>
                 <a:cs typeface="Calibri" pitchFamily="34" charset="-120"/>
               </a:rPr>
-              <a:t>SONUCLAR</a:t>
+              <a:t>SONUÇLAR</a:t>
             </a:r>
             <a:endParaRPr lang="en-US" sz="1200" dirty="0"/>
           </a:p>
@@ -6951,7 +6951,7 @@
                 <a:ea typeface="Georgia" pitchFamily="34" charset="-122"/>
                 <a:cs typeface="Georgia" pitchFamily="34" charset="-120"/>
               </a:rPr>
-              <a:t>Coupling ↑ vs Cohesion ↓ — Teknik Borc Makasi</a:t>
+              <a:t>Coupling ↑ vs Cohesion ↓ — Teknik Borç Makası</a:t>
             </a:r>
             <a:endParaRPr lang="en-US" sz="3000" dirty="0"/>
           </a:p>
@@ -7094,7 +7094,7 @@
                 <a:ea typeface="Calibri" pitchFamily="34" charset="-122"/>
                 <a:cs typeface="Calibri" pitchFamily="34" charset="-120"/>
               </a:rPr>
-              <a:t>CAM (cohesion) dususu</a:t>
+              <a:t>CAM (cohesion) düşüşü</a:t>
             </a:r>
             <a:endParaRPr lang="en-US" sz="1250" dirty="0"/>
           </a:p>
@@ -7206,7 +7206,7 @@
                 <a:ea typeface="Calibri" pitchFamily="34" charset="-122"/>
                 <a:cs typeface="Calibri" pitchFamily="34" charset="-120"/>
               </a:rPr>
-              <a:t>LCOM (CK) artisi — capraz dogrulama</a:t>
+              <a:t>LCOM (CK) artışı — çapraz doğrulama</a:t>
             </a:r>
             <a:endParaRPr lang="en-US" sz="1250" dirty="0"/>
           </a:p>
@@ -7318,7 +7318,7 @@
                 <a:ea typeface="Calibri" pitchFamily="34" charset="-122"/>
                 <a:cs typeface="Calibri" pitchFamily="34" charset="-120"/>
               </a:rPr>
-              <a:t>DCC/CBO (coupling) artisi</a:t>
+              <a:t>DCC/CBO (coupling) artışı</a:t>
             </a:r>
             <a:endParaRPr lang="en-US" sz="1250" dirty="0"/>
           </a:p>
@@ -7389,7 +7389,7 @@
                 <a:ea typeface="Calibri" pitchFamily="34" charset="-122"/>
                 <a:cs typeface="Calibri" pitchFamily="34" charset="-120"/>
               </a:rPr>
-              <a:t>TARTISMA</a:t>
+              <a:t>TARTIŞMA</a:t>
             </a:r>
             <a:endParaRPr lang="en-US" sz="1200" dirty="0"/>
           </a:p>
@@ -7428,7 +7428,7 @@
                 <a:ea typeface="Georgia" pitchFamily="34" charset="-122"/>
                 <a:cs typeface="Georgia" pitchFamily="34" charset="-120"/>
               </a:rPr>
-              <a:t>Teknik Borc: Kontrollu Birikim</a:t>
+              <a:t>Teknik Borç: Kontrollü Birikim</a:t>
             </a:r>
             <a:endParaRPr lang="en-US" sz="3000" dirty="0"/>
           </a:p>
@@ -7652,7 +7652,7 @@
                 <a:ea typeface="Calibri" pitchFamily="34" charset="-122"/>
                 <a:cs typeface="Calibri" pitchFamily="34" charset="-120"/>
               </a:rPr>
-              <a:t>DAM kapsulleme</a:t>
+              <a:t>DAM kapsülleme</a:t>
             </a:r>
             <a:endParaRPr lang="en-US" sz="1250" dirty="0"/>
           </a:p>
@@ -7764,7 +7764,7 @@
                 <a:ea typeface="Calibri" pitchFamily="34" charset="-122"/>
                 <a:cs typeface="Calibri" pitchFamily="34" charset="-120"/>
               </a:rPr>
-              <a:t>WMC karmasiklik</a:t>
+              <a:t>WMC karmaşıklık</a:t>
             </a:r>
             <a:endParaRPr lang="en-US" sz="1250" dirty="0"/>
           </a:p>
@@ -7918,7 +7918,7 @@
                 <a:ea typeface="Calibri" pitchFamily="34" charset="-122"/>
                 <a:cs typeface="Calibri" pitchFamily="34" charset="-120"/>
               </a:rPr>
-              <a:t>Cohesion erozyonu en guclu sinyal:  </a:t>
+              <a:t>Cohesion erozyonu en güçlü sinyal:  </a:t>
             </a:r>
             <a:pPr indent="0" marL="0">
               <a:lnSpc>
@@ -7935,7 +7935,7 @@
                 <a:ea typeface="Calibri" pitchFamily="34" charset="-122"/>
                 <a:cs typeface="Calibri" pitchFamily="34" charset="-120"/>
               </a:rPr>
-              <a:t>CAM ve LCOM iki bagimsiz metrik ayni yone isaret ediyor.  </a:t>
+              <a:t>CAM ve LCOM iki bağımsız metrik aynı yöne işaret ediyor.  </a:t>
             </a:r>
             <a:pPr indent="0" marL="0">
               <a:lnSpc>
@@ -7969,7 +7969,7 @@
                 <a:ea typeface="Calibri" pitchFamily="34" charset="-122"/>
                 <a:cs typeface="Calibri" pitchFamily="34" charset="-120"/>
               </a:rPr>
-              <a:t>MOA/MFA artisi (+%17) bilincli kompozisyon/kalitim iyilestirmesi</a:t>
+              <a:t>MOA/MFA artışı (+%17) bilinçli kompozisyon/kalıtım iyileştirmesi</a:t>
             </a:r>
             <a:pPr indent="0" marL="0">
               <a:lnSpc>
@@ -7986,7 +7986,7 @@
                 <a:ea typeface="Calibri" pitchFamily="34" charset="-122"/>
                 <a:cs typeface="Calibri" pitchFamily="34" charset="-120"/>
               </a:rPr>
-              <a:t> — yikici degil, kontrollu bir borc tablosu.</a:t>
+              <a:t> — yıkıcı değil, kontrollü bir borç tablosu.</a:t>
             </a:r>
             <a:endParaRPr lang="en-US" sz="1600" dirty="0"/>
           </a:p>
@@ -8028,7 +8028,7 @@
                 <a:ea typeface="Calibri" pitchFamily="34" charset="-122"/>
                 <a:cs typeface="Calibri" pitchFamily="34" charset="-120"/>
               </a:rPr>
-              <a:t>Kirilma noktasi ≈ 1.20.1 </a:t>
+              <a:t>Kırılma noktası ≈ 1.20.1 </a:t>
             </a:r>
             <a:pPr indent="0" marL="0">
               <a:lnSpc>
@@ -8045,7 +8045,7 @@
                 <a:ea typeface="Calibri" pitchFamily="34" charset="-122"/>
                 <a:cs typeface="Calibri" pitchFamily="34" charset="-120"/>
               </a:rPr>
-              <a:t>(ANA/DAM dip, LCOH zirve) → </a:t>
+              <a:t>(ANA/DAM dip, LCOM zirve) → </a:t>
             </a:r>
             <a:pPr indent="0" marL="0">
               <a:lnSpc>
@@ -8062,7 +8062,7 @@
                 <a:ea typeface="Calibri" pitchFamily="34" charset="-122"/>
                 <a:cs typeface="Calibri" pitchFamily="34" charset="-120"/>
               </a:rPr>
-              <a:t>1.21.2+ kismi toparlanma</a:t>
+              <a:t>1.21.2+ kısmi toparlanma</a:t>
             </a:r>
             <a:pPr indent="0" marL="0">
               <a:lnSpc>
@@ -8079,7 +8079,7 @@
                 <a:ea typeface="Calibri" pitchFamily="34" charset="-122"/>
                 <a:cs typeface="Calibri" pitchFamily="34" charset="-120"/>
               </a:rPr>
-              <a:t> (ANA, MFA, NOH yukari): ekip borcu fark edip odemeye baslamis.</a:t>
+              <a:t> (ANA, MFA, NOH yukarı): ekip borcu fark edip ödemeye başlamış.</a:t>
             </a:r>
             <a:endParaRPr lang="en-US" sz="1600" dirty="0"/>
           </a:p>
@@ -8150,7 +8150,7 @@
                 <a:ea typeface="Calibri" pitchFamily="34" charset="-122"/>
                 <a:cs typeface="Calibri" pitchFamily="34" charset="-120"/>
               </a:rPr>
-              <a:t>SONUCLAR</a:t>
+              <a:t>SONUÇLAR</a:t>
             </a:r>
             <a:endParaRPr lang="en-US" sz="1200" dirty="0"/>
           </a:p>
@@ -8189,7 +8189,7 @@
                 <a:ea typeface="Georgia" pitchFamily="34" charset="-122"/>
                 <a:cs typeface="Georgia" pitchFamily="34" charset="-120"/>
               </a:rPr>
-              <a:t>CK Metrik Ortalamalarinin Evrimi</a:t>
+              <a:t>CK Metrik Ortalamalarının Evrimi</a:t>
             </a:r>
             <a:endParaRPr lang="en-US" sz="3000" dirty="0"/>
           </a:p>
@@ -8259,7 +8259,7 @@
                 <a:ea typeface="Georgia" pitchFamily="34" charset="-122"/>
                 <a:cs typeface="Georgia" pitchFamily="34" charset="-120"/>
               </a:rPr>
-              <a:t>CK metrik degisimi (1.14.1 → 1.22.2)</a:t>
+              <a:t>CK metrik değişimi (1.14.1 → 1.22.2)</a:t>
             </a:r>
             <a:endParaRPr lang="en-US" sz="1500" dirty="0"/>
           </a:p>

</xml_diff>

<commit_message>
llm_responses senkron + yeniden uretilen yanitlarla puanlama guncellemesi
- gemini-flashExtended ve gemini-proExtended tam yanitlarla yeniden puanlandi
- flashExtended 15->30 (bol1-4 guclu); siralama + grafikler guncellendi
- bulgu rafine: belirleyici Pro/Flash kademesi degil reasoning/extended modu
- gecici dosyalar (2.md, gemini-code-*.md) temizlendi; nihai set 16 model
- tum belge/sunumda model sayisi 16'ya guncellendi

Co-Authored-By: Claude Opus 4.8 <noreply@anthropic.com>
</commit_message>
<xml_diff>
--- a/report/QMOOD_jsoup_sunum.pptx
+++ b/report/QMOOD_jsoup_sunum.pptx
@@ -2170,7 +2170,7 @@
                 <a:ea typeface="Calibri" pitchFamily="34" charset="-122"/>
                 <a:cs typeface="Calibri" pitchFamily="34" charset="-120"/>
               </a:rPr>
-              <a:t>17 LLM yapılandırması  ·  kendi yazdığımız metrik çıkarıcı  ·  6 kalite niteliği</a:t>
+              <a:t>16 LLM yapılandırması  ·  kendi yazdığımız metrik çıkarıcı  ·  6 kalite niteliği</a:t>
             </a:r>
             <a:endParaRPr lang="en-US" sz="1400" dirty="0"/>
           </a:p>
@@ -2319,7 +2319,7 @@
                 <a:ea typeface="Georgia" pitchFamily="34" charset="-122"/>
                 <a:cs typeface="Georgia" pitchFamily="34" charset="-120"/>
               </a:rPr>
-              <a:t>17 LLM Yapılandırması, Tek Ortak Prompt</a:t>
+              <a:t>16 LLM Yapılandırması, Tek Ortak Prompt</a:t>
             </a:r>
             <a:endParaRPr lang="en-US" sz="3200" dirty="0"/>
           </a:p>
@@ -3267,7 +3267,7 @@
                 <a:ea typeface="Calibri" pitchFamily="34" charset="-122"/>
                 <a:cs typeface="Calibri" pitchFamily="34" charset="-120"/>
               </a:rPr>
-              <a:t>En zayıf grup: Gemini Flash kademesi</a:t>
+              <a:t>En zayıf: Gemini Flash-Lite (18) / Standard (23)</a:t>
             </a:r>
             <a:endParaRPr lang="en-US" sz="1400" dirty="0"/>
           </a:p>
@@ -3456,7 +3456,7 @@
                 <a:ea typeface="Calibri" pitchFamily="34" charset="-122"/>
                 <a:cs typeface="Calibri" pitchFamily="34" charset="-120"/>
               </a:rPr>
-              <a:t>17 modelin tamamı 'dış kalite artıyor, iç kalite geriliyor' anlatısında birleşti — bizim analizimizle örtüşüyor.</a:t>
+              <a:t>16 modelin tamamı 'dış kalite artıyor, iç kalite geriliyor' anlatısında birleşti — bizim analizimizle örtüşüyor.</a:t>
             </a:r>
             <a:endParaRPr lang="en-US" sz="1500" dirty="0"/>
           </a:p>
@@ -3755,7 +3755,7 @@
                 <a:ea typeface="Calibri" pitchFamily="34" charset="-122"/>
                 <a:cs typeface="Calibri" pitchFamily="34" charset="-120"/>
               </a:rPr>
-              <a:t>Kademe &gt; sağlayıcı.  </a:t>
+              <a:t>Belirleyici: çalıştırma modu.  </a:t>
             </a:r>
             <a:pPr indent="0" marL="0">
               <a:lnSpc>
@@ -3772,7 +3772,7 @@
                 <a:ea typeface="Calibri" pitchFamily="34" charset="-122"/>
                 <a:cs typeface="Calibri" pitchFamily="34" charset="-120"/>
               </a:rPr>
-              <a:t>Üst kademe reasoning modları belirgin derin; aynı ailede Flash &lt;&lt; Pro.</a:t>
+              <a:t>Reasoning/extended modu kademeden önemli: Gemini Flash-Extended (30) Pro'lara yaklaştı, Flash-Lite (18) en zayıf.</a:t>
             </a:r>
             <a:endParaRPr lang="en-US" sz="1500" dirty="0"/>
           </a:p>

</xml_diff>

<commit_message>
Sunum dosyasi elle guncellendi
Co-Authored-By: Claude Opus 4.8 <noreply@anthropic.com>
</commit_message>
<xml_diff>
--- a/report/QMOOD_jsoup_sunum.pptx
+++ b/report/QMOOD_jsoup_sunum.pptx
@@ -4,6 +4,9 @@
   <p:sldMasterIdLst>
     <p:sldMasterId id="2147483648" r:id="rId1"/>
   </p:sldMasterIdLst>
+  <p:notesMasterIdLst>
+    <p:notesMasterId r:id="rId15"/>
+  </p:notesMasterIdLst>
   <p:sldIdLst>
     <p:sldId id="256" r:id="rId2"/>
     <p:sldId id="257" r:id="rId3"/>
@@ -19,11 +22,8 @@
     <p:sldId id="267" r:id="rId13"/>
     <p:sldId id="268" r:id="rId14"/>
   </p:sldIdLst>
-  <p:notesMasterIdLst>
-    <p:notesMasterId r:id="rId15"/>
-  </p:notesMasterIdLst>
-  <p:sldSz cx="12191695" cy="6858000"/>
-  <p:notesSz cx="6858000" cy="12191695"/>
+  <p:sldSz cx="12192000" cy="6858000"/>
+  <p:notesSz cx="6858000" cy="12192000"/>
   <p:defaultTextStyle>
     <a:lvl1pPr marL="0" algn="l" defTabSz="914400" rtl="0" eaLnBrk="1" latinLnBrk="0" hangingPunct="1">
       <a:defRPr sz="1800" kern="1200">
@@ -116,6 +116,11 @@
       </a:defRPr>
     </a:lvl9pPr>
   </p:defaultTextStyle>
+  <p:extLst>
+    <p:ext uri="{EFAFB233-063F-42B5-8137-9DF3F51BA10A}">
+      <p15:sldGuideLst xmlns:p15="http://schemas.microsoft.com/office/powerpoint/2012/main"/>
+    </p:ext>
+  </p:extLst>
 </p:presentation>
 </file>
 
@@ -141,234 +146,10 @@
           <a:chExt cx="0" cy="0"/>
         </a:xfrm>
       </p:grpSpPr>
-      <p:sp>
-        <p:nvSpPr>
-          <p:cNvPr id="2" name="Header Placeholder 1"/>
-          <p:cNvSpPr>
-            <a:spLocks noGrp="1"/>
-          </p:cNvSpPr>
-          <p:nvPr>
-            <p:ph type="hdr" sz="quarter"/>
-          </p:nvPr>
-        </p:nvSpPr>
-        <p:spPr>
-          <a:xfrm>
-            <a:off x="0" y="0"/>
-            <a:ext cx="2971800" cy="458788"/>
-          </a:xfrm>
-          <a:prstGeom prst="rect">
-            <a:avLst/>
-          </a:prstGeom>
-        </p:spPr>
-        <p:txBody>
-          <a:bodyPr vert="horz" lIns="91440" tIns="45720" rIns="91440" bIns="45720" rtlCol="0"/>
-          <a:lstStyle>
-            <a:lvl1pPr algn="l">
-              <a:defRPr sz="1200"/>
-            </a:lvl1pPr>
-          </a:lstStyle>
-          <a:p>
-            <a:endParaRPr lang="en-US"/>
-          </a:p>
-        </p:txBody>
-      </p:sp>
-      <p:sp>
-        <p:nvSpPr>
-          <p:cNvPr id="3" name="Date Placeholder 2"/>
-          <p:cNvSpPr>
-            <a:spLocks noGrp="1"/>
-          </p:cNvSpPr>
-          <p:nvPr>
-            <p:ph type="dt" idx="1"/>
-          </p:nvPr>
-        </p:nvSpPr>
-        <p:spPr>
-          <a:xfrm>
-            <a:off x="3884613" y="0"/>
-            <a:ext cx="2971800" cy="458788"/>
-          </a:xfrm>
-          <a:prstGeom prst="rect">
-            <a:avLst/>
-          </a:prstGeom>
-        </p:spPr>
-        <p:txBody>
-          <a:bodyPr vert="horz" lIns="91440" tIns="45720" rIns="91440" bIns="45720" rtlCol="0"/>
-          <a:lstStyle>
-            <a:lvl1pPr algn="r">
-              <a:defRPr sz="1200"/>
-            </a:lvl1pPr>
-          </a:lstStyle>
-          <a:p>
-            <a:fld id="{5282F153-3F37-0F45-9E97-73ACFA13230C}" type="datetimeFigureOut">
-              <a:rPr lang="en-US"/>
-              <a:t>7/23/19</a:t>
-            </a:fld>
-            <a:endParaRPr lang="en-US"/>
-          </a:p>
-        </p:txBody>
-      </p:sp>
-      <p:sp>
-        <p:nvSpPr>
-          <p:cNvPr id="4" name="Slide Image Placeholder 3"/>
-          <p:cNvSpPr>
-            <a:spLocks noGrp="1" noRot="1" noChangeAspect="1"/>
-          </p:cNvSpPr>
-          <p:nvPr>
-            <p:ph type="sldImg" idx="2"/>
-          </p:nvPr>
-        </p:nvSpPr>
-        <p:spPr>
-          <a:xfrm>
-            <a:off x="685800" y="1143000"/>
-            <a:ext cx="5486400" cy="3086100"/>
-          </a:xfrm>
-          <a:prstGeom prst="rect">
-            <a:avLst/>
-          </a:prstGeom>
-          <a:noFill/>
-          <a:ln w="12700">
-            <a:solidFill>
-              <a:prstClr val="black"/>
-            </a:solidFill>
-          </a:ln>
-        </p:spPr>
-        <p:txBody>
-          <a:bodyPr vert="horz" lIns="91440" tIns="45720" rIns="91440" bIns="45720" rtlCol="0" anchor="ctr"/>
-          <a:lstStyle/>
-          <a:p>
-            <a:endParaRPr lang="en-US"/>
-          </a:p>
-        </p:txBody>
-      </p:sp>
-      <p:sp>
-        <p:nvSpPr>
-          <p:cNvPr id="5" name="Notes Placeholder 4"/>
-          <p:cNvSpPr>
-            <a:spLocks noGrp="1"/>
-          </p:cNvSpPr>
-          <p:nvPr>
-            <p:ph type="body" sz="quarter" idx="3"/>
-          </p:nvPr>
-        </p:nvSpPr>
-        <p:spPr>
-          <a:xfrm>
-            <a:off x="685800" y="4400550"/>
-            <a:ext cx="5486400" cy="3600450"/>
-          </a:xfrm>
-          <a:prstGeom prst="rect">
-            <a:avLst/>
-          </a:prstGeom>
-        </p:spPr>
-        <p:txBody>
-          <a:bodyPr vert="horz" lIns="91440" tIns="45720" rIns="91440" bIns="45720" rtlCol="0"/>
-          <a:lstStyle/>
-          <a:p>
-            <a:pPr lvl="0"/>
-            <a:r>
-              <a:rPr lang="en-US"/>
-              <a:t>Click to edit Master text styles</a:t>
-            </a:r>
-          </a:p>
-          <a:p>
-            <a:pPr lvl="1"/>
-            <a:r>
-              <a:rPr lang="en-US"/>
-              <a:t>Second level</a:t>
-            </a:r>
-          </a:p>
-          <a:p>
-            <a:pPr lvl="2"/>
-            <a:r>
-              <a:rPr lang="en-US"/>
-              <a:t>Third level</a:t>
-            </a:r>
-          </a:p>
-          <a:p>
-            <a:pPr lvl="3"/>
-            <a:r>
-              <a:rPr lang="en-US"/>
-              <a:t>Fourth level</a:t>
-            </a:r>
-          </a:p>
-          <a:p>
-            <a:pPr lvl="4"/>
-            <a:r>
-              <a:rPr lang="en-US"/>
-              <a:t>Fifth level</a:t>
-            </a:r>
-          </a:p>
-        </p:txBody>
-      </p:sp>
-      <p:sp>
-        <p:nvSpPr>
-          <p:cNvPr id="6" name="Footer Placeholder 5"/>
-          <p:cNvSpPr>
-            <a:spLocks noGrp="1"/>
-          </p:cNvSpPr>
-          <p:nvPr>
-            <p:ph type="ftr" sz="quarter" idx="4"/>
-          </p:nvPr>
-        </p:nvSpPr>
-        <p:spPr>
-          <a:xfrm>
-            <a:off x="0" y="8685213"/>
-            <a:ext cx="2971800" cy="458787"/>
-          </a:xfrm>
-          <a:prstGeom prst="rect">
-            <a:avLst/>
-          </a:prstGeom>
-        </p:spPr>
-        <p:txBody>
-          <a:bodyPr vert="horz" lIns="91440" tIns="45720" rIns="91440" bIns="45720" rtlCol="0" anchor="b"/>
-          <a:lstStyle>
-            <a:lvl1pPr algn="l">
-              <a:defRPr sz="1200"/>
-            </a:lvl1pPr>
-          </a:lstStyle>
-          <a:p>
-            <a:endParaRPr lang="en-US"/>
-          </a:p>
-        </p:txBody>
-      </p:sp>
-      <p:sp>
-        <p:nvSpPr>
-          <p:cNvPr id="7" name="Slide Number Placeholder 6"/>
-          <p:cNvSpPr>
-            <a:spLocks noGrp="1"/>
-          </p:cNvSpPr>
-          <p:nvPr>
-            <p:ph type="sldNum" sz="quarter" idx="5"/>
-          </p:nvPr>
-        </p:nvSpPr>
-        <p:spPr>
-          <a:xfrm>
-            <a:off x="3884613" y="8685213"/>
-            <a:ext cx="2971800" cy="458787"/>
-          </a:xfrm>
-          <a:prstGeom prst="rect">
-            <a:avLst/>
-          </a:prstGeom>
-        </p:spPr>
-        <p:txBody>
-          <a:bodyPr vert="horz" lIns="91440" tIns="45720" rIns="91440" bIns="45720" rtlCol="0" anchor="b"/>
-          <a:lstStyle>
-            <a:lvl1pPr algn="r">
-              <a:defRPr sz="1200"/>
-            </a:lvl1pPr>
-          </a:lstStyle>
-          <a:p>
-            <a:fld id="{CE5E9CC1-C706-0F49-92D6-E571CC5EEA8F}" type="slidenum">
-              <a:rPr lang="en-US"/>
-              <a:t>‹#›</a:t>
-            </a:fld>
-            <a:endParaRPr lang="en-US"/>
-          </a:p>
-        </p:txBody>
-      </p:sp>
     </p:spTree>
     <p:extLst>
       <p:ext uri="{BB962C8B-B14F-4D97-AF65-F5344CB8AC3E}">
-        <p14:creationId xmlns:p14="http://schemas.microsoft.com/office/powerpoint/2010/main" val="1024086991"/>
+        <p14:creationId xmlns:p14="http://schemas.microsoft.com/office/powerpoint/2010/main" val="3902028199"/>
       </p:ext>
     </p:extLst>
   </p:cSld>
@@ -512,10 +293,6 @@
           <a:bodyPr/>
           <a:lstStyle/>
           <a:p>
-            <a:r>
-              <a:rPr lang="en-US" dirty="0"/>
-              <a:t/>
-            </a:r>
             <a:endParaRPr lang="en-US" dirty="0"/>
           </a:p>
         </p:txBody>
@@ -600,10 +377,6 @@
           <a:bodyPr/>
           <a:lstStyle/>
           <a:p>
-            <a:r>
-              <a:rPr lang="en-US" dirty="0"/>
-              <a:t/>
-            </a:r>
             <a:endParaRPr lang="en-US" dirty="0"/>
           </a:p>
         </p:txBody>
@@ -689,8 +462,8 @@
           <a:lstStyle/>
           <a:p>
             <a:r>
-              <a:rPr lang="en-US" dirty="0"/>
-              <a:t/>
+              <a:rPr lang="tr-TR" dirty="0"/>
+              <a:t>Bu grafik neye göre oluşuyor</a:t>
             </a:r>
             <a:endParaRPr lang="en-US" dirty="0"/>
           </a:p>
@@ -776,10 +549,103 @@
           <a:bodyPr/>
           <a:lstStyle/>
           <a:p>
-            <a:r>
-              <a:rPr lang="en-US" dirty="0"/>
-              <a:t/>
-            </a:r>
+            <a:pPr marL="0" marR="0" lvl="0" indent="0" algn="l" defTabSz="914400" rtl="0" eaLnBrk="1" fontAlgn="auto" latinLnBrk="0" hangingPunct="1">
+              <a:lnSpc>
+                <a:spcPct val="100000"/>
+              </a:lnSpc>
+              <a:spcBef>
+                <a:spcPts val="0"/>
+              </a:spcBef>
+              <a:spcAft>
+                <a:spcPts val="0"/>
+              </a:spcAft>
+              <a:buClrTx/>
+              <a:buSzTx/>
+              <a:buFontTx/>
+              <a:buNone/>
+              <a:tabLst/>
+              <a:defRPr/>
+            </a:pPr>
+            <a:r>
+              <a:rPr lang="en-US" sz="1200" b="1" dirty="0" err="1">
+                <a:solidFill>
+                  <a:srgbClr val="C0392B"/>
+                </a:solidFill>
+                <a:latin typeface="Calibri" pitchFamily="34" charset="0"/>
+                <a:ea typeface="Calibri" pitchFamily="34" charset="-122"/>
+                <a:cs typeface="Calibri" pitchFamily="34" charset="-120"/>
+              </a:rPr>
+              <a:t>Sınıf</a:t>
+            </a:r>
+            <a:r>
+              <a:rPr lang="en-US" sz="1200" b="1" dirty="0">
+                <a:solidFill>
+                  <a:srgbClr val="C0392B"/>
+                </a:solidFill>
+                <a:latin typeface="Calibri" pitchFamily="34" charset="0"/>
+                <a:ea typeface="Calibri" pitchFamily="34" charset="-122"/>
+                <a:cs typeface="Calibri" pitchFamily="34" charset="-120"/>
+              </a:rPr>
+              <a:t> </a:t>
+            </a:r>
+            <a:r>
+              <a:rPr lang="en-US" sz="1200" b="1" dirty="0" err="1">
+                <a:solidFill>
+                  <a:srgbClr val="C0392B"/>
+                </a:solidFill>
+                <a:latin typeface="Calibri" pitchFamily="34" charset="0"/>
+                <a:ea typeface="Calibri" pitchFamily="34" charset="-122"/>
+                <a:cs typeface="Calibri" pitchFamily="34" charset="-120"/>
+              </a:rPr>
+              <a:t>adı</a:t>
+            </a:r>
+            <a:r>
+              <a:rPr lang="en-US" sz="1200" b="1" dirty="0">
+                <a:solidFill>
+                  <a:srgbClr val="C0392B"/>
+                </a:solidFill>
+                <a:latin typeface="Calibri" pitchFamily="34" charset="0"/>
+                <a:ea typeface="Calibri" pitchFamily="34" charset="-122"/>
+                <a:cs typeface="Calibri" pitchFamily="34" charset="-120"/>
+              </a:rPr>
+              <a:t> </a:t>
+            </a:r>
+            <a:r>
+              <a:rPr lang="en-US" sz="1200" b="1" dirty="0" err="1">
+                <a:solidFill>
+                  <a:srgbClr val="C0392B"/>
+                </a:solidFill>
+                <a:latin typeface="Calibri" pitchFamily="34" charset="0"/>
+                <a:ea typeface="Calibri" pitchFamily="34" charset="-122"/>
+                <a:cs typeface="Calibri" pitchFamily="34" charset="-120"/>
+              </a:rPr>
+              <a:t>halüsinasyonu</a:t>
+            </a:r>
+            <a:r>
+              <a:rPr lang="en-US" sz="1200" b="1" dirty="0">
+                <a:solidFill>
+                  <a:srgbClr val="C0392B"/>
+                </a:solidFill>
+                <a:latin typeface="Calibri" pitchFamily="34" charset="0"/>
+                <a:ea typeface="Calibri" pitchFamily="34" charset="-122"/>
+                <a:cs typeface="Calibri" pitchFamily="34" charset="-120"/>
+              </a:rPr>
+              <a:t>.  </a:t>
+            </a:r>
+            <a:r>
+              <a:rPr lang="tr-TR" sz="1200" dirty="0">
+                <a:solidFill>
+                  <a:srgbClr val="1B2433"/>
+                </a:solidFill>
+                <a:latin typeface="Calibri" pitchFamily="34" charset="0"/>
+                <a:ea typeface="Calibri" pitchFamily="34" charset="-122"/>
+                <a:cs typeface="Calibri" pitchFamily="34" charset="-120"/>
+              </a:rPr>
+              <a:t>Ne demek</a:t>
+            </a:r>
+            <a:endParaRPr lang="en-US" sz="1200" dirty="0"/>
+          </a:p>
+          <a:p>
             <a:endParaRPr lang="en-US" dirty="0"/>
           </a:p>
         </p:txBody>
@@ -864,10 +730,213 @@
           <a:bodyPr/>
           <a:lstStyle/>
           <a:p>
-            <a:r>
-              <a:rPr lang="en-US" dirty="0"/>
-              <a:t/>
-            </a:r>
+            <a:pPr marL="0" marR="0" lvl="0" indent="0" algn="l" defTabSz="914400" rtl="0" eaLnBrk="1" fontAlgn="auto" latinLnBrk="0" hangingPunct="1">
+              <a:lnSpc>
+                <a:spcPct val="100000"/>
+              </a:lnSpc>
+              <a:spcBef>
+                <a:spcPts val="0"/>
+              </a:spcBef>
+              <a:spcAft>
+                <a:spcPts val="0"/>
+              </a:spcAft>
+              <a:buClrTx/>
+              <a:buSzTx/>
+              <a:buFontTx/>
+              <a:buNone/>
+              <a:tabLst/>
+              <a:defRPr/>
+            </a:pPr>
+            <a:r>
+              <a:rPr lang="tr-TR" sz="1200" dirty="0">
+                <a:solidFill>
+                  <a:srgbClr val="CADCFC"/>
+                </a:solidFill>
+                <a:latin typeface="Calibri" pitchFamily="34" charset="0"/>
+                <a:ea typeface="Calibri" pitchFamily="34" charset="-122"/>
+                <a:cs typeface="Calibri" pitchFamily="34" charset="-120"/>
+              </a:rPr>
+              <a:t>«</a:t>
+            </a:r>
+            <a:r>
+              <a:rPr lang="en-US" sz="1200" dirty="0" err="1">
+                <a:solidFill>
+                  <a:srgbClr val="CADCFC"/>
+                </a:solidFill>
+                <a:latin typeface="Calibri" pitchFamily="34" charset="0"/>
+                <a:ea typeface="Calibri" pitchFamily="34" charset="-122"/>
+                <a:cs typeface="Calibri" pitchFamily="34" charset="-120"/>
+              </a:rPr>
+              <a:t>Metrik</a:t>
+            </a:r>
+            <a:r>
+              <a:rPr lang="en-US" sz="1200" dirty="0">
+                <a:solidFill>
+                  <a:srgbClr val="CADCFC"/>
+                </a:solidFill>
+                <a:latin typeface="Calibri" pitchFamily="34" charset="0"/>
+                <a:ea typeface="Calibri" pitchFamily="34" charset="-122"/>
+                <a:cs typeface="Calibri" pitchFamily="34" charset="-120"/>
+              </a:rPr>
+              <a:t> </a:t>
+            </a:r>
+            <a:r>
+              <a:rPr lang="en-US" sz="1200" dirty="0" err="1">
+                <a:solidFill>
+                  <a:srgbClr val="CADCFC"/>
+                </a:solidFill>
+                <a:latin typeface="Calibri" pitchFamily="34" charset="0"/>
+                <a:ea typeface="Calibri" pitchFamily="34" charset="-122"/>
+                <a:cs typeface="Calibri" pitchFamily="34" charset="-120"/>
+              </a:rPr>
+              <a:t>eğilimleri</a:t>
+            </a:r>
+            <a:r>
+              <a:rPr lang="en-US" sz="1200" dirty="0">
+                <a:solidFill>
+                  <a:srgbClr val="CADCFC"/>
+                </a:solidFill>
+                <a:latin typeface="Calibri" pitchFamily="34" charset="0"/>
+                <a:ea typeface="Calibri" pitchFamily="34" charset="-122"/>
+                <a:cs typeface="Calibri" pitchFamily="34" charset="-120"/>
+              </a:rPr>
+              <a:t> </a:t>
+            </a:r>
+            <a:r>
+              <a:rPr lang="en-US" sz="1200" dirty="0" err="1">
+                <a:solidFill>
+                  <a:srgbClr val="CADCFC"/>
+                </a:solidFill>
+                <a:latin typeface="Calibri" pitchFamily="34" charset="0"/>
+                <a:ea typeface="Calibri" pitchFamily="34" charset="-122"/>
+                <a:cs typeface="Calibri" pitchFamily="34" charset="-120"/>
+              </a:rPr>
+              <a:t>ile</a:t>
+            </a:r>
+            <a:r>
+              <a:rPr lang="en-US" sz="1200" dirty="0">
+                <a:solidFill>
+                  <a:srgbClr val="CADCFC"/>
+                </a:solidFill>
+                <a:latin typeface="Calibri" pitchFamily="34" charset="0"/>
+                <a:ea typeface="Calibri" pitchFamily="34" charset="-122"/>
+                <a:cs typeface="Calibri" pitchFamily="34" charset="-120"/>
+              </a:rPr>
+              <a:t> </a:t>
+            </a:r>
+            <a:r>
+              <a:rPr lang="en-US" sz="1200" dirty="0" err="1">
+                <a:solidFill>
+                  <a:srgbClr val="CADCFC"/>
+                </a:solidFill>
+                <a:latin typeface="Calibri" pitchFamily="34" charset="0"/>
+                <a:ea typeface="Calibri" pitchFamily="34" charset="-122"/>
+                <a:cs typeface="Calibri" pitchFamily="34" charset="-120"/>
+              </a:rPr>
+              <a:t>gerçek</a:t>
+            </a:r>
+            <a:r>
+              <a:rPr lang="en-US" sz="1200" dirty="0">
+                <a:solidFill>
+                  <a:srgbClr val="CADCFC"/>
+                </a:solidFill>
+                <a:latin typeface="Calibri" pitchFamily="34" charset="0"/>
+                <a:ea typeface="Calibri" pitchFamily="34" charset="-122"/>
+                <a:cs typeface="Calibri" pitchFamily="34" charset="-120"/>
+              </a:rPr>
+              <a:t> </a:t>
+            </a:r>
+            <a:r>
+              <a:rPr lang="en-US" sz="1200" dirty="0" err="1">
+                <a:solidFill>
+                  <a:srgbClr val="CADCFC"/>
+                </a:solidFill>
+                <a:latin typeface="Calibri" pitchFamily="34" charset="0"/>
+                <a:ea typeface="Calibri" pitchFamily="34" charset="-122"/>
+                <a:cs typeface="Calibri" pitchFamily="34" charset="-120"/>
+              </a:rPr>
+              <a:t>hata</a:t>
+            </a:r>
+            <a:r>
+              <a:rPr lang="en-US" sz="1200" dirty="0">
+                <a:solidFill>
+                  <a:srgbClr val="CADCFC"/>
+                </a:solidFill>
+                <a:latin typeface="Calibri" pitchFamily="34" charset="0"/>
+                <a:ea typeface="Calibri" pitchFamily="34" charset="-122"/>
+                <a:cs typeface="Calibri" pitchFamily="34" charset="-120"/>
+              </a:rPr>
+              <a:t>/commit </a:t>
+            </a:r>
+            <a:r>
+              <a:rPr lang="en-US" sz="1200" dirty="0" err="1">
+                <a:solidFill>
+                  <a:srgbClr val="CADCFC"/>
+                </a:solidFill>
+                <a:latin typeface="Calibri" pitchFamily="34" charset="0"/>
+                <a:ea typeface="Calibri" pitchFamily="34" charset="-122"/>
+                <a:cs typeface="Calibri" pitchFamily="34" charset="-120"/>
+              </a:rPr>
+              <a:t>kayıtları</a:t>
+            </a:r>
+            <a:r>
+              <a:rPr lang="en-US" sz="1200" dirty="0">
+                <a:solidFill>
+                  <a:srgbClr val="CADCFC"/>
+                </a:solidFill>
+                <a:latin typeface="Calibri" pitchFamily="34" charset="0"/>
+                <a:ea typeface="Calibri" pitchFamily="34" charset="-122"/>
+                <a:cs typeface="Calibri" pitchFamily="34" charset="-120"/>
+              </a:rPr>
+              <a:t> </a:t>
+            </a:r>
+            <a:r>
+              <a:rPr lang="en-US" sz="1200" dirty="0" err="1">
+                <a:solidFill>
+                  <a:srgbClr val="CADCFC"/>
+                </a:solidFill>
+                <a:latin typeface="Calibri" pitchFamily="34" charset="0"/>
+                <a:ea typeface="Calibri" pitchFamily="34" charset="-122"/>
+                <a:cs typeface="Calibri" pitchFamily="34" charset="-120"/>
+              </a:rPr>
+              <a:t>arasındaki</a:t>
+            </a:r>
+            <a:r>
+              <a:rPr lang="en-US" sz="1200" dirty="0">
+                <a:solidFill>
+                  <a:srgbClr val="CADCFC"/>
+                </a:solidFill>
+                <a:latin typeface="Calibri" pitchFamily="34" charset="0"/>
+                <a:ea typeface="Calibri" pitchFamily="34" charset="-122"/>
+                <a:cs typeface="Calibri" pitchFamily="34" charset="-120"/>
+              </a:rPr>
+              <a:t> </a:t>
+            </a:r>
+            <a:r>
+              <a:rPr lang="en-US" sz="1200" dirty="0" err="1">
+                <a:solidFill>
+                  <a:srgbClr val="CADCFC"/>
+                </a:solidFill>
+                <a:latin typeface="Calibri" pitchFamily="34" charset="0"/>
+                <a:ea typeface="Calibri" pitchFamily="34" charset="-122"/>
+                <a:cs typeface="Calibri" pitchFamily="34" charset="-120"/>
+              </a:rPr>
+              <a:t>korelasyon</a:t>
+            </a:r>
+            <a:r>
+              <a:rPr lang="tr-TR" sz="1200" dirty="0">
+                <a:solidFill>
+                  <a:srgbClr val="CADCFC"/>
+                </a:solidFill>
+                <a:latin typeface="Calibri" pitchFamily="34" charset="0"/>
+                <a:ea typeface="Calibri" pitchFamily="34" charset="-122"/>
+                <a:cs typeface="Calibri" pitchFamily="34" charset="-120"/>
+              </a:rPr>
+              <a:t>» ne demek</a:t>
+            </a:r>
+            <a:endParaRPr lang="en-US" sz="1200" dirty="0"/>
+          </a:p>
+          <a:p>
             <a:endParaRPr lang="en-US" dirty="0"/>
           </a:p>
         </p:txBody>
@@ -953,8 +1022,147 @@
           <a:lstStyle/>
           <a:p>
             <a:r>
-              <a:rPr lang="en-US" dirty="0"/>
-              <a:t/>
+              <a:rPr lang="en-US" sz="1200" b="1" dirty="0" err="1">
+                <a:solidFill>
+                  <a:srgbClr val="1B2433"/>
+                </a:solidFill>
+                <a:latin typeface="Calibri" pitchFamily="34" charset="0"/>
+                <a:ea typeface="Calibri" pitchFamily="34" charset="-122"/>
+                <a:cs typeface="Calibri" pitchFamily="34" charset="-120"/>
+              </a:rPr>
+              <a:t>Hiçbir</a:t>
+            </a:r>
+            <a:r>
+              <a:rPr lang="en-US" sz="1200" b="1" dirty="0">
+                <a:solidFill>
+                  <a:srgbClr val="1B2433"/>
+                </a:solidFill>
+                <a:latin typeface="Calibri" pitchFamily="34" charset="0"/>
+                <a:ea typeface="Calibri" pitchFamily="34" charset="-122"/>
+                <a:cs typeface="Calibri" pitchFamily="34" charset="-120"/>
+              </a:rPr>
+              <a:t> </a:t>
+            </a:r>
+            <a:r>
+              <a:rPr lang="en-US" sz="1200" b="1" dirty="0" err="1">
+                <a:solidFill>
+                  <a:srgbClr val="1B2433"/>
+                </a:solidFill>
+                <a:latin typeface="Calibri" pitchFamily="34" charset="0"/>
+                <a:ea typeface="Calibri" pitchFamily="34" charset="-122"/>
+                <a:cs typeface="Calibri" pitchFamily="34" charset="-120"/>
+              </a:rPr>
+              <a:t>hazır</a:t>
+            </a:r>
+            <a:r>
+              <a:rPr lang="en-US" sz="1200" b="1" dirty="0">
+                <a:solidFill>
+                  <a:srgbClr val="1B2433"/>
+                </a:solidFill>
+                <a:latin typeface="Calibri" pitchFamily="34" charset="0"/>
+                <a:ea typeface="Calibri" pitchFamily="34" charset="-122"/>
+                <a:cs typeface="Calibri" pitchFamily="34" charset="-120"/>
+              </a:rPr>
+              <a:t> </a:t>
+            </a:r>
+            <a:r>
+              <a:rPr lang="en-US" sz="1200" b="1" dirty="0" err="1">
+                <a:solidFill>
+                  <a:srgbClr val="1B2433"/>
+                </a:solidFill>
+                <a:latin typeface="Calibri" pitchFamily="34" charset="0"/>
+                <a:ea typeface="Calibri" pitchFamily="34" charset="-122"/>
+                <a:cs typeface="Calibri" pitchFamily="34" charset="-120"/>
+              </a:rPr>
+              <a:t>araç</a:t>
+            </a:r>
+            <a:r>
+              <a:rPr lang="en-US" sz="1200" b="1" dirty="0">
+                <a:solidFill>
+                  <a:srgbClr val="1B2433"/>
+                </a:solidFill>
+                <a:latin typeface="Calibri" pitchFamily="34" charset="0"/>
+                <a:ea typeface="Calibri" pitchFamily="34" charset="-122"/>
+                <a:cs typeface="Calibri" pitchFamily="34" charset="-120"/>
+              </a:rPr>
+              <a:t> yok</a:t>
+            </a:r>
+            <a:r>
+              <a:rPr lang="tr-TR" sz="1200" b="1" dirty="0">
+                <a:solidFill>
+                  <a:srgbClr val="1B2433"/>
+                </a:solidFill>
+                <a:latin typeface="Calibri" pitchFamily="34" charset="0"/>
+                <a:ea typeface="Calibri" pitchFamily="34" charset="-122"/>
+                <a:cs typeface="Calibri" pitchFamily="34" charset="-120"/>
+              </a:rPr>
+              <a:t> kısmını beğenmedim, </a:t>
+            </a:r>
+            <a:r>
+              <a:rPr lang="en-US" sz="1200" b="1" dirty="0">
+                <a:solidFill>
+                  <a:srgbClr val="1B2433"/>
+                </a:solidFill>
+                <a:latin typeface="Calibri" pitchFamily="34" charset="0"/>
+                <a:ea typeface="Calibri" pitchFamily="34" charset="-122"/>
+                <a:cs typeface="Calibri" pitchFamily="34" charset="-120"/>
+              </a:rPr>
+              <a:t>Tek/</a:t>
+            </a:r>
+            <a:r>
+              <a:rPr lang="en-US" sz="1200" b="1" dirty="0" err="1">
+                <a:solidFill>
+                  <a:srgbClr val="1B2433"/>
+                </a:solidFill>
+                <a:latin typeface="Calibri" pitchFamily="34" charset="0"/>
+                <a:ea typeface="Calibri" pitchFamily="34" charset="-122"/>
+                <a:cs typeface="Calibri" pitchFamily="34" charset="-120"/>
+              </a:rPr>
+              <a:t>sürekli</a:t>
+            </a:r>
+            <a:r>
+              <a:rPr lang="en-US" sz="1200" b="1" dirty="0">
+                <a:solidFill>
+                  <a:srgbClr val="1B2433"/>
+                </a:solidFill>
+                <a:latin typeface="Calibri" pitchFamily="34" charset="0"/>
+                <a:ea typeface="Calibri" pitchFamily="34" charset="-122"/>
+                <a:cs typeface="Calibri" pitchFamily="34" charset="-120"/>
+              </a:rPr>
+              <a:t> </a:t>
+            </a:r>
+            <a:r>
+              <a:rPr lang="en-US" sz="1200" dirty="0">
+                <a:solidFill>
+                  <a:srgbClr val="1B2433"/>
+                </a:solidFill>
+                <a:latin typeface="Calibri" pitchFamily="34" charset="0"/>
+                <a:ea typeface="Calibri" pitchFamily="34" charset="-122"/>
+                <a:cs typeface="Calibri" pitchFamily="34" charset="-120"/>
+              </a:rPr>
+              <a:t>git </a:t>
+            </a:r>
+            <a:r>
+              <a:rPr lang="en-US" sz="1200" dirty="0" err="1">
+                <a:solidFill>
+                  <a:srgbClr val="1B2433"/>
+                </a:solidFill>
+                <a:latin typeface="Calibri" pitchFamily="34" charset="0"/>
+                <a:ea typeface="Calibri" pitchFamily="34" charset="-122"/>
+                <a:cs typeface="Calibri" pitchFamily="34" charset="-120"/>
+              </a:rPr>
+              <a:t>geçmişi</a:t>
+            </a:r>
+            <a:r>
+              <a:rPr lang="tr-TR" sz="1200">
+                <a:solidFill>
+                  <a:srgbClr val="1B2433"/>
+                </a:solidFill>
+                <a:latin typeface="Calibri" pitchFamily="34" charset="0"/>
+                <a:ea typeface="Calibri" pitchFamily="34" charset="-122"/>
+                <a:cs typeface="Calibri" pitchFamily="34" charset="-120"/>
+              </a:rPr>
+              <a:t> ne demek</a:t>
             </a:r>
             <a:endParaRPr lang="en-US" dirty="0"/>
           </a:p>
@@ -1040,10 +1248,6 @@
           <a:bodyPr/>
           <a:lstStyle/>
           <a:p>
-            <a:r>
-              <a:rPr lang="en-US" dirty="0"/>
-              <a:t/>
-            </a:r>
             <a:endParaRPr lang="en-US" dirty="0"/>
           </a:p>
         </p:txBody>
@@ -1128,10 +1332,6 @@
           <a:bodyPr/>
           <a:lstStyle/>
           <a:p>
-            <a:r>
-              <a:rPr lang="en-US" dirty="0"/>
-              <a:t/>
-            </a:r>
             <a:endParaRPr lang="en-US" dirty="0"/>
           </a:p>
         </p:txBody>
@@ -1216,10 +1416,6 @@
           <a:bodyPr/>
           <a:lstStyle/>
           <a:p>
-            <a:r>
-              <a:rPr lang="en-US" dirty="0"/>
-              <a:t/>
-            </a:r>
             <a:endParaRPr lang="en-US" dirty="0"/>
           </a:p>
         </p:txBody>
@@ -1305,8 +1501,8 @@
           <a:lstStyle/>
           <a:p>
             <a:r>
-              <a:rPr lang="en-US" dirty="0"/>
-              <a:t/>
+              <a:rPr lang="tr-TR" dirty="0"/>
+              <a:t>Aşağı = anlaşılabilirlik düşüyor</a:t>
             </a:r>
             <a:endParaRPr lang="en-US" dirty="0"/>
           </a:p>
@@ -1392,10 +1588,6 @@
           <a:bodyPr/>
           <a:lstStyle/>
           <a:p>
-            <a:r>
-              <a:rPr lang="en-US" dirty="0"/>
-              <a:t/>
-            </a:r>
             <a:endParaRPr lang="en-US" dirty="0"/>
           </a:p>
         </p:txBody>
@@ -1480,10 +1672,6 @@
           <a:bodyPr/>
           <a:lstStyle/>
           <a:p>
-            <a:r>
-              <a:rPr lang="en-US" dirty="0"/>
-              <a:t/>
-            </a:r>
             <a:endParaRPr lang="en-US" dirty="0"/>
           </a:p>
         </p:txBody>
@@ -1569,8 +1757,8 @@
           <a:lstStyle/>
           <a:p>
             <a:r>
-              <a:rPr lang="en-US" dirty="0"/>
-              <a:t/>
+              <a:rPr lang="tr-TR" dirty="0"/>
+              <a:t>Grafik ne anlatıyor</a:t>
             </a:r>
             <a:endParaRPr lang="en-US" dirty="0"/>
           </a:p>
@@ -1645,6 +1833,11 @@
 <file path=ppt/slideMasters/slideMaster1.xml><?xml version="1.0" encoding="utf-8"?>
 <p:sldMaster xmlns:a="http://schemas.openxmlformats.org/drawingml/2006/main" xmlns:r="http://schemas.openxmlformats.org/officeDocument/2006/relationships" xmlns:p="http://schemas.openxmlformats.org/presentationml/2006/main">
   <p:cSld>
+    <p:bg>
+      <p:bgRef idx="1001">
+        <a:schemeClr val="bg1"/>
+      </p:bgRef>
+    </p:bg>
     <p:spTree>
       <p:nvGrpSpPr>
         <p:cNvPr id="1" name=""/>
@@ -1927,6 +2120,7 @@
         <a:solidFill>
           <a:srgbClr val="1E2761"/>
         </a:solidFill>
+        <a:effectLst/>
       </p:bgPr>
     </p:bg>
     <p:spTree>
@@ -1962,6 +2156,13 @@
           </a:solidFill>
           <a:ln/>
         </p:spPr>
+        <p:txBody>
+          <a:bodyPr/>
+          <a:lstStyle/>
+          <a:p>
+            <a:endParaRPr lang="en-US"/>
+          </a:p>
+        </p:txBody>
       </p:sp>
       <p:sp>
         <p:nvSpPr>
@@ -1982,6 +2183,13 @@
           </a:solidFill>
           <a:ln/>
         </p:spPr>
+        <p:txBody>
+          <a:bodyPr/>
+          <a:lstStyle/>
+          <a:p>
+            <a:endParaRPr lang="en-US"/>
+          </a:p>
+        </p:txBody>
       </p:sp>
       <p:sp>
         <p:nvSpPr>
@@ -2004,11 +2212,11 @@
           <a:bodyPr wrap="square" lIns="0" tIns="0" rIns="0" bIns="0" rtlCol="0" anchor="ctr"/>
           <a:lstStyle/>
           <a:p>
-            <a:pPr indent="0" marL="0">
-              <a:buNone/>
-            </a:pPr>
-            <a:r>
-              <a:rPr lang="en-US" sz="1400" b="1" spc="200" kern="0" dirty="0">
+            <a:pPr marL="0" indent="0">
+              <a:buNone/>
+            </a:pPr>
+            <a:r>
+              <a:rPr lang="en-US" sz="1400" b="1" kern="0" spc="200" dirty="0">
                 <a:solidFill>
                   <a:srgbClr val="CADCFC"/>
                 </a:solidFill>
@@ -2043,7 +2251,7 @@
           <a:bodyPr wrap="square" lIns="0" tIns="0" rIns="0" bIns="0" rtlCol="0" anchor="ctr"/>
           <a:lstStyle/>
           <a:p>
-            <a:pPr indent="0" marL="0">
+            <a:pPr marL="0" indent="0">
               <a:lnSpc>
                 <a:spcPct val="105000"/>
               </a:lnSpc>
@@ -2063,7 +2271,7 @@
             <a:endParaRPr lang="en-US" sz="4000" dirty="0"/>
           </a:p>
           <a:p>
-            <a:pPr indent="0" marL="0">
+            <a:pPr marL="0" indent="0">
               <a:lnSpc>
                 <a:spcPct val="105000"/>
               </a:lnSpc>
@@ -2105,7 +2313,7 @@
           <a:bodyPr wrap="square" lIns="0" tIns="0" rIns="0" bIns="0" rtlCol="0" anchor="ctr"/>
           <a:lstStyle/>
           <a:p>
-            <a:pPr indent="0" marL="0">
+            <a:pPr marL="0" indent="0">
               <a:buNone/>
             </a:pPr>
             <a:r>
@@ -2119,9 +2327,6 @@
               </a:rPr>
               <a:t>Analiz edilen sistem:  </a:t>
             </a:r>
-            <a:pPr indent="0" marL="0">
-              <a:buNone/>
-            </a:pPr>
             <a:r>
               <a:rPr lang="en-US" sz="1700" b="1" dirty="0">
                 <a:solidFill>
@@ -2158,7 +2363,7 @@
           <a:bodyPr wrap="square" lIns="0" tIns="0" rIns="0" bIns="0" rtlCol="0" anchor="ctr"/>
           <a:lstStyle/>
           <a:p>
-            <a:pPr indent="0" marL="0">
+            <a:pPr marL="0" indent="0">
               <a:buNone/>
             </a:pPr>
             <a:r>
@@ -2197,7 +2402,7 @@
           <a:bodyPr wrap="square" lIns="0" tIns="0" rIns="0" bIns="0" rtlCol="0" anchor="ctr"/>
           <a:lstStyle/>
           <a:p>
-            <a:pPr indent="0" marL="0">
+            <a:pPr marL="0" indent="0">
               <a:buNone/>
             </a:pPr>
             <a:r>
@@ -2231,6 +2436,7 @@
         <a:solidFill>
           <a:srgbClr val="1E2761"/>
         </a:solidFill>
+        <a:effectLst/>
       </p:bgPr>
     </p:bg>
     <p:spTree>
@@ -2268,11 +2474,11 @@
           <a:bodyPr wrap="square" lIns="0" tIns="0" rIns="0" bIns="0" rtlCol="0" anchor="ctr"/>
           <a:lstStyle/>
           <a:p>
-            <a:pPr indent="0" marL="0">
-              <a:buNone/>
-            </a:pPr>
-            <a:r>
-              <a:rPr lang="en-US" sz="1400" b="1" spc="200" kern="0" dirty="0">
+            <a:pPr marL="0" indent="0">
+              <a:buNone/>
+            </a:pPr>
+            <a:r>
+              <a:rPr lang="en-US" sz="1400" b="1" kern="0" spc="200" dirty="0">
                 <a:solidFill>
                   <a:srgbClr val="CADCFC"/>
                 </a:solidFill>
@@ -2307,7 +2513,7 @@
           <a:bodyPr wrap="square" lIns="0" tIns="0" rIns="0" bIns="0" rtlCol="0" anchor="ctr"/>
           <a:lstStyle/>
           <a:p>
-            <a:pPr indent="0" marL="0">
+            <a:pPr marL="0" indent="0">
               <a:buNone/>
             </a:pPr>
             <a:r>
@@ -2351,6 +2557,13 @@
             <a:prstDash val="solid"/>
           </a:ln>
         </p:spPr>
+        <p:txBody>
+          <a:bodyPr/>
+          <a:lstStyle/>
+          <a:p>
+            <a:endParaRPr lang="en-US"/>
+          </a:p>
+        </p:txBody>
       </p:sp>
       <p:sp>
         <p:nvSpPr>
@@ -2373,7 +2586,7 @@
           <a:bodyPr wrap="square" lIns="0" tIns="0" rIns="0" bIns="0" rtlCol="0" anchor="ctr"/>
           <a:lstStyle/>
           <a:p>
-            <a:pPr indent="0" marL="0">
+            <a:pPr marL="0" indent="0">
               <a:buNone/>
             </a:pPr>
             <a:r>
@@ -2412,7 +2625,7 @@
           <a:bodyPr wrap="square" lIns="0" tIns="0" rIns="0" bIns="0" rtlCol="0" anchor="ctr"/>
           <a:lstStyle/>
           <a:p>
-            <a:pPr indent="0" marL="0">
+            <a:pPr marL="0" indent="0">
               <a:buNone/>
             </a:pPr>
             <a:r>
@@ -2456,6 +2669,13 @@
             <a:prstDash val="solid"/>
           </a:ln>
         </p:spPr>
+        <p:txBody>
+          <a:bodyPr/>
+          <a:lstStyle/>
+          <a:p>
+            <a:endParaRPr lang="en-US"/>
+          </a:p>
+        </p:txBody>
       </p:sp>
       <p:sp>
         <p:nvSpPr>
@@ -2478,7 +2698,7 @@
           <a:bodyPr wrap="square" lIns="0" tIns="0" rIns="0" bIns="0" rtlCol="0" anchor="ctr"/>
           <a:lstStyle/>
           <a:p>
-            <a:pPr indent="0" marL="0">
+            <a:pPr marL="0" indent="0">
               <a:buNone/>
             </a:pPr>
             <a:r>
@@ -2517,7 +2737,7 @@
           <a:bodyPr wrap="square" lIns="0" tIns="0" rIns="0" bIns="0" rtlCol="0" anchor="ctr"/>
           <a:lstStyle/>
           <a:p>
-            <a:pPr indent="0" marL="0">
+            <a:pPr marL="0" indent="0">
               <a:buNone/>
             </a:pPr>
             <a:r>
@@ -2561,6 +2781,13 @@
             <a:prstDash val="solid"/>
           </a:ln>
         </p:spPr>
+        <p:txBody>
+          <a:bodyPr/>
+          <a:lstStyle/>
+          <a:p>
+            <a:endParaRPr lang="en-US"/>
+          </a:p>
+        </p:txBody>
       </p:sp>
       <p:sp>
         <p:nvSpPr>
@@ -2583,7 +2810,7 @@
           <a:bodyPr wrap="square" lIns="0" tIns="0" rIns="0" bIns="0" rtlCol="0" anchor="ctr"/>
           <a:lstStyle/>
           <a:p>
-            <a:pPr indent="0" marL="0">
+            <a:pPr marL="0" indent="0">
               <a:buNone/>
             </a:pPr>
             <a:r>
@@ -2622,7 +2849,7 @@
           <a:bodyPr wrap="square" lIns="0" tIns="0" rIns="0" bIns="0" rtlCol="0" anchor="ctr"/>
           <a:lstStyle/>
           <a:p>
-            <a:pPr indent="0" marL="0">
+            <a:pPr marL="0" indent="0">
               <a:buNone/>
             </a:pPr>
             <a:r>
@@ -2666,6 +2893,13 @@
             <a:prstDash val="solid"/>
           </a:ln>
         </p:spPr>
+        <p:txBody>
+          <a:bodyPr/>
+          <a:lstStyle/>
+          <a:p>
+            <a:endParaRPr lang="en-US"/>
+          </a:p>
+        </p:txBody>
       </p:sp>
       <p:sp>
         <p:nvSpPr>
@@ -2688,7 +2922,7 @@
           <a:bodyPr wrap="square" lIns="0" tIns="0" rIns="0" bIns="0" rtlCol="0" anchor="ctr"/>
           <a:lstStyle/>
           <a:p>
-            <a:pPr indent="0" marL="0">
+            <a:pPr marL="0" indent="0">
               <a:buNone/>
             </a:pPr>
             <a:r>
@@ -2727,7 +2961,7 @@
           <a:bodyPr wrap="square" lIns="0" tIns="0" rIns="0" bIns="0" rtlCol="0" anchor="ctr"/>
           <a:lstStyle/>
           <a:p>
-            <a:pPr indent="0" marL="0">
+            <a:pPr marL="0" indent="0">
               <a:buNone/>
             </a:pPr>
             <a:r>
@@ -2771,6 +3005,13 @@
             <a:prstDash val="solid"/>
           </a:ln>
         </p:spPr>
+        <p:txBody>
+          <a:bodyPr/>
+          <a:lstStyle/>
+          <a:p>
+            <a:endParaRPr lang="en-US"/>
+          </a:p>
+        </p:txBody>
       </p:sp>
       <p:sp>
         <p:nvSpPr>
@@ -2793,7 +3034,7 @@
           <a:bodyPr wrap="square" lIns="0" tIns="0" rIns="0" bIns="0" rtlCol="0" anchor="ctr"/>
           <a:lstStyle/>
           <a:p>
-            <a:pPr indent="0" marL="0">
+            <a:pPr marL="0" indent="0">
               <a:buNone/>
             </a:pPr>
             <a:r>
@@ -2832,7 +3073,7 @@
           <a:bodyPr wrap="square" lIns="0" tIns="0" rIns="0" bIns="0" rtlCol="0" anchor="ctr"/>
           <a:lstStyle/>
           <a:p>
-            <a:pPr indent="0" marL="0">
+            <a:pPr marL="0" indent="0">
               <a:buNone/>
             </a:pPr>
             <a:r>
@@ -2876,6 +3117,13 @@
             <a:prstDash val="solid"/>
           </a:ln>
         </p:spPr>
+        <p:txBody>
+          <a:bodyPr/>
+          <a:lstStyle/>
+          <a:p>
+            <a:endParaRPr lang="en-US"/>
+          </a:p>
+        </p:txBody>
       </p:sp>
       <p:sp>
         <p:nvSpPr>
@@ -2898,7 +3146,7 @@
           <a:bodyPr wrap="square" lIns="0" tIns="0" rIns="0" bIns="0" rtlCol="0" anchor="ctr"/>
           <a:lstStyle/>
           <a:p>
-            <a:pPr indent="0" marL="0">
+            <a:pPr marL="0" indent="0">
               <a:buNone/>
             </a:pPr>
             <a:r>
@@ -2937,7 +3185,7 @@
           <a:bodyPr wrap="square" lIns="0" tIns="0" rIns="0" bIns="0" rtlCol="0" anchor="ctr"/>
           <a:lstStyle/>
           <a:p>
-            <a:pPr indent="0" marL="0">
+            <a:pPr marL="0" indent="0">
               <a:buNone/>
             </a:pPr>
             <a:r>
@@ -2976,7 +3224,7 @@
           <a:bodyPr wrap="square" lIns="0" tIns="0" rIns="0" bIns="0" rtlCol="0" anchor="ctr"/>
           <a:lstStyle/>
           <a:p>
-            <a:pPr indent="0" marL="0">
+            <a:pPr marL="0" indent="0">
               <a:buNone/>
             </a:pPr>
             <a:r>
@@ -3010,6 +3258,7 @@
         <a:solidFill>
           <a:srgbClr val="FFFFFF"/>
         </a:solidFill>
+        <a:effectLst/>
       </p:bgPr>
     </p:bg>
     <p:spTree>
@@ -3047,11 +3296,11 @@
           <a:bodyPr wrap="square" lIns="0" tIns="0" rIns="0" bIns="0" rtlCol="0" anchor="ctr"/>
           <a:lstStyle/>
           <a:p>
-            <a:pPr indent="0" marL="0">
-              <a:buNone/>
-            </a:pPr>
-            <a:r>
-              <a:rPr lang="en-US" sz="1200" b="1" spc="200" kern="0" dirty="0">
+            <a:pPr marL="0" indent="0">
+              <a:buNone/>
+            </a:pPr>
+            <a:r>
+              <a:rPr lang="en-US" sz="1200" b="1" kern="0" spc="200" dirty="0">
                 <a:solidFill>
                   <a:srgbClr val="3D5AAE"/>
                 </a:solidFill>
@@ -3086,7 +3335,7 @@
           <a:bodyPr wrap="square" lIns="0" tIns="0" rIns="0" bIns="0" rtlCol="0" anchor="ctr"/>
           <a:lstStyle/>
           <a:p>
-            <a:pPr indent="0" marL="0">
+            <a:pPr marL="0" indent="0">
               <a:buNone/>
             </a:pPr>
             <a:r>
@@ -3106,14 +3355,14 @@
       </p:sp>
       <p:pic>
         <p:nvPicPr>
-          <p:cNvPr id="4" name="Image 0" descr="C:\yüksek\Yazılım Tasarım ve Mimarisi\proje\figures\fig_llm_ranking.png">    </p:cNvPr>
+          <p:cNvPr id="4" name="Image 0" descr="C:\yüksek\Yazılım Tasarım ve Mimarisi\proje\figures\fig_llm_ranking.png"/>
           <p:cNvPicPr>
             <a:picLocks noChangeAspect="1"/>
           </p:cNvPicPr>
           <p:nvPr/>
         </p:nvPicPr>
         <p:blipFill>
-          <a:blip r:embed="rId1"/>
+          <a:blip r:embed="rId3"/>
           <a:stretch>
             <a:fillRect/>
           </a:stretch>
@@ -3127,7 +3376,7 @@
             <a:avLst/>
           </a:prstGeom>
           <a:effectLst>
-            <a:outerShdw sx="100000" sy="100000" kx="0" ky="0" algn="bl" rotWithShape="0" blurRad="88900" dist="38100" dir="8100000">
+            <a:outerShdw blurRad="88900" dist="38100" dir="8100000" algn="bl" rotWithShape="0">
               <a:srgbClr val="000000">
                 <a:alpha val="18000"/>
               </a:srgbClr>
@@ -3156,7 +3405,7 @@
           <a:bodyPr wrap="square" lIns="0" tIns="0" rIns="0" bIns="0" rtlCol="0" anchor="ctr"/>
           <a:lstStyle/>
           <a:p>
-            <a:pPr indent="0" marL="0">
+            <a:pPr marL="0" indent="0">
               <a:buNone/>
             </a:pPr>
             <a:r>
@@ -3195,7 +3444,7 @@
           <a:bodyPr wrap="square" lIns="0" tIns="0" rIns="0" bIns="0" rtlCol="0" anchor="t"/>
           <a:lstStyle/>
           <a:p>
-            <a:pPr indent="0" marL="0">
+            <a:pPr marL="0" indent="0">
               <a:lnSpc>
                 <a:spcPct val="115000"/>
               </a:lnSpc>
@@ -3237,7 +3486,7 @@
           <a:bodyPr wrap="square" lIns="0" tIns="0" rIns="0" bIns="0" rtlCol="0" anchor="t"/>
           <a:lstStyle/>
           <a:p>
-            <a:pPr indent="0" marL="0">
+            <a:pPr marL="0" indent="0">
               <a:buNone/>
             </a:pPr>
             <a:r>
@@ -3255,7 +3504,7 @@
             <a:endParaRPr lang="en-US" sz="1400" dirty="0"/>
           </a:p>
           <a:p>
-            <a:pPr indent="0" marL="0">
+            <a:pPr marL="0" indent="0">
               <a:buNone/>
             </a:pPr>
             <a:r>
@@ -3289,6 +3538,7 @@
         <a:solidFill>
           <a:srgbClr val="FFFFFF"/>
         </a:solidFill>
+        <a:effectLst/>
       </p:bgPr>
     </p:bg>
     <p:spTree>
@@ -3326,11 +3576,11 @@
           <a:bodyPr wrap="square" lIns="0" tIns="0" rIns="0" bIns="0" rtlCol="0" anchor="ctr"/>
           <a:lstStyle/>
           <a:p>
-            <a:pPr indent="0" marL="0">
-              <a:buNone/>
-            </a:pPr>
-            <a:r>
-              <a:rPr lang="en-US" sz="1200" b="1" spc="200" kern="0" dirty="0">
+            <a:pPr marL="0" indent="0">
+              <a:buNone/>
+            </a:pPr>
+            <a:r>
+              <a:rPr lang="en-US" sz="1200" b="1" kern="0" spc="200" dirty="0">
                 <a:solidFill>
                   <a:srgbClr val="3D5AAE"/>
                 </a:solidFill>
@@ -3365,7 +3615,7 @@
           <a:bodyPr wrap="square" lIns="0" tIns="0" rIns="0" bIns="0" rtlCol="0" anchor="ctr"/>
           <a:lstStyle/>
           <a:p>
-            <a:pPr indent="0" marL="0">
+            <a:pPr marL="0" indent="0">
               <a:buNone/>
             </a:pPr>
             <a:r>
@@ -3402,6 +3652,13 @@
           </a:solidFill>
           <a:ln/>
         </p:spPr>
+        <p:txBody>
+          <a:bodyPr/>
+          <a:lstStyle/>
+          <a:p>
+            <a:endParaRPr lang="en-US"/>
+          </a:p>
+        </p:txBody>
       </p:sp>
       <p:sp>
         <p:nvSpPr>
@@ -3424,7 +3681,7 @@
           <a:bodyPr wrap="square" lIns="0" tIns="0" rIns="0" bIns="0" rtlCol="0" anchor="t"/>
           <a:lstStyle/>
           <a:p>
-            <a:pPr indent="0" marL="0">
+            <a:pPr marL="0" indent="0">
               <a:lnSpc>
                 <a:spcPct val="110000"/>
               </a:lnSpc>
@@ -3441,13 +3698,87 @@
               </a:rPr>
               <a:t>Uzlaşı yüksek.  </a:t>
             </a:r>
-            <a:pPr indent="0" marL="0">
+            <a:r>
+              <a:rPr lang="en-US" sz="1500" dirty="0">
+                <a:solidFill>
+                  <a:srgbClr val="1B2433"/>
+                </a:solidFill>
+                <a:latin typeface="Calibri" pitchFamily="34" charset="0"/>
+                <a:ea typeface="Calibri" pitchFamily="34" charset="-122"/>
+                <a:cs typeface="Calibri" pitchFamily="34" charset="-120"/>
+              </a:rPr>
+              <a:t>16 modelin tamamı 'dış kalite artıyor, iç kalite geriliyor' anlatısında birleşti — bizim analizimizle örtüşüyor.</a:t>
+            </a:r>
+            <a:endParaRPr lang="en-US" sz="1500" dirty="0"/>
+          </a:p>
+        </p:txBody>
+      </p:sp>
+      <p:sp>
+        <p:nvSpPr>
+          <p:cNvPr id="6" name="Shape 4"/>
+          <p:cNvSpPr/>
+          <p:nvPr/>
+        </p:nvSpPr>
+        <p:spPr>
+          <a:xfrm>
+            <a:off x="548640" y="2578608"/>
+            <a:ext cx="201168" cy="201168"/>
+          </a:xfrm>
+          <a:prstGeom prst="ellipse">
+            <a:avLst/>
+          </a:prstGeom>
+          <a:solidFill>
+            <a:srgbClr val="1E8449"/>
+          </a:solidFill>
+          <a:ln/>
+        </p:spPr>
+        <p:txBody>
+          <a:bodyPr/>
+          <a:lstStyle/>
+          <a:p>
+            <a:endParaRPr lang="en-US"/>
+          </a:p>
+        </p:txBody>
+      </p:sp>
+      <p:sp>
+        <p:nvSpPr>
+          <p:cNvPr id="7" name="Text 5"/>
+          <p:cNvSpPr/>
+          <p:nvPr/>
+        </p:nvSpPr>
+        <p:spPr>
+          <a:xfrm>
+            <a:off x="914400" y="2487168"/>
+            <a:ext cx="10698480" cy="868680"/>
+          </a:xfrm>
+          <a:prstGeom prst="rect">
+            <a:avLst/>
+          </a:prstGeom>
+          <a:noFill/>
+          <a:ln/>
+        </p:spPr>
+        <p:txBody>
+          <a:bodyPr wrap="square" lIns="0" tIns="0" rIns="0" bIns="0" rtlCol="0" anchor="t"/>
+          <a:lstStyle/>
+          <a:p>
+            <a:pPr marL="0" indent="0">
               <a:lnSpc>
                 <a:spcPct val="110000"/>
               </a:lnSpc>
               <a:buNone/>
             </a:pPr>
             <a:r>
+              <a:rPr lang="en-US" sz="1500" b="1" dirty="0">
+                <a:solidFill>
+                  <a:srgbClr val="1E8449"/>
+                </a:solidFill>
+                <a:latin typeface="Calibri" pitchFamily="34" charset="0"/>
+                <a:ea typeface="Calibri" pitchFamily="34" charset="-122"/>
+                <a:cs typeface="Calibri" pitchFamily="34" charset="-120"/>
+              </a:rPr>
+              <a:t>Metrik halüsinasyonu YOK.  </a:t>
+            </a:r>
+            <a:r>
               <a:rPr lang="en-US" sz="1500" dirty="0">
                 <a:solidFill>
                   <a:srgbClr val="1B2433"/>
@@ -3456,7 +3787,7 @@
                 <a:ea typeface="Calibri" pitchFamily="34" charset="-122"/>
                 <a:cs typeface="Calibri" pitchFamily="34" charset="-120"/>
               </a:rPr>
-              <a:t>16 modelin tamamı 'dış kalite artıyor, iç kalite geriliyor' anlatısında birleşti — bizim analizimizle örtüşüyor.</a:t>
+              <a:t>Hiçbir model sayısal değer uydurmadı (sayısal-kanıt kuralının başarısı).</a:t>
             </a:r>
             <a:endParaRPr lang="en-US" sz="1500" dirty="0"/>
           </a:p>
@@ -3464,33 +3795,40 @@
       </p:sp>
       <p:sp>
         <p:nvSpPr>
-          <p:cNvPr id="6" name="Shape 4"/>
-          <p:cNvSpPr/>
-          <p:nvPr/>
-        </p:nvSpPr>
-        <p:spPr>
-          <a:xfrm>
-            <a:off x="548640" y="2578608"/>
+          <p:cNvPr id="8" name="Shape 6"/>
+          <p:cNvSpPr/>
+          <p:nvPr/>
+        </p:nvSpPr>
+        <p:spPr>
+          <a:xfrm>
+            <a:off x="548640" y="3511296"/>
             <a:ext cx="201168" cy="201168"/>
           </a:xfrm>
           <a:prstGeom prst="ellipse">
             <a:avLst/>
           </a:prstGeom>
           <a:solidFill>
-            <a:srgbClr val="1E8449"/>
+            <a:srgbClr val="C0392B"/>
           </a:solidFill>
           <a:ln/>
         </p:spPr>
-      </p:sp>
-      <p:sp>
-        <p:nvSpPr>
-          <p:cNvPr id="7" name="Text 5"/>
-          <p:cNvSpPr/>
-          <p:nvPr/>
-        </p:nvSpPr>
-        <p:spPr>
-          <a:xfrm>
-            <a:off x="914400" y="2487168"/>
+        <p:txBody>
+          <a:bodyPr/>
+          <a:lstStyle/>
+          <a:p>
+            <a:endParaRPr lang="en-US"/>
+          </a:p>
+        </p:txBody>
+      </p:sp>
+      <p:sp>
+        <p:nvSpPr>
+          <p:cNvPr id="9" name="Text 7"/>
+          <p:cNvSpPr/>
+          <p:nvPr/>
+        </p:nvSpPr>
+        <p:spPr>
+          <a:xfrm>
+            <a:off x="914400" y="3419856"/>
             <a:ext cx="10698480" cy="868680"/>
           </a:xfrm>
           <a:prstGeom prst="rect">
@@ -3503,7 +3841,7 @@
           <a:bodyPr wrap="square" lIns="0" tIns="0" rIns="0" bIns="0" rtlCol="0" anchor="t"/>
           <a:lstStyle/>
           <a:p>
-            <a:pPr indent="0" marL="0">
+            <a:pPr marL="0" indent="0">
               <a:lnSpc>
                 <a:spcPct val="110000"/>
               </a:lnSpc>
@@ -3512,21 +3850,95 @@
             <a:r>
               <a:rPr lang="en-US" sz="1500" b="1" dirty="0">
                 <a:solidFill>
-                  <a:srgbClr val="1E8449"/>
-                </a:solidFill>
-                <a:latin typeface="Calibri" pitchFamily="34" charset="0"/>
-                <a:ea typeface="Calibri" pitchFamily="34" charset="-122"/>
-                <a:cs typeface="Calibri" pitchFamily="34" charset="-120"/>
-              </a:rPr>
-              <a:t>Metrik halüsinasyonu YOK.  </a:t>
-            </a:r>
-            <a:pPr indent="0" marL="0">
+                  <a:srgbClr val="C0392B"/>
+                </a:solidFill>
+                <a:latin typeface="Calibri" pitchFamily="34" charset="0"/>
+                <a:ea typeface="Calibri" pitchFamily="34" charset="-122"/>
+                <a:cs typeface="Calibri" pitchFamily="34" charset="-120"/>
+              </a:rPr>
+              <a:t>Sınıf adı halüsinasyonu.  </a:t>
+            </a:r>
+            <a:r>
+              <a:rPr lang="en-US" sz="1500" dirty="0">
+                <a:solidFill>
+                  <a:srgbClr val="1B2433"/>
+                </a:solidFill>
+                <a:latin typeface="Calibri" pitchFamily="34" charset="0"/>
+                <a:ea typeface="Calibri" pitchFamily="34" charset="-122"/>
+                <a:cs typeface="Calibri" pitchFamily="34" charset="-120"/>
+              </a:rPr>
+              <a:t>Bazı modeller toplu veriden türetilemeyecek sınıf adlarını (Parser, Element...) refactoring hedefi gösterdi.</a:t>
+            </a:r>
+            <a:endParaRPr lang="en-US" sz="1500" dirty="0"/>
+          </a:p>
+        </p:txBody>
+      </p:sp>
+      <p:sp>
+        <p:nvSpPr>
+          <p:cNvPr id="10" name="Shape 8"/>
+          <p:cNvSpPr/>
+          <p:nvPr/>
+        </p:nvSpPr>
+        <p:spPr>
+          <a:xfrm>
+            <a:off x="548640" y="4443984"/>
+            <a:ext cx="201168" cy="201168"/>
+          </a:xfrm>
+          <a:prstGeom prst="ellipse">
+            <a:avLst/>
+          </a:prstGeom>
+          <a:solidFill>
+            <a:srgbClr val="1E2761"/>
+          </a:solidFill>
+          <a:ln/>
+        </p:spPr>
+        <p:txBody>
+          <a:bodyPr/>
+          <a:lstStyle/>
+          <a:p>
+            <a:endParaRPr lang="en-US"/>
+          </a:p>
+        </p:txBody>
+      </p:sp>
+      <p:sp>
+        <p:nvSpPr>
+          <p:cNvPr id="11" name="Text 9"/>
+          <p:cNvSpPr/>
+          <p:nvPr/>
+        </p:nvSpPr>
+        <p:spPr>
+          <a:xfrm>
+            <a:off x="914400" y="4352544"/>
+            <a:ext cx="10698480" cy="868680"/>
+          </a:xfrm>
+          <a:prstGeom prst="rect">
+            <a:avLst/>
+          </a:prstGeom>
+          <a:noFill/>
+          <a:ln/>
+        </p:spPr>
+        <p:txBody>
+          <a:bodyPr wrap="square" lIns="0" tIns="0" rIns="0" bIns="0" rtlCol="0" anchor="t"/>
+          <a:lstStyle/>
+          <a:p>
+            <a:pPr marL="0" indent="0">
               <a:lnSpc>
                 <a:spcPct val="110000"/>
               </a:lnSpc>
               <a:buNone/>
             </a:pPr>
             <a:r>
+              <a:rPr lang="en-US" sz="1500" b="1" dirty="0">
+                <a:solidFill>
+                  <a:srgbClr val="1E2761"/>
+                </a:solidFill>
+                <a:latin typeface="Calibri" pitchFamily="34" charset="0"/>
+                <a:ea typeface="Calibri" pitchFamily="34" charset="-122"/>
+                <a:cs typeface="Calibri" pitchFamily="34" charset="-120"/>
+              </a:rPr>
+              <a:t>Ayırt edici: DSC-artefakt.  </a:t>
+            </a:r>
+            <a:r>
               <a:rPr lang="en-US" sz="1500" dirty="0">
                 <a:solidFill>
                   <a:srgbClr val="1B2433"/>
@@ -3535,7 +3947,7 @@
                 <a:ea typeface="Calibri" pitchFamily="34" charset="-122"/>
                 <a:cs typeface="Calibri" pitchFamily="34" charset="-120"/>
               </a:rPr>
-              <a:t>Hiçbir model sayısal değer uydurmadı (sayısal-kanıt kuralının başarısı).</a:t>
+              <a:t>En güçlü yanıt, Reusability +%27'nin tamamının boyut kaynaklı olduğunu sayısal ayrıştırdı (kalite bileşeni 1.969→1.958).</a:t>
             </a:r>
             <a:endParaRPr lang="en-US" sz="1500" dirty="0"/>
           </a:p>
@@ -3543,33 +3955,40 @@
       </p:sp>
       <p:sp>
         <p:nvSpPr>
-          <p:cNvPr id="8" name="Shape 6"/>
-          <p:cNvSpPr/>
-          <p:nvPr/>
-        </p:nvSpPr>
-        <p:spPr>
-          <a:xfrm>
-            <a:off x="548640" y="3511296"/>
+          <p:cNvPr id="12" name="Shape 10"/>
+          <p:cNvSpPr/>
+          <p:nvPr/>
+        </p:nvSpPr>
+        <p:spPr>
+          <a:xfrm>
+            <a:off x="548640" y="5376672"/>
             <a:ext cx="201168" cy="201168"/>
           </a:xfrm>
           <a:prstGeom prst="ellipse">
             <a:avLst/>
           </a:prstGeom>
           <a:solidFill>
-            <a:srgbClr val="C0392B"/>
+            <a:srgbClr val="1E2761"/>
           </a:solidFill>
           <a:ln/>
         </p:spPr>
-      </p:sp>
-      <p:sp>
-        <p:nvSpPr>
-          <p:cNvPr id="9" name="Text 7"/>
-          <p:cNvSpPr/>
-          <p:nvPr/>
-        </p:nvSpPr>
-        <p:spPr>
-          <a:xfrm>
-            <a:off x="914400" y="3419856"/>
+        <p:txBody>
+          <a:bodyPr/>
+          <a:lstStyle/>
+          <a:p>
+            <a:endParaRPr lang="en-US"/>
+          </a:p>
+        </p:txBody>
+      </p:sp>
+      <p:sp>
+        <p:nvSpPr>
+          <p:cNvPr id="13" name="Text 11"/>
+          <p:cNvSpPr/>
+          <p:nvPr/>
+        </p:nvSpPr>
+        <p:spPr>
+          <a:xfrm>
+            <a:off x="914400" y="5285232"/>
             <a:ext cx="10698480" cy="868680"/>
           </a:xfrm>
           <a:prstGeom prst="rect">
@@ -3582,7 +4001,7 @@
           <a:bodyPr wrap="square" lIns="0" tIns="0" rIns="0" bIns="0" rtlCol="0" anchor="t"/>
           <a:lstStyle/>
           <a:p>
-            <a:pPr indent="0" marL="0">
+            <a:pPr marL="0" indent="0">
               <a:lnSpc>
                 <a:spcPct val="110000"/>
               </a:lnSpc>
@@ -3591,178 +4010,14 @@
             <a:r>
               <a:rPr lang="en-US" sz="1500" b="1" dirty="0">
                 <a:solidFill>
-                  <a:srgbClr val="C0392B"/>
-                </a:solidFill>
-                <a:latin typeface="Calibri" pitchFamily="34" charset="0"/>
-                <a:ea typeface="Calibri" pitchFamily="34" charset="-122"/>
-                <a:cs typeface="Calibri" pitchFamily="34" charset="-120"/>
-              </a:rPr>
-              <a:t>Sınıf adı halüsinasyonu.  </a:t>
-            </a:r>
-            <a:pPr indent="0" marL="0">
-              <a:lnSpc>
-                <a:spcPct val="110000"/>
-              </a:lnSpc>
-              <a:buNone/>
-            </a:pPr>
-            <a:r>
-              <a:rPr lang="en-US" sz="1500" dirty="0">
-                <a:solidFill>
-                  <a:srgbClr val="1B2433"/>
-                </a:solidFill>
-                <a:latin typeface="Calibri" pitchFamily="34" charset="0"/>
-                <a:ea typeface="Calibri" pitchFamily="34" charset="-122"/>
-                <a:cs typeface="Calibri" pitchFamily="34" charset="-120"/>
-              </a:rPr>
-              <a:t>Bazı modeller toplu veriden türetilemeyecek sınıf adlarını (Parser, Element...) refactoring hedefi gösterdi.</a:t>
-            </a:r>
-            <a:endParaRPr lang="en-US" sz="1500" dirty="0"/>
-          </a:p>
-        </p:txBody>
-      </p:sp>
-      <p:sp>
-        <p:nvSpPr>
-          <p:cNvPr id="10" name="Shape 8"/>
-          <p:cNvSpPr/>
-          <p:nvPr/>
-        </p:nvSpPr>
-        <p:spPr>
-          <a:xfrm>
-            <a:off x="548640" y="4443984"/>
-            <a:ext cx="201168" cy="201168"/>
-          </a:xfrm>
-          <a:prstGeom prst="ellipse">
-            <a:avLst/>
-          </a:prstGeom>
-          <a:solidFill>
-            <a:srgbClr val="1E2761"/>
-          </a:solidFill>
-          <a:ln/>
-        </p:spPr>
-      </p:sp>
-      <p:sp>
-        <p:nvSpPr>
-          <p:cNvPr id="11" name="Text 9"/>
-          <p:cNvSpPr/>
-          <p:nvPr/>
-        </p:nvSpPr>
-        <p:spPr>
-          <a:xfrm>
-            <a:off x="914400" y="4352544"/>
-            <a:ext cx="10698480" cy="868680"/>
-          </a:xfrm>
-          <a:prstGeom prst="rect">
-            <a:avLst/>
-          </a:prstGeom>
-          <a:noFill/>
-          <a:ln/>
-        </p:spPr>
-        <p:txBody>
-          <a:bodyPr wrap="square" lIns="0" tIns="0" rIns="0" bIns="0" rtlCol="0" anchor="t"/>
-          <a:lstStyle/>
-          <a:p>
-            <a:pPr indent="0" marL="0">
-              <a:lnSpc>
-                <a:spcPct val="110000"/>
-              </a:lnSpc>
-              <a:buNone/>
-            </a:pPr>
-            <a:r>
-              <a:rPr lang="en-US" sz="1500" b="1" dirty="0">
-                <a:solidFill>
                   <a:srgbClr val="1E2761"/>
                 </a:solidFill>
                 <a:latin typeface="Calibri" pitchFamily="34" charset="0"/>
                 <a:ea typeface="Calibri" pitchFamily="34" charset="-122"/>
                 <a:cs typeface="Calibri" pitchFamily="34" charset="-120"/>
               </a:rPr>
-              <a:t>Ayırt edici: DSC-artefakt.  </a:t>
-            </a:r>
-            <a:pPr indent="0" marL="0">
-              <a:lnSpc>
-                <a:spcPct val="110000"/>
-              </a:lnSpc>
-              <a:buNone/>
-            </a:pPr>
-            <a:r>
-              <a:rPr lang="en-US" sz="1500" dirty="0">
-                <a:solidFill>
-                  <a:srgbClr val="1B2433"/>
-                </a:solidFill>
-                <a:latin typeface="Calibri" pitchFamily="34" charset="0"/>
-                <a:ea typeface="Calibri" pitchFamily="34" charset="-122"/>
-                <a:cs typeface="Calibri" pitchFamily="34" charset="-120"/>
-              </a:rPr>
-              <a:t>En güçlü yanıt, Reusability +%27'nin tamamının boyut kaynaklı olduğunu sayısal ayrıştırdı (kalite bileşeni 1.969→1.958).</a:t>
-            </a:r>
-            <a:endParaRPr lang="en-US" sz="1500" dirty="0"/>
-          </a:p>
-        </p:txBody>
-      </p:sp>
-      <p:sp>
-        <p:nvSpPr>
-          <p:cNvPr id="12" name="Shape 10"/>
-          <p:cNvSpPr/>
-          <p:nvPr/>
-        </p:nvSpPr>
-        <p:spPr>
-          <a:xfrm>
-            <a:off x="548640" y="5376672"/>
-            <a:ext cx="201168" cy="201168"/>
-          </a:xfrm>
-          <a:prstGeom prst="ellipse">
-            <a:avLst/>
-          </a:prstGeom>
-          <a:solidFill>
-            <a:srgbClr val="1E2761"/>
-          </a:solidFill>
-          <a:ln/>
-        </p:spPr>
-      </p:sp>
-      <p:sp>
-        <p:nvSpPr>
-          <p:cNvPr id="13" name="Text 11"/>
-          <p:cNvSpPr/>
-          <p:nvPr/>
-        </p:nvSpPr>
-        <p:spPr>
-          <a:xfrm>
-            <a:off x="914400" y="5285232"/>
-            <a:ext cx="10698480" cy="868680"/>
-          </a:xfrm>
-          <a:prstGeom prst="rect">
-            <a:avLst/>
-          </a:prstGeom>
-          <a:noFill/>
-          <a:ln/>
-        </p:spPr>
-        <p:txBody>
-          <a:bodyPr wrap="square" lIns="0" tIns="0" rIns="0" bIns="0" rtlCol="0" anchor="t"/>
-          <a:lstStyle/>
-          <a:p>
-            <a:pPr indent="0" marL="0">
-              <a:lnSpc>
-                <a:spcPct val="110000"/>
-              </a:lnSpc>
-              <a:buNone/>
-            </a:pPr>
-            <a:r>
-              <a:rPr lang="en-US" sz="1500" b="1" dirty="0">
-                <a:solidFill>
-                  <a:srgbClr val="1E2761"/>
-                </a:solidFill>
-                <a:latin typeface="Calibri" pitchFamily="34" charset="0"/>
-                <a:ea typeface="Calibri" pitchFamily="34" charset="-122"/>
-                <a:cs typeface="Calibri" pitchFamily="34" charset="-120"/>
-              </a:rPr>
               <a:t>Belirleyici: çalıştırma modu.  </a:t>
             </a:r>
-            <a:pPr indent="0" marL="0">
-              <a:lnSpc>
-                <a:spcPct val="110000"/>
-              </a:lnSpc>
-              <a:buNone/>
-            </a:pPr>
             <a:r>
               <a:rPr lang="en-US" sz="1500" dirty="0">
                 <a:solidFill>
@@ -3794,6 +4049,7 @@
         <a:solidFill>
           <a:srgbClr val="1E2761"/>
         </a:solidFill>
+        <a:effectLst/>
       </p:bgPr>
     </p:bg>
     <p:spTree>
@@ -3829,6 +4085,13 @@
           </a:solidFill>
           <a:ln/>
         </p:spPr>
+        <p:txBody>
+          <a:bodyPr/>
+          <a:lstStyle/>
+          <a:p>
+            <a:endParaRPr lang="en-US"/>
+          </a:p>
+        </p:txBody>
       </p:sp>
       <p:sp>
         <p:nvSpPr>
@@ -3851,11 +4114,11 @@
           <a:bodyPr wrap="square" lIns="0" tIns="0" rIns="0" bIns="0" rtlCol="0" anchor="ctr"/>
           <a:lstStyle/>
           <a:p>
-            <a:pPr indent="0" marL="0">
-              <a:buNone/>
-            </a:pPr>
-            <a:r>
-              <a:rPr lang="en-US" sz="1400" b="1" spc="200" kern="0" dirty="0">
+            <a:pPr marL="0" indent="0">
+              <a:buNone/>
+            </a:pPr>
+            <a:r>
+              <a:rPr lang="en-US" sz="1400" b="1" kern="0" spc="200" dirty="0">
                 <a:solidFill>
                   <a:srgbClr val="CADCFC"/>
                 </a:solidFill>
@@ -3890,7 +4153,7 @@
           <a:bodyPr wrap="square" lIns="0" tIns="0" rIns="0" bIns="0" rtlCol="0" anchor="ctr"/>
           <a:lstStyle/>
           <a:p>
-            <a:pPr indent="0" marL="0">
+            <a:pPr marL="0" indent="0">
               <a:buNone/>
             </a:pPr>
             <a:r>
@@ -3929,7 +4192,7 @@
           <a:bodyPr wrap="square" lIns="0" tIns="0" rIns="0" bIns="0" rtlCol="0" anchor="t"/>
           <a:lstStyle/>
           <a:p>
-            <a:pPr indent="0" marL="0">
+            <a:pPr marL="0" indent="0">
               <a:lnSpc>
                 <a:spcPct val="118000"/>
               </a:lnSpc>
@@ -3952,7 +4215,7 @@
             <a:endParaRPr lang="en-US" sz="1650" dirty="0"/>
           </a:p>
           <a:p>
-            <a:pPr indent="0" marL="0">
+            <a:pPr marL="0" indent="0">
               <a:lnSpc>
                 <a:spcPct val="118000"/>
               </a:lnSpc>
@@ -3994,7 +4257,7 @@
           <a:bodyPr wrap="square" lIns="0" tIns="0" rIns="0" bIns="0" rtlCol="0" anchor="ctr"/>
           <a:lstStyle/>
           <a:p>
-            <a:pPr indent="0" marL="0">
+            <a:pPr marL="0" indent="0">
               <a:buNone/>
             </a:pPr>
             <a:r>
@@ -4104,6 +4367,7 @@
         <a:solidFill>
           <a:srgbClr val="FFFFFF"/>
         </a:solidFill>
+        <a:effectLst/>
       </p:bgPr>
     </p:bg>
     <p:spTree>
@@ -4141,11 +4405,11 @@
           <a:bodyPr wrap="square" lIns="0" tIns="0" rIns="0" bIns="0" rtlCol="0" anchor="ctr"/>
           <a:lstStyle/>
           <a:p>
-            <a:pPr indent="0" marL="0">
-              <a:buNone/>
-            </a:pPr>
-            <a:r>
-              <a:rPr lang="en-US" sz="1200" b="1" spc="200" kern="0" dirty="0">
+            <a:pPr marL="0" indent="0">
+              <a:buNone/>
+            </a:pPr>
+            <a:r>
+              <a:rPr lang="en-US" sz="1200" b="1" kern="0" spc="200" dirty="0">
                 <a:solidFill>
                   <a:srgbClr val="3D5AAE"/>
                 </a:solidFill>
@@ -4180,7 +4444,7 @@
           <a:bodyPr wrap="square" lIns="0" tIns="0" rIns="0" bIns="0" rtlCol="0" anchor="ctr"/>
           <a:lstStyle/>
           <a:p>
-            <a:pPr indent="0" marL="0">
+            <a:pPr marL="0" indent="0">
               <a:buNone/>
             </a:pPr>
             <a:r>
@@ -4217,6 +4481,13 @@
           </a:solidFill>
           <a:ln/>
         </p:spPr>
+        <p:txBody>
+          <a:bodyPr/>
+          <a:lstStyle/>
+          <a:p>
+            <a:endParaRPr lang="en-US"/>
+          </a:p>
+        </p:txBody>
       </p:sp>
       <p:sp>
         <p:nvSpPr>
@@ -4239,7 +4510,7 @@
           <a:bodyPr wrap="square" lIns="0" tIns="0" rIns="0" bIns="0" rtlCol="0" anchor="ctr"/>
           <a:lstStyle/>
           <a:p>
-            <a:pPr indent="0" marL="0">
+            <a:pPr marL="0" indent="0">
               <a:buNone/>
             </a:pPr>
             <a:r>
@@ -4278,7 +4549,7 @@
           <a:bodyPr wrap="square" lIns="0" tIns="0" rIns="0" bIns="0" rtlCol="0" anchor="ctr"/>
           <a:lstStyle/>
           <a:p>
-            <a:pPr indent="0" marL="0">
+            <a:pPr marL="0" indent="0">
               <a:buNone/>
             </a:pPr>
             <a:r>
@@ -4315,6 +4586,13 @@
           </a:solidFill>
           <a:ln/>
         </p:spPr>
+        <p:txBody>
+          <a:bodyPr/>
+          <a:lstStyle/>
+          <a:p>
+            <a:endParaRPr lang="en-US"/>
+          </a:p>
+        </p:txBody>
       </p:sp>
       <p:sp>
         <p:nvSpPr>
@@ -4337,7 +4615,7 @@
           <a:bodyPr wrap="square" lIns="0" tIns="0" rIns="0" bIns="0" rtlCol="0" anchor="ctr"/>
           <a:lstStyle/>
           <a:p>
-            <a:pPr indent="0" marL="0">
+            <a:pPr marL="0" indent="0">
               <a:buNone/>
             </a:pPr>
             <a:r>
@@ -4376,9 +4654,20 @@
           <a:bodyPr wrap="square" lIns="0" tIns="0" rIns="0" bIns="0" rtlCol="0" anchor="ctr"/>
           <a:lstStyle/>
           <a:p>
-            <a:pPr indent="0" marL="0">
-              <a:buNone/>
-            </a:pPr>
+            <a:pPr marL="0" indent="0">
+              <a:buNone/>
+            </a:pPr>
+            <a:r>
+              <a:rPr lang="en-US" sz="1550" b="1" dirty="0">
+                <a:solidFill>
+                  <a:srgbClr val="1B2433"/>
+                </a:solidFill>
+                <a:latin typeface="Calibri" pitchFamily="34" charset="0"/>
+                <a:ea typeface="Calibri" pitchFamily="34" charset="-122"/>
+                <a:cs typeface="Calibri" pitchFamily="34" charset="-120"/>
+              </a:rPr>
+              <a:t>Tek/sürekli </a:t>
+            </a:r>
             <a:r>
               <a:rPr lang="en-US" sz="1550" dirty="0">
                 <a:solidFill>
@@ -4388,7 +4677,7 @@
                 <a:ea typeface="Calibri" pitchFamily="34" charset="-122"/>
                 <a:cs typeface="Calibri" pitchFamily="34" charset="-120"/>
               </a:rPr>
-              <a:t>Tek/sürekli git geçmişi, zengin kalıtım-polimorfizm (Node→Element...), yönetilebilir boyut (~250 sınıf), düzenli sürüm yayını.</a:t>
+              <a:t>git geçmişi, zengin kalıtım-polimorfizm (Node→Element...), yönetilebilir boyut (~250 sınıf), düzenli sürüm yayını.</a:t>
             </a:r>
             <a:endParaRPr lang="en-US" sz="1550" dirty="0"/>
           </a:p>
@@ -4413,6 +4702,13 @@
           </a:solidFill>
           <a:ln/>
         </p:spPr>
+        <p:txBody>
+          <a:bodyPr/>
+          <a:lstStyle/>
+          <a:p>
+            <a:endParaRPr lang="en-US"/>
+          </a:p>
+        </p:txBody>
       </p:sp>
       <p:sp>
         <p:nvSpPr>
@@ -4435,7 +4731,7 @@
           <a:bodyPr wrap="square" lIns="0" tIns="0" rIns="0" bIns="0" rtlCol="0" anchor="ctr"/>
           <a:lstStyle/>
           <a:p>
-            <a:pPr indent="0" marL="0">
+            <a:pPr marL="0" indent="0">
               <a:buNone/>
             </a:pPr>
             <a:r>
@@ -4474,9 +4770,20 @@
           <a:bodyPr wrap="square" lIns="0" tIns="0" rIns="0" bIns="0" rtlCol="0" anchor="ctr"/>
           <a:lstStyle/>
           <a:p>
-            <a:pPr indent="0" marL="0">
-              <a:buNone/>
-            </a:pPr>
+            <a:pPr marL="0" indent="0">
+              <a:buNone/>
+            </a:pPr>
+            <a:r>
+              <a:rPr lang="en-US" sz="1550" b="1" dirty="0">
+                <a:solidFill>
+                  <a:srgbClr val="1B2433"/>
+                </a:solidFill>
+                <a:latin typeface="Calibri" pitchFamily="34" charset="0"/>
+                <a:ea typeface="Calibri" pitchFamily="34" charset="-122"/>
+                <a:cs typeface="Calibri" pitchFamily="34" charset="-120"/>
+              </a:rPr>
+              <a:t>Hiçbir hazır araç yok: </a:t>
+            </a:r>
             <a:r>
               <a:rPr lang="en-US" sz="1550" dirty="0">
                 <a:solidFill>
@@ -4486,7 +4793,40 @@
                 <a:ea typeface="Calibri" pitchFamily="34" charset="-122"/>
                 <a:cs typeface="Calibri" pitchFamily="34" charset="-120"/>
               </a:rPr>
-              <a:t>Hiçbir hazır araç yok: metrikler javalang ile kendi çözümleyicimizle çıkarıldı (yönerge: hazır sonuç kullanımı yasak).</a:t>
+              <a:t>metrikler javalang ile kendi </a:t>
+            </a:r>
+            <a:r>
+              <a:rPr lang="en-US" sz="1550" dirty="0" err="1">
+                <a:solidFill>
+                  <a:srgbClr val="1B2433"/>
+                </a:solidFill>
+                <a:latin typeface="Calibri" pitchFamily="34" charset="0"/>
+                <a:ea typeface="Calibri" pitchFamily="34" charset="-122"/>
+                <a:cs typeface="Calibri" pitchFamily="34" charset="-120"/>
+              </a:rPr>
+              <a:t>çözümleyicimizle</a:t>
+            </a:r>
+            <a:r>
+              <a:rPr lang="en-US" sz="1550" dirty="0">
+                <a:solidFill>
+                  <a:srgbClr val="1B2433"/>
+                </a:solidFill>
+                <a:latin typeface="Calibri" pitchFamily="34" charset="0"/>
+                <a:ea typeface="Calibri" pitchFamily="34" charset="-122"/>
+                <a:cs typeface="Calibri" pitchFamily="34" charset="-120"/>
+              </a:rPr>
+              <a:t> </a:t>
+            </a:r>
+            <a:r>
+              <a:rPr lang="en-US" sz="1550" dirty="0" err="1">
+                <a:solidFill>
+                  <a:srgbClr val="1B2433"/>
+                </a:solidFill>
+                <a:latin typeface="Calibri" pitchFamily="34" charset="0"/>
+                <a:ea typeface="Calibri" pitchFamily="34" charset="-122"/>
+                <a:cs typeface="Calibri" pitchFamily="34" charset="-120"/>
+              </a:rPr>
+              <a:t>çıkarıldı</a:t>
             </a:r>
             <a:endParaRPr lang="en-US" sz="1550" dirty="0"/>
           </a:p>
@@ -4508,6 +4848,7 @@
         <a:solidFill>
           <a:srgbClr val="FFFFFF"/>
         </a:solidFill>
+        <a:effectLst/>
       </p:bgPr>
     </p:bg>
     <p:spTree>
@@ -4545,11 +4886,11 @@
           <a:bodyPr wrap="square" lIns="0" tIns="0" rIns="0" bIns="0" rtlCol="0" anchor="ctr"/>
           <a:lstStyle/>
           <a:p>
-            <a:pPr indent="0" marL="0">
-              <a:buNone/>
-            </a:pPr>
-            <a:r>
-              <a:rPr lang="en-US" sz="1200" b="1" spc="200" kern="0" dirty="0">
+            <a:pPr marL="0" indent="0">
+              <a:buNone/>
+            </a:pPr>
+            <a:r>
+              <a:rPr lang="en-US" sz="1200" b="1" kern="0" spc="200" dirty="0">
                 <a:solidFill>
                   <a:srgbClr val="3D5AAE"/>
                 </a:solidFill>
@@ -4584,7 +4925,7 @@
           <a:bodyPr wrap="square" lIns="0" tIns="0" rIns="0" bIns="0" rtlCol="0" anchor="ctr"/>
           <a:lstStyle/>
           <a:p>
-            <a:pPr indent="0" marL="0">
+            <a:pPr marL="0" indent="0">
               <a:buNone/>
             </a:pPr>
             <a:r>
@@ -4623,7 +4964,7 @@
           <a:bodyPr wrap="square" lIns="0" tIns="0" rIns="0" bIns="0" rtlCol="0" anchor="t"/>
           <a:lstStyle/>
           <a:p>
-            <a:pPr indent="0" marL="0">
+            <a:pPr marL="0" indent="0">
               <a:lnSpc>
                 <a:spcPct val="115000"/>
               </a:lnSpc>
@@ -4644,7 +4985,7 @@
             <a:endParaRPr lang="en-US" sz="1600" dirty="0"/>
           </a:p>
           <a:p>
-            <a:pPr indent="0" marL="0">
+            <a:pPr marL="0" indent="0">
               <a:lnSpc>
                 <a:spcPct val="115000"/>
               </a:lnSpc>
@@ -4686,7 +5027,7 @@
           <a:bodyPr wrap="square" lIns="0" tIns="0" rIns="0" bIns="0" rtlCol="0" anchor="t"/>
           <a:lstStyle/>
           <a:p>
-            <a:pPr indent="0" marL="0">
+            <a:pPr marL="0" indent="0">
               <a:lnSpc>
                 <a:spcPct val="115000"/>
               </a:lnSpc>
@@ -4707,7 +5048,7 @@
             <a:endParaRPr lang="en-US" sz="1600" dirty="0"/>
           </a:p>
           <a:p>
-            <a:pPr indent="0" marL="0">
+            <a:pPr marL="0" indent="0">
               <a:lnSpc>
                 <a:spcPct val="115000"/>
               </a:lnSpc>
@@ -4754,6 +5095,13 @@
             <a:prstDash val="solid"/>
           </a:ln>
         </p:spPr>
+        <p:txBody>
+          <a:bodyPr/>
+          <a:lstStyle/>
+          <a:p>
+            <a:endParaRPr lang="en-US"/>
+          </a:p>
+        </p:txBody>
       </p:sp>
       <p:sp>
         <p:nvSpPr>
@@ -4776,7 +5124,7 @@
           <a:bodyPr wrap="square" lIns="0" tIns="0" rIns="0" bIns="0" rtlCol="0" anchor="ctr"/>
           <a:lstStyle/>
           <a:p>
-            <a:pPr indent="0" marL="0">
+            <a:pPr marL="0" indent="0">
               <a:buNone/>
             </a:pPr>
             <a:r>
@@ -4815,7 +5163,7 @@
           <a:bodyPr wrap="square" lIns="0" tIns="0" rIns="0" bIns="0" rtlCol="0" anchor="ctr"/>
           <a:lstStyle/>
           <a:p>
-            <a:pPr indent="0" marL="0">
+            <a:pPr marL="0" indent="0">
               <a:spcAft>
                 <a:spcPts val="800"/>
               </a:spcAft>
@@ -4835,7 +5183,7 @@
             <a:endParaRPr lang="en-US" sz="1100" dirty="0"/>
           </a:p>
           <a:p>
-            <a:pPr indent="0" marL="0">
+            <a:pPr marL="0" indent="0">
               <a:spcAft>
                 <a:spcPts val="800"/>
               </a:spcAft>
@@ -4855,7 +5203,7 @@
             <a:endParaRPr lang="en-US" sz="1100" dirty="0"/>
           </a:p>
           <a:p>
-            <a:pPr indent="0" marL="0">
+            <a:pPr marL="0" indent="0">
               <a:spcAft>
                 <a:spcPts val="800"/>
               </a:spcAft>
@@ -4875,7 +5223,7 @@
             <a:endParaRPr lang="en-US" sz="1100" dirty="0"/>
           </a:p>
           <a:p>
-            <a:pPr indent="0" marL="0">
+            <a:pPr marL="0" indent="0">
               <a:spcAft>
                 <a:spcPts val="800"/>
               </a:spcAft>
@@ -4895,7 +5243,7 @@
             <a:endParaRPr lang="en-US" sz="1100" dirty="0"/>
           </a:p>
           <a:p>
-            <a:pPr indent="0" marL="0">
+            <a:pPr marL="0" indent="0">
               <a:spcAft>
                 <a:spcPts val="800"/>
               </a:spcAft>
@@ -4915,7 +5263,7 @@
             <a:endParaRPr lang="en-US" sz="1100" dirty="0"/>
           </a:p>
           <a:p>
-            <a:pPr indent="0" marL="0">
+            <a:pPr marL="0" indent="0">
               <a:spcAft>
                 <a:spcPts val="800"/>
               </a:spcAft>
@@ -4952,6 +5300,7 @@
         <a:solidFill>
           <a:srgbClr val="FFFFFF"/>
         </a:solidFill>
+        <a:effectLst/>
       </p:bgPr>
     </p:bg>
     <p:spTree>
@@ -4989,11 +5338,11 @@
           <a:bodyPr wrap="square" lIns="0" tIns="0" rIns="0" bIns="0" rtlCol="0" anchor="ctr"/>
           <a:lstStyle/>
           <a:p>
-            <a:pPr indent="0" marL="0">
-              <a:buNone/>
-            </a:pPr>
-            <a:r>
-              <a:rPr lang="en-US" sz="1200" b="1" spc="200" kern="0" dirty="0">
+            <a:pPr marL="0" indent="0">
+              <a:buNone/>
+            </a:pPr>
+            <a:r>
+              <a:rPr lang="en-US" sz="1200" b="1" kern="0" spc="200" dirty="0">
                 <a:solidFill>
                   <a:srgbClr val="3D5AAE"/>
                 </a:solidFill>
@@ -5028,7 +5377,7 @@
           <a:bodyPr wrap="square" lIns="0" tIns="0" rIns="0" bIns="0" rtlCol="0" anchor="ctr"/>
           <a:lstStyle/>
           <a:p>
-            <a:pPr indent="0" marL="0">
+            <a:pPr marL="0" indent="0">
               <a:buNone/>
             </a:pPr>
             <a:r>
@@ -5040,7 +5389,40 @@
                 <a:ea typeface="Georgia" pitchFamily="34" charset="-122"/>
                 <a:cs typeface="Georgia" pitchFamily="34" charset="-120"/>
               </a:rPr>
-              <a:t>Metrik Çıkarım Pipeline'ı (kendi geliştirdiğimiz)</a:t>
+              <a:t>Metrik </a:t>
+            </a:r>
+            <a:r>
+              <a:rPr lang="en-US" sz="3000" b="1" dirty="0" err="1">
+                <a:solidFill>
+                  <a:srgbClr val="1E2761"/>
+                </a:solidFill>
+                <a:latin typeface="Georgia" pitchFamily="34" charset="0"/>
+                <a:ea typeface="Georgia" pitchFamily="34" charset="-122"/>
+                <a:cs typeface="Georgia" pitchFamily="34" charset="-120"/>
+              </a:rPr>
+              <a:t>Çıkarım</a:t>
+            </a:r>
+            <a:r>
+              <a:rPr lang="en-US" sz="3000" b="1" dirty="0">
+                <a:solidFill>
+                  <a:srgbClr val="1E2761"/>
+                </a:solidFill>
+                <a:latin typeface="Georgia" pitchFamily="34" charset="0"/>
+                <a:ea typeface="Georgia" pitchFamily="34" charset="-122"/>
+                <a:cs typeface="Georgia" pitchFamily="34" charset="-120"/>
+              </a:rPr>
+              <a:t> </a:t>
+            </a:r>
+            <a:r>
+              <a:rPr lang="tr-TR" sz="3000" b="1" dirty="0">
+                <a:solidFill>
+                  <a:srgbClr val="1E2761"/>
+                </a:solidFill>
+                <a:latin typeface="Georgia" pitchFamily="34" charset="0"/>
+                <a:ea typeface="Georgia" pitchFamily="34" charset="-122"/>
+                <a:cs typeface="Georgia" pitchFamily="34" charset="-120"/>
+              </a:rPr>
+              <a:t>Akışı</a:t>
             </a:r>
             <a:endParaRPr lang="en-US" sz="3000" dirty="0"/>
           </a:p>
@@ -5072,13 +5454,20 @@
             <a:prstDash val="solid"/>
           </a:ln>
           <a:effectLst>
-            <a:outerShdw sx="100000" sy="100000" kx="0" ky="0" algn="bl" rotWithShape="0" blurRad="88900" dist="38100" dir="8100000">
+            <a:outerShdw blurRad="88900" dist="38100" dir="8100000" algn="bl" rotWithShape="0">
               <a:srgbClr val="000000">
                 <a:alpha val="18000"/>
               </a:srgbClr>
             </a:outerShdw>
           </a:effectLst>
         </p:spPr>
+        <p:txBody>
+          <a:bodyPr/>
+          <a:lstStyle/>
+          <a:p>
+            <a:endParaRPr lang="en-US"/>
+          </a:p>
+        </p:txBody>
       </p:sp>
       <p:sp>
         <p:nvSpPr>
@@ -5099,6 +5488,13 @@
           </a:solidFill>
           <a:ln/>
         </p:spPr>
+        <p:txBody>
+          <a:bodyPr/>
+          <a:lstStyle/>
+          <a:p>
+            <a:endParaRPr lang="en-US"/>
+          </a:p>
+        </p:txBody>
       </p:sp>
       <p:sp>
         <p:nvSpPr>
@@ -5121,7 +5517,7 @@
           <a:bodyPr wrap="square" lIns="0" tIns="0" rIns="0" bIns="0" rtlCol="0" anchor="ctr"/>
           <a:lstStyle/>
           <a:p>
-            <a:pPr algn="ctr" indent="0" marL="0">
+            <a:pPr marL="0" indent="0" algn="ctr">
               <a:buNone/>
             </a:pPr>
             <a:r>
@@ -5160,7 +5556,7 @@
           <a:bodyPr wrap="square" lIns="0" tIns="0" rIns="0" bIns="0" rtlCol="0" anchor="ctr"/>
           <a:lstStyle/>
           <a:p>
-            <a:pPr algn="ctr" indent="0" marL="0">
+            <a:pPr marL="0" indent="0" algn="ctr">
               <a:buNone/>
             </a:pPr>
             <a:r>
@@ -5199,7 +5595,7 @@
           <a:bodyPr wrap="square" lIns="0" tIns="0" rIns="0" bIns="0" rtlCol="0" anchor="t"/>
           <a:lstStyle/>
           <a:p>
-            <a:pPr algn="ctr" indent="0" marL="0">
+            <a:pPr marL="0" indent="0" algn="ctr">
               <a:buNone/>
             </a:pPr>
             <a:r>
@@ -5243,13 +5639,20 @@
             <a:prstDash val="solid"/>
           </a:ln>
           <a:effectLst>
-            <a:outerShdw sx="100000" sy="100000" kx="0" ky="0" algn="bl" rotWithShape="0" blurRad="88900" dist="38100" dir="8100000">
+            <a:outerShdw blurRad="88900" dist="38100" dir="8100000" algn="bl" rotWithShape="0">
               <a:srgbClr val="000000">
                 <a:alpha val="18000"/>
               </a:srgbClr>
             </a:outerShdw>
           </a:effectLst>
         </p:spPr>
+        <p:txBody>
+          <a:bodyPr/>
+          <a:lstStyle/>
+          <a:p>
+            <a:endParaRPr lang="en-US"/>
+          </a:p>
+        </p:txBody>
       </p:sp>
       <p:sp>
         <p:nvSpPr>
@@ -5270,6 +5673,13 @@
           </a:solidFill>
           <a:ln/>
         </p:spPr>
+        <p:txBody>
+          <a:bodyPr/>
+          <a:lstStyle/>
+          <a:p>
+            <a:endParaRPr lang="en-US"/>
+          </a:p>
+        </p:txBody>
       </p:sp>
       <p:sp>
         <p:nvSpPr>
@@ -5292,7 +5702,7 @@
           <a:bodyPr wrap="square" lIns="0" tIns="0" rIns="0" bIns="0" rtlCol="0" anchor="ctr"/>
           <a:lstStyle/>
           <a:p>
-            <a:pPr algn="ctr" indent="0" marL="0">
+            <a:pPr marL="0" indent="0" algn="ctr">
               <a:buNone/>
             </a:pPr>
             <a:r>
@@ -5331,7 +5741,7 @@
           <a:bodyPr wrap="square" lIns="0" tIns="0" rIns="0" bIns="0" rtlCol="0" anchor="ctr"/>
           <a:lstStyle/>
           <a:p>
-            <a:pPr algn="ctr" indent="0" marL="0">
+            <a:pPr marL="0" indent="0" algn="ctr">
               <a:buNone/>
             </a:pPr>
             <a:r>
@@ -5370,7 +5780,7 @@
           <a:bodyPr wrap="square" lIns="0" tIns="0" rIns="0" bIns="0" rtlCol="0" anchor="t"/>
           <a:lstStyle/>
           <a:p>
-            <a:pPr algn="ctr" indent="0" marL="0">
+            <a:pPr marL="0" indent="0" algn="ctr">
               <a:buNone/>
             </a:pPr>
             <a:r>
@@ -5414,13 +5824,20 @@
             <a:prstDash val="solid"/>
           </a:ln>
           <a:effectLst>
-            <a:outerShdw sx="100000" sy="100000" kx="0" ky="0" algn="bl" rotWithShape="0" blurRad="88900" dist="38100" dir="8100000">
+            <a:outerShdw blurRad="88900" dist="38100" dir="8100000" algn="bl" rotWithShape="0">
               <a:srgbClr val="000000">
                 <a:alpha val="18000"/>
               </a:srgbClr>
             </a:outerShdw>
           </a:effectLst>
         </p:spPr>
+        <p:txBody>
+          <a:bodyPr/>
+          <a:lstStyle/>
+          <a:p>
+            <a:endParaRPr lang="en-US"/>
+          </a:p>
+        </p:txBody>
       </p:sp>
       <p:sp>
         <p:nvSpPr>
@@ -5441,6 +5858,13 @@
           </a:solidFill>
           <a:ln/>
         </p:spPr>
+        <p:txBody>
+          <a:bodyPr/>
+          <a:lstStyle/>
+          <a:p>
+            <a:endParaRPr lang="en-US"/>
+          </a:p>
+        </p:txBody>
       </p:sp>
       <p:sp>
         <p:nvSpPr>
@@ -5463,7 +5887,7 @@
           <a:bodyPr wrap="square" lIns="0" tIns="0" rIns="0" bIns="0" rtlCol="0" anchor="ctr"/>
           <a:lstStyle/>
           <a:p>
-            <a:pPr algn="ctr" indent="0" marL="0">
+            <a:pPr marL="0" indent="0" algn="ctr">
               <a:buNone/>
             </a:pPr>
             <a:r>
@@ -5502,7 +5926,7 @@
           <a:bodyPr wrap="square" lIns="0" tIns="0" rIns="0" bIns="0" rtlCol="0" anchor="ctr"/>
           <a:lstStyle/>
           <a:p>
-            <a:pPr algn="ctr" indent="0" marL="0">
+            <a:pPr marL="0" indent="0" algn="ctr">
               <a:buNone/>
             </a:pPr>
             <a:r>
@@ -5541,7 +5965,7 @@
           <a:bodyPr wrap="square" lIns="0" tIns="0" rIns="0" bIns="0" rtlCol="0" anchor="t"/>
           <a:lstStyle/>
           <a:p>
-            <a:pPr algn="ctr" indent="0" marL="0">
+            <a:pPr marL="0" indent="0" algn="ctr">
               <a:buNone/>
             </a:pPr>
             <a:r>
@@ -5585,13 +6009,20 @@
             <a:prstDash val="solid"/>
           </a:ln>
           <a:effectLst>
-            <a:outerShdw sx="100000" sy="100000" kx="0" ky="0" algn="bl" rotWithShape="0" blurRad="88900" dist="38100" dir="8100000">
+            <a:outerShdw blurRad="88900" dist="38100" dir="8100000" algn="bl" rotWithShape="0">
               <a:srgbClr val="000000">
                 <a:alpha val="18000"/>
               </a:srgbClr>
             </a:outerShdw>
           </a:effectLst>
         </p:spPr>
+        <p:txBody>
+          <a:bodyPr/>
+          <a:lstStyle/>
+          <a:p>
+            <a:endParaRPr lang="en-US"/>
+          </a:p>
+        </p:txBody>
       </p:sp>
       <p:sp>
         <p:nvSpPr>
@@ -5612,6 +6043,13 @@
           </a:solidFill>
           <a:ln/>
         </p:spPr>
+        <p:txBody>
+          <a:bodyPr/>
+          <a:lstStyle/>
+          <a:p>
+            <a:endParaRPr lang="en-US"/>
+          </a:p>
+        </p:txBody>
       </p:sp>
       <p:sp>
         <p:nvSpPr>
@@ -5634,7 +6072,7 @@
           <a:bodyPr wrap="square" lIns="0" tIns="0" rIns="0" bIns="0" rtlCol="0" anchor="ctr"/>
           <a:lstStyle/>
           <a:p>
-            <a:pPr algn="ctr" indent="0" marL="0">
+            <a:pPr marL="0" indent="0" algn="ctr">
               <a:buNone/>
             </a:pPr>
             <a:r>
@@ -5673,7 +6111,7 @@
           <a:bodyPr wrap="square" lIns="0" tIns="0" rIns="0" bIns="0" rtlCol="0" anchor="ctr"/>
           <a:lstStyle/>
           <a:p>
-            <a:pPr algn="ctr" indent="0" marL="0">
+            <a:pPr marL="0" indent="0" algn="ctr">
               <a:buNone/>
             </a:pPr>
             <a:r>
@@ -5712,7 +6150,7 @@
           <a:bodyPr wrap="square" lIns="0" tIns="0" rIns="0" bIns="0" rtlCol="0" anchor="t"/>
           <a:lstStyle/>
           <a:p>
-            <a:pPr algn="ctr" indent="0" marL="0">
+            <a:pPr marL="0" indent="0" algn="ctr">
               <a:buNone/>
             </a:pPr>
             <a:r>
@@ -5756,13 +6194,20 @@
             <a:prstDash val="solid"/>
           </a:ln>
           <a:effectLst>
-            <a:outerShdw sx="100000" sy="100000" kx="0" ky="0" algn="bl" rotWithShape="0" blurRad="88900" dist="38100" dir="8100000">
+            <a:outerShdw blurRad="88900" dist="38100" dir="8100000" algn="bl" rotWithShape="0">
               <a:srgbClr val="000000">
                 <a:alpha val="18000"/>
               </a:srgbClr>
             </a:outerShdw>
           </a:effectLst>
         </p:spPr>
+        <p:txBody>
+          <a:bodyPr/>
+          <a:lstStyle/>
+          <a:p>
+            <a:endParaRPr lang="en-US"/>
+          </a:p>
+        </p:txBody>
       </p:sp>
       <p:sp>
         <p:nvSpPr>
@@ -5783,6 +6228,13 @@
           </a:solidFill>
           <a:ln/>
         </p:spPr>
+        <p:txBody>
+          <a:bodyPr/>
+          <a:lstStyle/>
+          <a:p>
+            <a:endParaRPr lang="en-US"/>
+          </a:p>
+        </p:txBody>
       </p:sp>
       <p:sp>
         <p:nvSpPr>
@@ -5805,7 +6257,7 @@
           <a:bodyPr wrap="square" lIns="0" tIns="0" rIns="0" bIns="0" rtlCol="0" anchor="ctr"/>
           <a:lstStyle/>
           <a:p>
-            <a:pPr algn="ctr" indent="0" marL="0">
+            <a:pPr marL="0" indent="0" algn="ctr">
               <a:buNone/>
             </a:pPr>
             <a:r>
@@ -5844,7 +6296,7 @@
           <a:bodyPr wrap="square" lIns="0" tIns="0" rIns="0" bIns="0" rtlCol="0" anchor="ctr"/>
           <a:lstStyle/>
           <a:p>
-            <a:pPr algn="ctr" indent="0" marL="0">
+            <a:pPr marL="0" indent="0" algn="ctr">
               <a:buNone/>
             </a:pPr>
             <a:r>
@@ -5883,7 +6335,7 @@
           <a:bodyPr wrap="square" lIns="0" tIns="0" rIns="0" bIns="0" rtlCol="0" anchor="t"/>
           <a:lstStyle/>
           <a:p>
-            <a:pPr algn="ctr" indent="0" marL="0">
+            <a:pPr marL="0" indent="0" algn="ctr">
               <a:buNone/>
             </a:pPr>
             <a:r>
@@ -5927,13 +6379,20 @@
             <a:prstDash val="solid"/>
           </a:ln>
           <a:effectLst>
-            <a:outerShdw sx="100000" sy="100000" kx="0" ky="0" algn="bl" rotWithShape="0" blurRad="88900" dist="38100" dir="8100000">
+            <a:outerShdw blurRad="88900" dist="38100" dir="8100000" algn="bl" rotWithShape="0">
               <a:srgbClr val="000000">
                 <a:alpha val="18000"/>
               </a:srgbClr>
             </a:outerShdw>
           </a:effectLst>
         </p:spPr>
+        <p:txBody>
+          <a:bodyPr/>
+          <a:lstStyle/>
+          <a:p>
+            <a:endParaRPr lang="en-US"/>
+          </a:p>
+        </p:txBody>
       </p:sp>
       <p:sp>
         <p:nvSpPr>
@@ -5954,6 +6413,13 @@
           </a:solidFill>
           <a:ln/>
         </p:spPr>
+        <p:txBody>
+          <a:bodyPr/>
+          <a:lstStyle/>
+          <a:p>
+            <a:endParaRPr lang="en-US"/>
+          </a:p>
+        </p:txBody>
       </p:sp>
       <p:sp>
         <p:nvSpPr>
@@ -5976,7 +6442,7 @@
           <a:bodyPr wrap="square" lIns="0" tIns="0" rIns="0" bIns="0" rtlCol="0" anchor="ctr"/>
           <a:lstStyle/>
           <a:p>
-            <a:pPr algn="ctr" indent="0" marL="0">
+            <a:pPr marL="0" indent="0" algn="ctr">
               <a:buNone/>
             </a:pPr>
             <a:r>
@@ -6015,7 +6481,7 @@
           <a:bodyPr wrap="square" lIns="0" tIns="0" rIns="0" bIns="0" rtlCol="0" anchor="ctr"/>
           <a:lstStyle/>
           <a:p>
-            <a:pPr algn="ctr" indent="0" marL="0">
+            <a:pPr marL="0" indent="0" algn="ctr">
               <a:buNone/>
             </a:pPr>
             <a:r>
@@ -6054,7 +6520,7 @@
           <a:bodyPr wrap="square" lIns="0" tIns="0" rIns="0" bIns="0" rtlCol="0" anchor="t"/>
           <a:lstStyle/>
           <a:p>
-            <a:pPr algn="ctr" indent="0" marL="0">
+            <a:pPr marL="0" indent="0" algn="ctr">
               <a:buNone/>
             </a:pPr>
             <a:r>
@@ -6093,7 +6559,7 @@
           <a:bodyPr wrap="square" lIns="0" tIns="0" rIns="0" bIns="0" rtlCol="0" anchor="ctr"/>
           <a:lstStyle/>
           <a:p>
-            <a:pPr algn="ctr" indent="0" marL="0">
+            <a:pPr marL="0" indent="0" algn="ctr">
               <a:buNone/>
             </a:pPr>
             <a:r>
@@ -6127,6 +6593,7 @@
         <a:solidFill>
           <a:srgbClr val="FFFFFF"/>
         </a:solidFill>
+        <a:effectLst/>
       </p:bgPr>
     </p:bg>
     <p:spTree>
@@ -6164,11 +6631,11 @@
           <a:bodyPr wrap="square" lIns="0" tIns="0" rIns="0" bIns="0" rtlCol="0" anchor="ctr"/>
           <a:lstStyle/>
           <a:p>
-            <a:pPr indent="0" marL="0">
-              <a:buNone/>
-            </a:pPr>
-            <a:r>
-              <a:rPr lang="en-US" sz="1200" b="1" spc="200" kern="0" dirty="0">
+            <a:pPr marL="0" indent="0">
+              <a:buNone/>
+            </a:pPr>
+            <a:r>
+              <a:rPr lang="en-US" sz="1200" b="1" kern="0" spc="200" dirty="0">
                 <a:solidFill>
                   <a:srgbClr val="3D5AAE"/>
                 </a:solidFill>
@@ -6203,7 +6670,7 @@
           <a:bodyPr wrap="square" lIns="0" tIns="0" rIns="0" bIns="0" rtlCol="0" anchor="ctr"/>
           <a:lstStyle/>
           <a:p>
-            <a:pPr indent="0" marL="0">
+            <a:pPr marL="0" indent="0">
               <a:buNone/>
             </a:pPr>
             <a:r>
@@ -6223,14 +6690,14 @@
       </p:sp>
       <p:pic>
         <p:nvPicPr>
-          <p:cNvPr id="4" name="Image 0" descr="C:\yüksek\Yazılım Tasarım ve Mimarisi\proje\figures\fig_design_size.png">    </p:cNvPr>
+          <p:cNvPr id="4" name="Image 0" descr="C:\yüksek\Yazılım Tasarım ve Mimarisi\proje\figures\fig_design_size.png"/>
           <p:cNvPicPr>
             <a:picLocks noChangeAspect="1"/>
           </p:cNvPicPr>
           <p:nvPr/>
         </p:nvPicPr>
         <p:blipFill>
-          <a:blip r:embed="rId1"/>
+          <a:blip r:embed="rId3"/>
           <a:stretch>
             <a:fillRect/>
           </a:stretch>
@@ -6244,7 +6711,7 @@
             <a:avLst/>
           </a:prstGeom>
           <a:effectLst>
-            <a:outerShdw sx="100000" sy="100000" kx="0" ky="0" algn="bl" rotWithShape="0" blurRad="88900" dist="38100" dir="8100000">
+            <a:outerShdw blurRad="88900" dist="38100" dir="8100000" algn="bl" rotWithShape="0">
               <a:srgbClr val="000000">
                 <a:alpha val="18000"/>
               </a:srgbClr>
@@ -6278,13 +6745,20 @@
             <a:prstDash val="solid"/>
           </a:ln>
           <a:effectLst>
-            <a:outerShdw sx="100000" sy="100000" kx="0" ky="0" algn="bl" rotWithShape="0" blurRad="88900" dist="38100" dir="8100000">
+            <a:outerShdw blurRad="88900" dist="38100" dir="8100000" algn="bl" rotWithShape="0">
               <a:srgbClr val="000000">
                 <a:alpha val="18000"/>
               </a:srgbClr>
             </a:outerShdw>
           </a:effectLst>
         </p:spPr>
+        <p:txBody>
+          <a:bodyPr/>
+          <a:lstStyle/>
+          <a:p>
+            <a:endParaRPr lang="en-US"/>
+          </a:p>
+        </p:txBody>
       </p:sp>
       <p:sp>
         <p:nvSpPr>
@@ -6307,7 +6781,7 @@
           <a:bodyPr wrap="square" lIns="0" tIns="0" rIns="0" bIns="0" rtlCol="0" anchor="ctr"/>
           <a:lstStyle/>
           <a:p>
-            <a:pPr algn="ctr" indent="0" marL="0">
+            <a:pPr marL="0" indent="0" algn="ctr">
               <a:buNone/>
             </a:pPr>
             <a:r>
@@ -6346,7 +6820,7 @@
           <a:bodyPr wrap="square" lIns="0" tIns="0" rIns="0" bIns="0" rtlCol="0" anchor="ctr"/>
           <a:lstStyle/>
           <a:p>
-            <a:pPr algn="ctr" indent="0" marL="0">
+            <a:pPr marL="0" indent="0" algn="ctr">
               <a:buNone/>
             </a:pPr>
             <a:r>
@@ -6363,7 +6837,7 @@
             <a:endParaRPr lang="en-US" sz="1250" dirty="0"/>
           </a:p>
           <a:p>
-            <a:pPr algn="ctr" indent="0" marL="0">
+            <a:pPr marL="0" indent="0" algn="ctr">
               <a:buNone/>
             </a:pPr>
             <a:r>
@@ -6407,13 +6881,20 @@
             <a:prstDash val="solid"/>
           </a:ln>
           <a:effectLst>
-            <a:outerShdw sx="100000" sy="100000" kx="0" ky="0" algn="bl" rotWithShape="0" blurRad="88900" dist="38100" dir="8100000">
+            <a:outerShdw blurRad="88900" dist="38100" dir="8100000" algn="bl" rotWithShape="0">
               <a:srgbClr val="000000">
                 <a:alpha val="18000"/>
               </a:srgbClr>
             </a:outerShdw>
           </a:effectLst>
         </p:spPr>
+        <p:txBody>
+          <a:bodyPr/>
+          <a:lstStyle/>
+          <a:p>
+            <a:endParaRPr lang="en-US"/>
+          </a:p>
+        </p:txBody>
       </p:sp>
       <p:sp>
         <p:nvSpPr>
@@ -6436,7 +6917,7 @@
           <a:bodyPr wrap="square" lIns="0" tIns="0" rIns="0" bIns="0" rtlCol="0" anchor="ctr"/>
           <a:lstStyle/>
           <a:p>
-            <a:pPr algn="ctr" indent="0" marL="0">
+            <a:pPr marL="0" indent="0" algn="ctr">
               <a:buNone/>
             </a:pPr>
             <a:r>
@@ -6475,7 +6956,7 @@
           <a:bodyPr wrap="square" lIns="0" tIns="0" rIns="0" bIns="0" rtlCol="0" anchor="ctr"/>
           <a:lstStyle/>
           <a:p>
-            <a:pPr algn="ctr" indent="0" marL="0">
+            <a:pPr marL="0" indent="0" algn="ctr">
               <a:buNone/>
             </a:pPr>
             <a:r>
@@ -6492,7 +6973,7 @@
             <a:endParaRPr lang="en-US" sz="1250" dirty="0"/>
           </a:p>
           <a:p>
-            <a:pPr algn="ctr" indent="0" marL="0">
+            <a:pPr marL="0" indent="0" algn="ctr">
               <a:buNone/>
             </a:pPr>
             <a:r>
@@ -6536,13 +7017,20 @@
             <a:prstDash val="solid"/>
           </a:ln>
           <a:effectLst>
-            <a:outerShdw sx="100000" sy="100000" kx="0" ky="0" algn="bl" rotWithShape="0" blurRad="88900" dist="38100" dir="8100000">
+            <a:outerShdw blurRad="88900" dist="38100" dir="8100000" algn="bl" rotWithShape="0">
               <a:srgbClr val="000000">
                 <a:alpha val="18000"/>
               </a:srgbClr>
             </a:outerShdw>
           </a:effectLst>
         </p:spPr>
+        <p:txBody>
+          <a:bodyPr/>
+          <a:lstStyle/>
+          <a:p>
+            <a:endParaRPr lang="en-US"/>
+          </a:p>
+        </p:txBody>
       </p:sp>
       <p:sp>
         <p:nvSpPr>
@@ -6565,7 +7053,7 @@
           <a:bodyPr wrap="square" lIns="0" tIns="0" rIns="0" bIns="0" rtlCol="0" anchor="ctr"/>
           <a:lstStyle/>
           <a:p>
-            <a:pPr algn="ctr" indent="0" marL="0">
+            <a:pPr marL="0" indent="0" algn="ctr">
               <a:buNone/>
             </a:pPr>
             <a:r>
@@ -6604,7 +7092,7 @@
           <a:bodyPr wrap="square" lIns="0" tIns="0" rIns="0" bIns="0" rtlCol="0" anchor="ctr"/>
           <a:lstStyle/>
           <a:p>
-            <a:pPr algn="ctr" indent="0" marL="0">
+            <a:pPr marL="0" indent="0" algn="ctr">
               <a:buNone/>
             </a:pPr>
             <a:r>
@@ -6621,7 +7109,7 @@
             <a:endParaRPr lang="en-US" sz="1250" dirty="0"/>
           </a:p>
           <a:p>
-            <a:pPr algn="ctr" indent="0" marL="0">
+            <a:pPr marL="0" indent="0" algn="ctr">
               <a:buNone/>
             </a:pPr>
             <a:r>
@@ -6655,6 +7143,7 @@
         <a:solidFill>
           <a:srgbClr val="FFFFFF"/>
         </a:solidFill>
+        <a:effectLst/>
       </p:bgPr>
     </p:bg>
     <p:spTree>
@@ -6692,11 +7181,11 @@
           <a:bodyPr wrap="square" lIns="0" tIns="0" rIns="0" bIns="0" rtlCol="0" anchor="ctr"/>
           <a:lstStyle/>
           <a:p>
-            <a:pPr indent="0" marL="0">
-              <a:buNone/>
-            </a:pPr>
-            <a:r>
-              <a:rPr lang="en-US" sz="1200" b="1" spc="200" kern="0" dirty="0">
+            <a:pPr marL="0" indent="0">
+              <a:buNone/>
+            </a:pPr>
+            <a:r>
+              <a:rPr lang="en-US" sz="1200" b="1" kern="0" spc="200" dirty="0">
                 <a:solidFill>
                   <a:srgbClr val="3D5AAE"/>
                 </a:solidFill>
@@ -6731,7 +7220,7 @@
           <a:bodyPr wrap="square" lIns="0" tIns="0" rIns="0" bIns="0" rtlCol="0" anchor="ctr"/>
           <a:lstStyle/>
           <a:p>
-            <a:pPr indent="0" marL="0">
+            <a:pPr marL="0" indent="0">
               <a:buNone/>
             </a:pPr>
             <a:r>
@@ -6751,14 +7240,14 @@
       </p:sp>
       <p:pic>
         <p:nvPicPr>
-          <p:cNvPr id="4" name="Image 0" descr="C:\yüksek\Yazılım Tasarım ve Mimarisi\proje\figures\fig_quality_norm.png">    </p:cNvPr>
+          <p:cNvPr id="4" name="Image 0" descr="C:\yüksek\Yazılım Tasarım ve Mimarisi\proje\figures\fig_quality_norm.png"/>
           <p:cNvPicPr>
             <a:picLocks noChangeAspect="1"/>
           </p:cNvPicPr>
           <p:nvPr/>
         </p:nvPicPr>
         <p:blipFill>
-          <a:blip r:embed="rId1"/>
+          <a:blip r:embed="rId3"/>
           <a:stretch>
             <a:fillRect/>
           </a:stretch>
@@ -6772,7 +7261,7 @@
             <a:avLst/>
           </a:prstGeom>
           <a:effectLst>
-            <a:outerShdw sx="100000" sy="100000" kx="0" ky="0" algn="bl" rotWithShape="0" blurRad="88900" dist="38100" dir="8100000">
+            <a:outerShdw blurRad="88900" dist="38100" dir="8100000" algn="bl" rotWithShape="0">
               <a:srgbClr val="000000">
                 <a:alpha val="18000"/>
               </a:srgbClr>
@@ -6801,7 +7290,7 @@
           <a:bodyPr wrap="square" lIns="0" tIns="0" rIns="0" bIns="0" rtlCol="0" anchor="ctr"/>
           <a:lstStyle/>
           <a:p>
-            <a:pPr algn="ctr" indent="0" marL="0">
+            <a:pPr marL="0" indent="0" algn="ctr">
               <a:buNone/>
             </a:pPr>
             <a:r>
@@ -6815,9 +7304,6 @@
               </a:rPr>
               <a:t>Pozitif nitelikler artıyor (Reusability +%9, Flexibility +%8); </a:t>
             </a:r>
-            <a:pPr algn="ctr" indent="0" marL="0">
-              <a:buNone/>
-            </a:pPr>
             <a:r>
               <a:rPr lang="en-US" sz="1450" b="1" dirty="0">
                 <a:solidFill>
@@ -6829,9 +7315,6 @@
               </a:rPr>
               <a:t>Understandability tek yönlü kötüleşiyor (-%20). </a:t>
             </a:r>
-            <a:pPr algn="ctr" indent="0" marL="0">
-              <a:buNone/>
-            </a:pPr>
             <a:r>
               <a:rPr lang="en-US" sz="1450" dirty="0">
                 <a:solidFill>
@@ -6863,6 +7346,7 @@
         <a:solidFill>
           <a:srgbClr val="FFFFFF"/>
         </a:solidFill>
+        <a:effectLst/>
       </p:bgPr>
     </p:bg>
     <p:spTree>
@@ -6900,11 +7384,11 @@
           <a:bodyPr wrap="square" lIns="0" tIns="0" rIns="0" bIns="0" rtlCol="0" anchor="ctr"/>
           <a:lstStyle/>
           <a:p>
-            <a:pPr indent="0" marL="0">
-              <a:buNone/>
-            </a:pPr>
-            <a:r>
-              <a:rPr lang="en-US" sz="1200" b="1" spc="200" kern="0" dirty="0">
+            <a:pPr marL="0" indent="0">
+              <a:buNone/>
+            </a:pPr>
+            <a:r>
+              <a:rPr lang="en-US" sz="1200" b="1" kern="0" spc="200" dirty="0">
                 <a:solidFill>
                   <a:srgbClr val="3D5AAE"/>
                 </a:solidFill>
@@ -6939,7 +7423,7 @@
           <a:bodyPr wrap="square" lIns="0" tIns="0" rIns="0" bIns="0" rtlCol="0" anchor="ctr"/>
           <a:lstStyle/>
           <a:p>
-            <a:pPr indent="0" marL="0">
+            <a:pPr marL="0" indent="0">
               <a:buNone/>
             </a:pPr>
             <a:r>
@@ -6959,14 +7443,14 @@
       </p:sp>
       <p:pic>
         <p:nvPicPr>
-          <p:cNvPr id="4" name="Image 0" descr="C:\yüksek\Yazılım Tasarım ve Mimarisi\proje\figures\fig_coupling_cohesion.png">    </p:cNvPr>
+          <p:cNvPr id="4" name="Image 0" descr="C:\yüksek\Yazılım Tasarım ve Mimarisi\proje\figures\fig_coupling_cohesion.png"/>
           <p:cNvPicPr>
             <a:picLocks noChangeAspect="1"/>
           </p:cNvPicPr>
           <p:nvPr/>
         </p:nvPicPr>
         <p:blipFill>
-          <a:blip r:embed="rId1"/>
+          <a:blip r:embed="rId3"/>
           <a:stretch>
             <a:fillRect/>
           </a:stretch>
@@ -6980,7 +7464,7 @@
             <a:avLst/>
           </a:prstGeom>
           <a:effectLst>
-            <a:outerShdw sx="100000" sy="100000" kx="0" ky="0" algn="bl" rotWithShape="0" blurRad="88900" dist="38100" dir="8100000">
+            <a:outerShdw blurRad="88900" dist="38100" dir="8100000" algn="bl" rotWithShape="0">
               <a:srgbClr val="000000">
                 <a:alpha val="18000"/>
               </a:srgbClr>
@@ -7014,13 +7498,20 @@
             <a:prstDash val="solid"/>
           </a:ln>
           <a:effectLst>
-            <a:outerShdw sx="100000" sy="100000" kx="0" ky="0" algn="bl" rotWithShape="0" blurRad="88900" dist="38100" dir="8100000">
+            <a:outerShdw blurRad="88900" dist="38100" dir="8100000" algn="bl" rotWithShape="0">
               <a:srgbClr val="000000">
                 <a:alpha val="18000"/>
               </a:srgbClr>
             </a:outerShdw>
           </a:effectLst>
         </p:spPr>
+        <p:txBody>
+          <a:bodyPr/>
+          <a:lstStyle/>
+          <a:p>
+            <a:endParaRPr lang="en-US"/>
+          </a:p>
+        </p:txBody>
       </p:sp>
       <p:sp>
         <p:nvSpPr>
@@ -7043,7 +7534,7 @@
           <a:bodyPr wrap="square" lIns="0" tIns="0" rIns="0" bIns="0" rtlCol="0" anchor="ctr"/>
           <a:lstStyle/>
           <a:p>
-            <a:pPr algn="ctr" indent="0" marL="0">
+            <a:pPr marL="0" indent="0" algn="ctr">
               <a:buNone/>
             </a:pPr>
             <a:r>
@@ -7082,7 +7573,7 @@
           <a:bodyPr wrap="square" lIns="0" tIns="0" rIns="0" bIns="0" rtlCol="0" anchor="ctr"/>
           <a:lstStyle/>
           <a:p>
-            <a:pPr algn="ctr" indent="0" marL="0">
+            <a:pPr marL="0" indent="0" algn="ctr">
               <a:buNone/>
             </a:pPr>
             <a:r>
@@ -7126,13 +7617,20 @@
             <a:prstDash val="solid"/>
           </a:ln>
           <a:effectLst>
-            <a:outerShdw sx="100000" sy="100000" kx="0" ky="0" algn="bl" rotWithShape="0" blurRad="88900" dist="38100" dir="8100000">
+            <a:outerShdw blurRad="88900" dist="38100" dir="8100000" algn="bl" rotWithShape="0">
               <a:srgbClr val="000000">
                 <a:alpha val="18000"/>
               </a:srgbClr>
             </a:outerShdw>
           </a:effectLst>
         </p:spPr>
+        <p:txBody>
+          <a:bodyPr/>
+          <a:lstStyle/>
+          <a:p>
+            <a:endParaRPr lang="en-US"/>
+          </a:p>
+        </p:txBody>
       </p:sp>
       <p:sp>
         <p:nvSpPr>
@@ -7155,7 +7653,7 @@
           <a:bodyPr wrap="square" lIns="0" tIns="0" rIns="0" bIns="0" rtlCol="0" anchor="ctr"/>
           <a:lstStyle/>
           <a:p>
-            <a:pPr algn="ctr" indent="0" marL="0">
+            <a:pPr marL="0" indent="0" algn="ctr">
               <a:buNone/>
             </a:pPr>
             <a:r>
@@ -7194,7 +7692,7 @@
           <a:bodyPr wrap="square" lIns="0" tIns="0" rIns="0" bIns="0" rtlCol="0" anchor="ctr"/>
           <a:lstStyle/>
           <a:p>
-            <a:pPr algn="ctr" indent="0" marL="0">
+            <a:pPr marL="0" indent="0" algn="ctr">
               <a:buNone/>
             </a:pPr>
             <a:r>
@@ -7238,13 +7736,20 @@
             <a:prstDash val="solid"/>
           </a:ln>
           <a:effectLst>
-            <a:outerShdw sx="100000" sy="100000" kx="0" ky="0" algn="bl" rotWithShape="0" blurRad="88900" dist="38100" dir="8100000">
+            <a:outerShdw blurRad="88900" dist="38100" dir="8100000" algn="bl" rotWithShape="0">
               <a:srgbClr val="000000">
                 <a:alpha val="18000"/>
               </a:srgbClr>
             </a:outerShdw>
           </a:effectLst>
         </p:spPr>
+        <p:txBody>
+          <a:bodyPr/>
+          <a:lstStyle/>
+          <a:p>
+            <a:endParaRPr lang="en-US"/>
+          </a:p>
+        </p:txBody>
       </p:sp>
       <p:sp>
         <p:nvSpPr>
@@ -7267,7 +7772,7 @@
           <a:bodyPr wrap="square" lIns="0" tIns="0" rIns="0" bIns="0" rtlCol="0" anchor="ctr"/>
           <a:lstStyle/>
           <a:p>
-            <a:pPr algn="ctr" indent="0" marL="0">
+            <a:pPr marL="0" indent="0" algn="ctr">
               <a:buNone/>
             </a:pPr>
             <a:r>
@@ -7306,7 +7811,7 @@
           <a:bodyPr wrap="square" lIns="0" tIns="0" rIns="0" bIns="0" rtlCol="0" anchor="ctr"/>
           <a:lstStyle/>
           <a:p>
-            <a:pPr algn="ctr" indent="0" marL="0">
+            <a:pPr marL="0" indent="0" algn="ctr">
               <a:buNone/>
             </a:pPr>
             <a:r>
@@ -7340,6 +7845,7 @@
         <a:solidFill>
           <a:srgbClr val="FFFFFF"/>
         </a:solidFill>
+        <a:effectLst/>
       </p:bgPr>
     </p:bg>
     <p:spTree>
@@ -7377,11 +7883,11 @@
           <a:bodyPr wrap="square" lIns="0" tIns="0" rIns="0" bIns="0" rtlCol="0" anchor="ctr"/>
           <a:lstStyle/>
           <a:p>
-            <a:pPr indent="0" marL="0">
-              <a:buNone/>
-            </a:pPr>
-            <a:r>
-              <a:rPr lang="en-US" sz="1200" b="1" spc="200" kern="0" dirty="0">
+            <a:pPr marL="0" indent="0">
+              <a:buNone/>
+            </a:pPr>
+            <a:r>
+              <a:rPr lang="en-US" sz="1200" b="1" kern="0" spc="200" dirty="0">
                 <a:solidFill>
                   <a:srgbClr val="3D5AAE"/>
                 </a:solidFill>
@@ -7416,7 +7922,7 @@
           <a:bodyPr wrap="square" lIns="0" tIns="0" rIns="0" bIns="0" rtlCol="0" anchor="ctr"/>
           <a:lstStyle/>
           <a:p>
-            <a:pPr indent="0" marL="0">
+            <a:pPr marL="0" indent="0">
               <a:buNone/>
             </a:pPr>
             <a:r>
@@ -7460,13 +7966,20 @@
             <a:prstDash val="solid"/>
           </a:ln>
           <a:effectLst>
-            <a:outerShdw sx="100000" sy="100000" kx="0" ky="0" algn="bl" rotWithShape="0" blurRad="88900" dist="38100" dir="8100000">
+            <a:outerShdw blurRad="88900" dist="38100" dir="8100000" algn="bl" rotWithShape="0">
               <a:srgbClr val="000000">
                 <a:alpha val="18000"/>
               </a:srgbClr>
             </a:outerShdw>
           </a:effectLst>
         </p:spPr>
+        <p:txBody>
+          <a:bodyPr/>
+          <a:lstStyle/>
+          <a:p>
+            <a:endParaRPr lang="en-US"/>
+          </a:p>
+        </p:txBody>
       </p:sp>
       <p:sp>
         <p:nvSpPr>
@@ -7489,7 +8002,7 @@
           <a:bodyPr wrap="square" lIns="0" tIns="0" rIns="0" bIns="0" rtlCol="0" anchor="ctr"/>
           <a:lstStyle/>
           <a:p>
-            <a:pPr algn="ctr" indent="0" marL="0">
+            <a:pPr marL="0" indent="0" algn="ctr">
               <a:buNone/>
             </a:pPr>
             <a:r>
@@ -7528,7 +8041,7 @@
           <a:bodyPr wrap="square" lIns="0" tIns="0" rIns="0" bIns="0" rtlCol="0" anchor="ctr"/>
           <a:lstStyle/>
           <a:p>
-            <a:pPr algn="ctr" indent="0" marL="0">
+            <a:pPr marL="0" indent="0" algn="ctr">
               <a:buNone/>
             </a:pPr>
             <a:r>
@@ -7572,13 +8085,20 @@
             <a:prstDash val="solid"/>
           </a:ln>
           <a:effectLst>
-            <a:outerShdw sx="100000" sy="100000" kx="0" ky="0" algn="bl" rotWithShape="0" blurRad="88900" dist="38100" dir="8100000">
+            <a:outerShdw blurRad="88900" dist="38100" dir="8100000" algn="bl" rotWithShape="0">
               <a:srgbClr val="000000">
                 <a:alpha val="18000"/>
               </a:srgbClr>
             </a:outerShdw>
           </a:effectLst>
         </p:spPr>
+        <p:txBody>
+          <a:bodyPr/>
+          <a:lstStyle/>
+          <a:p>
+            <a:endParaRPr lang="en-US"/>
+          </a:p>
+        </p:txBody>
       </p:sp>
       <p:sp>
         <p:nvSpPr>
@@ -7601,7 +8121,7 @@
           <a:bodyPr wrap="square" lIns="0" tIns="0" rIns="0" bIns="0" rtlCol="0" anchor="ctr"/>
           <a:lstStyle/>
           <a:p>
-            <a:pPr algn="ctr" indent="0" marL="0">
+            <a:pPr marL="0" indent="0" algn="ctr">
               <a:buNone/>
             </a:pPr>
             <a:r>
@@ -7640,7 +8160,7 @@
           <a:bodyPr wrap="square" lIns="0" tIns="0" rIns="0" bIns="0" rtlCol="0" anchor="ctr"/>
           <a:lstStyle/>
           <a:p>
-            <a:pPr algn="ctr" indent="0" marL="0">
+            <a:pPr marL="0" indent="0" algn="ctr">
               <a:buNone/>
             </a:pPr>
             <a:r>
@@ -7684,13 +8204,20 @@
             <a:prstDash val="solid"/>
           </a:ln>
           <a:effectLst>
-            <a:outerShdw sx="100000" sy="100000" kx="0" ky="0" algn="bl" rotWithShape="0" blurRad="88900" dist="38100" dir="8100000">
+            <a:outerShdw blurRad="88900" dist="38100" dir="8100000" algn="bl" rotWithShape="0">
               <a:srgbClr val="000000">
                 <a:alpha val="18000"/>
               </a:srgbClr>
             </a:outerShdw>
           </a:effectLst>
         </p:spPr>
+        <p:txBody>
+          <a:bodyPr/>
+          <a:lstStyle/>
+          <a:p>
+            <a:endParaRPr lang="en-US"/>
+          </a:p>
+        </p:txBody>
       </p:sp>
       <p:sp>
         <p:nvSpPr>
@@ -7713,7 +8240,7 @@
           <a:bodyPr wrap="square" lIns="0" tIns="0" rIns="0" bIns="0" rtlCol="0" anchor="ctr"/>
           <a:lstStyle/>
           <a:p>
-            <a:pPr algn="ctr" indent="0" marL="0">
+            <a:pPr marL="0" indent="0" algn="ctr">
               <a:buNone/>
             </a:pPr>
             <a:r>
@@ -7752,7 +8279,7 @@
           <a:bodyPr wrap="square" lIns="0" tIns="0" rIns="0" bIns="0" rtlCol="0" anchor="ctr"/>
           <a:lstStyle/>
           <a:p>
-            <a:pPr algn="ctr" indent="0" marL="0">
+            <a:pPr marL="0" indent="0" algn="ctr">
               <a:buNone/>
             </a:pPr>
             <a:r>
@@ -7796,13 +8323,20 @@
             <a:prstDash val="solid"/>
           </a:ln>
           <a:effectLst>
-            <a:outerShdw sx="100000" sy="100000" kx="0" ky="0" algn="bl" rotWithShape="0" blurRad="88900" dist="38100" dir="8100000">
+            <a:outerShdw blurRad="88900" dist="38100" dir="8100000" algn="bl" rotWithShape="0">
               <a:srgbClr val="000000">
                 <a:alpha val="18000"/>
               </a:srgbClr>
             </a:outerShdw>
           </a:effectLst>
         </p:spPr>
+        <p:txBody>
+          <a:bodyPr/>
+          <a:lstStyle/>
+          <a:p>
+            <a:endParaRPr lang="en-US"/>
+          </a:p>
+        </p:txBody>
       </p:sp>
       <p:sp>
         <p:nvSpPr>
@@ -7825,7 +8359,7 @@
           <a:bodyPr wrap="square" lIns="0" tIns="0" rIns="0" bIns="0" rtlCol="0" anchor="ctr"/>
           <a:lstStyle/>
           <a:p>
-            <a:pPr algn="ctr" indent="0" marL="0">
+            <a:pPr marL="0" indent="0" algn="ctr">
               <a:buNone/>
             </a:pPr>
             <a:r>
@@ -7864,7 +8398,7 @@
           <a:bodyPr wrap="square" lIns="0" tIns="0" rIns="0" bIns="0" rtlCol="0" anchor="ctr"/>
           <a:lstStyle/>
           <a:p>
-            <a:pPr algn="ctr" indent="0" marL="0">
+            <a:pPr marL="0" indent="0" algn="ctr">
               <a:buNone/>
             </a:pPr>
             <a:r>
@@ -7903,7 +8437,7 @@
           <a:bodyPr wrap="square" lIns="0" tIns="0" rIns="0" bIns="0" rtlCol="0" anchor="t"/>
           <a:lstStyle/>
           <a:p>
-            <a:pPr indent="0" marL="0">
+            <a:pPr marL="0" indent="0">
               <a:lnSpc>
                 <a:spcPct val="120000"/>
               </a:lnSpc>
@@ -7920,13 +8454,82 @@
               </a:rPr>
               <a:t>Cohesion erozyonu en güçlü sinyal:  </a:t>
             </a:r>
-            <a:pPr indent="0" marL="0">
+            <a:r>
+              <a:rPr lang="en-US" sz="1600" dirty="0">
+                <a:solidFill>
+                  <a:srgbClr val="1B2433"/>
+                </a:solidFill>
+                <a:latin typeface="Calibri" pitchFamily="34" charset="0"/>
+                <a:ea typeface="Calibri" pitchFamily="34" charset="-122"/>
+                <a:cs typeface="Calibri" pitchFamily="34" charset="-120"/>
+              </a:rPr>
+              <a:t>CAM ve LCOM iki bağımsız metrik aynı yöne işaret ediyor.  Ancak </a:t>
+            </a:r>
+            <a:r>
+              <a:rPr lang="en-US" sz="1600" b="1" dirty="0">
+                <a:solidFill>
+                  <a:srgbClr val="1E8449"/>
+                </a:solidFill>
+                <a:latin typeface="Calibri" pitchFamily="34" charset="0"/>
+                <a:ea typeface="Calibri" pitchFamily="34" charset="-122"/>
+                <a:cs typeface="Calibri" pitchFamily="34" charset="-120"/>
+              </a:rPr>
+              <a:t>MOA/MFA artışı (+%17) bilinçli kompozisyon/kalıtım iyileştirmesi</a:t>
+            </a:r>
+            <a:r>
+              <a:rPr lang="en-US" sz="1600" dirty="0">
+                <a:solidFill>
+                  <a:srgbClr val="1B2433"/>
+                </a:solidFill>
+                <a:latin typeface="Calibri" pitchFamily="34" charset="0"/>
+                <a:ea typeface="Calibri" pitchFamily="34" charset="-122"/>
+                <a:cs typeface="Calibri" pitchFamily="34" charset="-120"/>
+              </a:rPr>
+              <a:t> — yıkıcı değil, kontrollü bir borç tablosu.</a:t>
+            </a:r>
+            <a:endParaRPr lang="en-US" sz="1600" dirty="0"/>
+          </a:p>
+        </p:txBody>
+      </p:sp>
+      <p:sp>
+        <p:nvSpPr>
+          <p:cNvPr id="17" name="Text 15"/>
+          <p:cNvSpPr/>
+          <p:nvPr/>
+        </p:nvSpPr>
+        <p:spPr>
+          <a:xfrm>
+            <a:off x="640080" y="4846320"/>
+            <a:ext cx="10972800" cy="1097280"/>
+          </a:xfrm>
+          <a:prstGeom prst="rect">
+            <a:avLst/>
+          </a:prstGeom>
+          <a:noFill/>
+          <a:ln/>
+        </p:spPr>
+        <p:txBody>
+          <a:bodyPr wrap="square" lIns="0" tIns="0" rIns="0" bIns="0" rtlCol="0" anchor="t"/>
+          <a:lstStyle/>
+          <a:p>
+            <a:pPr marL="0" indent="0">
               <a:lnSpc>
                 <a:spcPct val="120000"/>
               </a:lnSpc>
               <a:buNone/>
             </a:pPr>
             <a:r>
+              <a:rPr lang="en-US" sz="1600" b="1" dirty="0">
+                <a:solidFill>
+                  <a:srgbClr val="1E2761"/>
+                </a:solidFill>
+                <a:latin typeface="Calibri" pitchFamily="34" charset="0"/>
+                <a:ea typeface="Calibri" pitchFamily="34" charset="-122"/>
+                <a:cs typeface="Calibri" pitchFamily="34" charset="-120"/>
+              </a:rPr>
+              <a:t>Kırılma noktası ≈ 1.20.1 </a:t>
+            </a:r>
+            <a:r>
               <a:rPr lang="en-US" sz="1600" dirty="0">
                 <a:solidFill>
                   <a:srgbClr val="1B2433"/>
@@ -7935,31 +8538,8 @@
                 <a:ea typeface="Calibri" pitchFamily="34" charset="-122"/>
                 <a:cs typeface="Calibri" pitchFamily="34" charset="-120"/>
               </a:rPr>
-              <a:t>CAM ve LCOM iki bağımsız metrik aynı yöne işaret ediyor.  </a:t>
-            </a:r>
-            <a:pPr indent="0" marL="0">
-              <a:lnSpc>
-                <a:spcPct val="120000"/>
-              </a:lnSpc>
-              <a:buNone/>
-            </a:pPr>
-            <a:r>
-              <a:rPr lang="en-US" sz="1600" dirty="0">
-                <a:solidFill>
-                  <a:srgbClr val="1B2433"/>
-                </a:solidFill>
-                <a:latin typeface="Calibri" pitchFamily="34" charset="0"/>
-                <a:ea typeface="Calibri" pitchFamily="34" charset="-122"/>
-                <a:cs typeface="Calibri" pitchFamily="34" charset="-120"/>
-              </a:rPr>
-              <a:t>Ancak </a:t>
-            </a:r>
-            <a:pPr indent="0" marL="0">
-              <a:lnSpc>
-                <a:spcPct val="120000"/>
-              </a:lnSpc>
-              <a:buNone/>
-            </a:pPr>
+              <a:t>(ANA/DAM dip, LCOM zirve) → </a:t>
+            </a:r>
             <a:r>
               <a:rPr lang="en-US" sz="1600" b="1" dirty="0">
                 <a:solidFill>
@@ -7969,107 +8549,8 @@
                 <a:ea typeface="Calibri" pitchFamily="34" charset="-122"/>
                 <a:cs typeface="Calibri" pitchFamily="34" charset="-120"/>
               </a:rPr>
-              <a:t>MOA/MFA artışı (+%17) bilinçli kompozisyon/kalıtım iyileştirmesi</a:t>
-            </a:r>
-            <a:pPr indent="0" marL="0">
-              <a:lnSpc>
-                <a:spcPct val="120000"/>
-              </a:lnSpc>
-              <a:buNone/>
-            </a:pPr>
-            <a:r>
-              <a:rPr lang="en-US" sz="1600" dirty="0">
-                <a:solidFill>
-                  <a:srgbClr val="1B2433"/>
-                </a:solidFill>
-                <a:latin typeface="Calibri" pitchFamily="34" charset="0"/>
-                <a:ea typeface="Calibri" pitchFamily="34" charset="-122"/>
-                <a:cs typeface="Calibri" pitchFamily="34" charset="-120"/>
-              </a:rPr>
-              <a:t> — yıkıcı değil, kontrollü bir borç tablosu.</a:t>
-            </a:r>
-            <a:endParaRPr lang="en-US" sz="1600" dirty="0"/>
-          </a:p>
-        </p:txBody>
-      </p:sp>
-      <p:sp>
-        <p:nvSpPr>
-          <p:cNvPr id="17" name="Text 15"/>
-          <p:cNvSpPr/>
-          <p:nvPr/>
-        </p:nvSpPr>
-        <p:spPr>
-          <a:xfrm>
-            <a:off x="640080" y="4846320"/>
-            <a:ext cx="10972800" cy="1097280"/>
-          </a:xfrm>
-          <a:prstGeom prst="rect">
-            <a:avLst/>
-          </a:prstGeom>
-          <a:noFill/>
-          <a:ln/>
-        </p:spPr>
-        <p:txBody>
-          <a:bodyPr wrap="square" lIns="0" tIns="0" rIns="0" bIns="0" rtlCol="0" anchor="t"/>
-          <a:lstStyle/>
-          <a:p>
-            <a:pPr indent="0" marL="0">
-              <a:lnSpc>
-                <a:spcPct val="120000"/>
-              </a:lnSpc>
-              <a:buNone/>
-            </a:pPr>
-            <a:r>
-              <a:rPr lang="en-US" sz="1600" b="1" dirty="0">
-                <a:solidFill>
-                  <a:srgbClr val="1E2761"/>
-                </a:solidFill>
-                <a:latin typeface="Calibri" pitchFamily="34" charset="0"/>
-                <a:ea typeface="Calibri" pitchFamily="34" charset="-122"/>
-                <a:cs typeface="Calibri" pitchFamily="34" charset="-120"/>
-              </a:rPr>
-              <a:t>Kırılma noktası ≈ 1.20.1 </a:t>
-            </a:r>
-            <a:pPr indent="0" marL="0">
-              <a:lnSpc>
-                <a:spcPct val="120000"/>
-              </a:lnSpc>
-              <a:buNone/>
-            </a:pPr>
-            <a:r>
-              <a:rPr lang="en-US" sz="1600" dirty="0">
-                <a:solidFill>
-                  <a:srgbClr val="1B2433"/>
-                </a:solidFill>
-                <a:latin typeface="Calibri" pitchFamily="34" charset="0"/>
-                <a:ea typeface="Calibri" pitchFamily="34" charset="-122"/>
-                <a:cs typeface="Calibri" pitchFamily="34" charset="-120"/>
-              </a:rPr>
-              <a:t>(ANA/DAM dip, LCOM zirve) → </a:t>
-            </a:r>
-            <a:pPr indent="0" marL="0">
-              <a:lnSpc>
-                <a:spcPct val="120000"/>
-              </a:lnSpc>
-              <a:buNone/>
-            </a:pPr>
-            <a:r>
-              <a:rPr lang="en-US" sz="1600" b="1" dirty="0">
-                <a:solidFill>
-                  <a:srgbClr val="1E8449"/>
-                </a:solidFill>
-                <a:latin typeface="Calibri" pitchFamily="34" charset="0"/>
-                <a:ea typeface="Calibri" pitchFamily="34" charset="-122"/>
-                <a:cs typeface="Calibri" pitchFamily="34" charset="-120"/>
-              </a:rPr>
               <a:t>1.21.2+ kısmi toparlanma</a:t>
             </a:r>
-            <a:pPr indent="0" marL="0">
-              <a:lnSpc>
-                <a:spcPct val="120000"/>
-              </a:lnSpc>
-              <a:buNone/>
-            </a:pPr>
             <a:r>
               <a:rPr lang="en-US" sz="1600" dirty="0">
                 <a:solidFill>
@@ -8101,6 +8582,7 @@
         <a:solidFill>
           <a:srgbClr val="FFFFFF"/>
         </a:solidFill>
+        <a:effectLst/>
       </p:bgPr>
     </p:bg>
     <p:spTree>
@@ -8138,11 +8620,11 @@
           <a:bodyPr wrap="square" lIns="0" tIns="0" rIns="0" bIns="0" rtlCol="0" anchor="ctr"/>
           <a:lstStyle/>
           <a:p>
-            <a:pPr indent="0" marL="0">
-              <a:buNone/>
-            </a:pPr>
-            <a:r>
-              <a:rPr lang="en-US" sz="1200" b="1" spc="200" kern="0" dirty="0">
+            <a:pPr marL="0" indent="0">
+              <a:buNone/>
+            </a:pPr>
+            <a:r>
+              <a:rPr lang="en-US" sz="1200" b="1" kern="0" spc="200" dirty="0">
                 <a:solidFill>
                   <a:srgbClr val="3D5AAE"/>
                 </a:solidFill>
@@ -8177,7 +8659,7 @@
           <a:bodyPr wrap="square" lIns="0" tIns="0" rIns="0" bIns="0" rtlCol="0" anchor="ctr"/>
           <a:lstStyle/>
           <a:p>
-            <a:pPr indent="0" marL="0">
+            <a:pPr marL="0" indent="0">
               <a:buNone/>
             </a:pPr>
             <a:r>
@@ -8197,14 +8679,14 @@
       </p:sp>
       <p:pic>
         <p:nvPicPr>
-          <p:cNvPr id="4" name="Image 0" descr="C:\yüksek\Yazılım Tasarım ve Mimarisi\proje\figures\fig_ck_means.png">    </p:cNvPr>
+          <p:cNvPr id="4" name="Image 0" descr="C:\yüksek\Yazılım Tasarım ve Mimarisi\proje\figures\fig_ck_means.png"/>
           <p:cNvPicPr>
             <a:picLocks noChangeAspect="1"/>
           </p:cNvPicPr>
           <p:nvPr/>
         </p:nvPicPr>
         <p:blipFill>
-          <a:blip r:embed="rId1"/>
+          <a:blip r:embed="rId3"/>
           <a:stretch>
             <a:fillRect/>
           </a:stretch>
@@ -8218,7 +8700,7 @@
             <a:avLst/>
           </a:prstGeom>
           <a:effectLst>
-            <a:outerShdw sx="100000" sy="100000" kx="0" ky="0" algn="bl" rotWithShape="0" blurRad="88900" dist="38100" dir="8100000">
+            <a:outerShdw blurRad="88900" dist="38100" dir="8100000" algn="bl" rotWithShape="0">
               <a:srgbClr val="000000">
                 <a:alpha val="18000"/>
               </a:srgbClr>
@@ -8247,7 +8729,7 @@
           <a:bodyPr wrap="square" lIns="0" tIns="0" rIns="0" bIns="0" rtlCol="0" anchor="ctr"/>
           <a:lstStyle/>
           <a:p>
-            <a:pPr indent="0" marL="0">
+            <a:pPr marL="0" indent="0">
               <a:buNone/>
             </a:pPr>
             <a:r>
@@ -8281,15 +8763,27 @@
         </p:nvGraphicFramePr>
         <p:xfrm>
           <a:off x="8229600" y="2148840"/>
-          <a:ext cx="3474720" cy="914400"/>
+          <a:ext cx="3474720" cy="2688336"/>
         </p:xfrm>
         <a:graphic>
           <a:graphicData uri="http://schemas.openxmlformats.org/drawingml/2006/table">
             <a:tbl>
               <a:tblPr/>
               <a:tblGrid>
-                <a:gridCol w="2011680"/>
-                <a:gridCol w="1463040"/>
+                <a:gridCol w="2011680">
+                  <a:extLst>
+                    <a:ext uri="{9D8B030D-6E8A-4147-A177-3AD203B41FA5}">
+                      <a16:colId xmlns:a16="http://schemas.microsoft.com/office/drawing/2014/main" val="20000"/>
+                    </a:ext>
+                  </a:extLst>
+                </a:gridCol>
+                <a:gridCol w="1463040">
+                  <a:extLst>
+                    <a:ext uri="{9D8B030D-6E8A-4147-A177-3AD203B41FA5}">
+                      <a16:colId xmlns:a16="http://schemas.microsoft.com/office/drawing/2014/main" val="20001"/>
+                    </a:ext>
+                  </a:extLst>
+                </a:gridCol>
               </a:tblGrid>
               <a:tr h="384048">
                 <a:tc>
@@ -8297,7 +8791,7 @@
                     <a:bodyPr/>
                     <a:lstStyle/>
                     <a:p>
-                      <a:pPr algn="l" indent="0" marL="0">
+                      <a:pPr marL="0" indent="0" algn="l">
                         <a:buNone/>
                       </a:pPr>
                       <a:r>
@@ -8318,7 +8812,7 @@
                       </a:endParaRPr>
                     </a:p>
                   </a:txBody>
-                  <a:tcPr marL="91440" marR="91440" marT="45720" marB="45720" anchor="ctr">
+                  <a:tcPr anchor="ctr">
                     <a:lnL w="6350" cap="flat" cmpd="sng" algn="ctr">
                       <a:solidFill>
                         <a:srgbClr val="CADCFC"/>
@@ -8365,7 +8859,7 @@
                     <a:bodyPr/>
                     <a:lstStyle/>
                     <a:p>
-                      <a:pPr algn="l" indent="0" marL="0">
+                      <a:pPr marL="0" indent="0" algn="l">
                         <a:buNone/>
                       </a:pPr>
                       <a:r>
@@ -8386,7 +8880,7 @@
                       </a:endParaRPr>
                     </a:p>
                   </a:txBody>
-                  <a:tcPr marL="91440" marR="91440" marT="45720" marB="45720" anchor="ctr">
+                  <a:tcPr anchor="ctr">
                     <a:lnL w="6350" cap="flat" cmpd="sng" algn="ctr">
                       <a:solidFill>
                         <a:srgbClr val="CADCFC"/>
@@ -8428,6 +8922,11 @@
                     </a:solidFill>
                   </a:tcPr>
                 </a:tc>
+                <a:extLst>
+                  <a:ext uri="{0D108BD9-81ED-4DB2-BD59-A6C34878D82A}">
+                    <a16:rowId xmlns:a16="http://schemas.microsoft.com/office/drawing/2014/main" val="10000"/>
+                  </a:ext>
+                </a:extLst>
               </a:tr>
               <a:tr h="384048">
                 <a:tc>
@@ -8435,7 +8934,7 @@
                     <a:bodyPr/>
                     <a:lstStyle/>
                     <a:p>
-                      <a:pPr algn="l" indent="0" marL="0">
+                      <a:pPr marL="0" indent="0" algn="l">
                         <a:buNone/>
                       </a:pPr>
                       <a:r>
@@ -8456,7 +8955,7 @@
                       </a:endParaRPr>
                     </a:p>
                   </a:txBody>
-                  <a:tcPr marL="91440" marR="91440" marT="45720" marB="45720" anchor="ctr">
+                  <a:tcPr anchor="ctr">
                     <a:lnL w="6350" cap="flat" cmpd="sng" algn="ctr">
                       <a:solidFill>
                         <a:srgbClr val="CADCFC"/>
@@ -8500,7 +8999,7 @@
                     <a:bodyPr/>
                     <a:lstStyle/>
                     <a:p>
-                      <a:pPr algn="l" indent="0" marL="0">
+                      <a:pPr marL="0" indent="0" algn="l">
                         <a:buNone/>
                       </a:pPr>
                       <a:r>
@@ -8521,7 +9020,7 @@
                       </a:endParaRPr>
                     </a:p>
                   </a:txBody>
-                  <a:tcPr marL="91440" marR="91440" marT="45720" marB="45720" anchor="ctr">
+                  <a:tcPr anchor="ctr">
                     <a:lnL w="6350" cap="flat" cmpd="sng" algn="ctr">
                       <a:solidFill>
                         <a:srgbClr val="CADCFC"/>
@@ -8560,6 +9059,11 @@
                     </a:lnB>
                   </a:tcPr>
                 </a:tc>
+                <a:extLst>
+                  <a:ext uri="{0D108BD9-81ED-4DB2-BD59-A6C34878D82A}">
+                    <a16:rowId xmlns:a16="http://schemas.microsoft.com/office/drawing/2014/main" val="10001"/>
+                  </a:ext>
+                </a:extLst>
               </a:tr>
               <a:tr h="384048">
                 <a:tc>
@@ -8567,7 +9071,7 @@
                     <a:bodyPr/>
                     <a:lstStyle/>
                     <a:p>
-                      <a:pPr algn="l" indent="0" marL="0">
+                      <a:pPr marL="0" indent="0" algn="l">
                         <a:buNone/>
                       </a:pPr>
                       <a:r>
@@ -8588,7 +9092,7 @@
                       </a:endParaRPr>
                     </a:p>
                   </a:txBody>
-                  <a:tcPr marL="91440" marR="91440" marT="45720" marB="45720" anchor="ctr">
+                  <a:tcPr anchor="ctr">
                     <a:lnL w="6350" cap="flat" cmpd="sng" algn="ctr">
                       <a:solidFill>
                         <a:srgbClr val="CADCFC"/>
@@ -8632,7 +9136,7 @@
                     <a:bodyPr/>
                     <a:lstStyle/>
                     <a:p>
-                      <a:pPr algn="l" indent="0" marL="0">
+                      <a:pPr marL="0" indent="0" algn="l">
                         <a:buNone/>
                       </a:pPr>
                       <a:r>
@@ -8653,7 +9157,7 @@
                       </a:endParaRPr>
                     </a:p>
                   </a:txBody>
-                  <a:tcPr marL="91440" marR="91440" marT="45720" marB="45720" anchor="ctr">
+                  <a:tcPr anchor="ctr">
                     <a:lnL w="6350" cap="flat" cmpd="sng" algn="ctr">
                       <a:solidFill>
                         <a:srgbClr val="CADCFC"/>
@@ -8692,6 +9196,11 @@
                     </a:lnB>
                   </a:tcPr>
                 </a:tc>
+                <a:extLst>
+                  <a:ext uri="{0D108BD9-81ED-4DB2-BD59-A6C34878D82A}">
+                    <a16:rowId xmlns:a16="http://schemas.microsoft.com/office/drawing/2014/main" val="10002"/>
+                  </a:ext>
+                </a:extLst>
               </a:tr>
               <a:tr h="384048">
                 <a:tc>
@@ -8699,7 +9208,7 @@
                     <a:bodyPr/>
                     <a:lstStyle/>
                     <a:p>
-                      <a:pPr algn="l" indent="0" marL="0">
+                      <a:pPr marL="0" indent="0" algn="l">
                         <a:buNone/>
                       </a:pPr>
                       <a:r>
@@ -8720,7 +9229,7 @@
                       </a:endParaRPr>
                     </a:p>
                   </a:txBody>
-                  <a:tcPr marL="91440" marR="91440" marT="45720" marB="45720" anchor="ctr">
+                  <a:tcPr anchor="ctr">
                     <a:lnL w="6350" cap="flat" cmpd="sng" algn="ctr">
                       <a:solidFill>
                         <a:srgbClr val="CADCFC"/>
@@ -8764,7 +9273,7 @@
                     <a:bodyPr/>
                     <a:lstStyle/>
                     <a:p>
-                      <a:pPr algn="l" indent="0" marL="0">
+                      <a:pPr marL="0" indent="0" algn="l">
                         <a:buNone/>
                       </a:pPr>
                       <a:r>
@@ -8785,7 +9294,7 @@
                       </a:endParaRPr>
                     </a:p>
                   </a:txBody>
-                  <a:tcPr marL="91440" marR="91440" marT="45720" marB="45720" anchor="ctr">
+                  <a:tcPr anchor="ctr">
                     <a:lnL w="6350" cap="flat" cmpd="sng" algn="ctr">
                       <a:solidFill>
                         <a:srgbClr val="CADCFC"/>
@@ -8824,6 +9333,11 @@
                     </a:lnB>
                   </a:tcPr>
                 </a:tc>
+                <a:extLst>
+                  <a:ext uri="{0D108BD9-81ED-4DB2-BD59-A6C34878D82A}">
+                    <a16:rowId xmlns:a16="http://schemas.microsoft.com/office/drawing/2014/main" val="10003"/>
+                  </a:ext>
+                </a:extLst>
               </a:tr>
               <a:tr h="384048">
                 <a:tc>
@@ -8831,7 +9345,7 @@
                     <a:bodyPr/>
                     <a:lstStyle/>
                     <a:p>
-                      <a:pPr algn="l" indent="0" marL="0">
+                      <a:pPr marL="0" indent="0" algn="l">
                         <a:buNone/>
                       </a:pPr>
                       <a:r>
@@ -8852,7 +9366,7 @@
                       </a:endParaRPr>
                     </a:p>
                   </a:txBody>
-                  <a:tcPr marL="91440" marR="91440" marT="45720" marB="45720" anchor="ctr">
+                  <a:tcPr anchor="ctr">
                     <a:lnL w="6350" cap="flat" cmpd="sng" algn="ctr">
                       <a:solidFill>
                         <a:srgbClr val="CADCFC"/>
@@ -8896,7 +9410,7 @@
                     <a:bodyPr/>
                     <a:lstStyle/>
                     <a:p>
-                      <a:pPr algn="l" indent="0" marL="0">
+                      <a:pPr marL="0" indent="0" algn="l">
                         <a:buNone/>
                       </a:pPr>
                       <a:r>
@@ -8917,7 +9431,7 @@
                       </a:endParaRPr>
                     </a:p>
                   </a:txBody>
-                  <a:tcPr marL="91440" marR="91440" marT="45720" marB="45720" anchor="ctr">
+                  <a:tcPr anchor="ctr">
                     <a:lnL w="6350" cap="flat" cmpd="sng" algn="ctr">
                       <a:solidFill>
                         <a:srgbClr val="CADCFC"/>
@@ -8956,6 +9470,11 @@
                     </a:lnB>
                   </a:tcPr>
                 </a:tc>
+                <a:extLst>
+                  <a:ext uri="{0D108BD9-81ED-4DB2-BD59-A6C34878D82A}">
+                    <a16:rowId xmlns:a16="http://schemas.microsoft.com/office/drawing/2014/main" val="10004"/>
+                  </a:ext>
+                </a:extLst>
               </a:tr>
               <a:tr h="384048">
                 <a:tc>
@@ -8963,7 +9482,7 @@
                     <a:bodyPr/>
                     <a:lstStyle/>
                     <a:p>
-                      <a:pPr algn="l" indent="0" marL="0">
+                      <a:pPr marL="0" indent="0" algn="l">
                         <a:buNone/>
                       </a:pPr>
                       <a:r>
@@ -8984,7 +9503,7 @@
                       </a:endParaRPr>
                     </a:p>
                   </a:txBody>
-                  <a:tcPr marL="91440" marR="91440" marT="45720" marB="45720" anchor="ctr">
+                  <a:tcPr anchor="ctr">
                     <a:lnL w="6350" cap="flat" cmpd="sng" algn="ctr">
                       <a:solidFill>
                         <a:srgbClr val="CADCFC"/>
@@ -9028,7 +9547,7 @@
                     <a:bodyPr/>
                     <a:lstStyle/>
                     <a:p>
-                      <a:pPr algn="l" indent="0" marL="0">
+                      <a:pPr marL="0" indent="0" algn="l">
                         <a:buNone/>
                       </a:pPr>
                       <a:r>
@@ -9049,7 +9568,7 @@
                       </a:endParaRPr>
                     </a:p>
                   </a:txBody>
-                  <a:tcPr marL="91440" marR="91440" marT="45720" marB="45720" anchor="ctr">
+                  <a:tcPr anchor="ctr">
                     <a:lnL w="6350" cap="flat" cmpd="sng" algn="ctr">
                       <a:solidFill>
                         <a:srgbClr val="CADCFC"/>
@@ -9088,6 +9607,11 @@
                     </a:lnB>
                   </a:tcPr>
                 </a:tc>
+                <a:extLst>
+                  <a:ext uri="{0D108BD9-81ED-4DB2-BD59-A6C34878D82A}">
+                    <a16:rowId xmlns:a16="http://schemas.microsoft.com/office/drawing/2014/main" val="10005"/>
+                  </a:ext>
+                </a:extLst>
               </a:tr>
               <a:tr h="384048">
                 <a:tc>
@@ -9095,7 +9619,7 @@
                     <a:bodyPr/>
                     <a:lstStyle/>
                     <a:p>
-                      <a:pPr algn="l" indent="0" marL="0">
+                      <a:pPr marL="0" indent="0" algn="l">
                         <a:buNone/>
                       </a:pPr>
                       <a:r>
@@ -9116,7 +9640,7 @@
                       </a:endParaRPr>
                     </a:p>
                   </a:txBody>
-                  <a:tcPr marL="91440" marR="91440" marT="45720" marB="45720" anchor="ctr">
+                  <a:tcPr anchor="ctr">
                     <a:lnL w="6350" cap="flat" cmpd="sng" algn="ctr">
                       <a:solidFill>
                         <a:srgbClr val="CADCFC"/>
@@ -9160,7 +9684,7 @@
                     <a:bodyPr/>
                     <a:lstStyle/>
                     <a:p>
-                      <a:pPr algn="l" indent="0" marL="0">
+                      <a:pPr marL="0" indent="0" algn="l">
                         <a:buNone/>
                       </a:pPr>
                       <a:r>
@@ -9181,7 +9705,7 @@
                       </a:endParaRPr>
                     </a:p>
                   </a:txBody>
-                  <a:tcPr marL="91440" marR="91440" marT="45720" marB="45720" anchor="ctr">
+                  <a:tcPr anchor="ctr">
                     <a:lnL w="6350" cap="flat" cmpd="sng" algn="ctr">
                       <a:solidFill>
                         <a:srgbClr val="CADCFC"/>
@@ -9220,6 +9744,11 @@
                     </a:lnB>
                   </a:tcPr>
                 </a:tc>
+                <a:extLst>
+                  <a:ext uri="{0D108BD9-81ED-4DB2-BD59-A6C34878D82A}">
+                    <a16:rowId xmlns:a16="http://schemas.microsoft.com/office/drawing/2014/main" val="10006"/>
+                  </a:ext>
+                </a:extLst>
               </a:tr>
             </a:tbl>
           </a:graphicData>
@@ -9526,4 +10055,319 @@
     </a:ext>
   </a:extLst>
 </a:theme>
+</file>
+
+<file path=ppt/theme/theme2.xml><?xml version="1.0" encoding="utf-8"?>
+<a:theme xmlns:a="http://schemas.openxmlformats.org/drawingml/2006/main" name="Office Teması">
+  <a:themeElements>
+    <a:clrScheme name="Office">
+      <a:dk1>
+        <a:sysClr val="windowText" lastClr="000000"/>
+      </a:dk1>
+      <a:lt1>
+        <a:sysClr val="window" lastClr="FFFFFF"/>
+      </a:lt1>
+      <a:dk2>
+        <a:srgbClr val="0E2841"/>
+      </a:dk2>
+      <a:lt2>
+        <a:srgbClr val="E8E8E8"/>
+      </a:lt2>
+      <a:accent1>
+        <a:srgbClr val="156082"/>
+      </a:accent1>
+      <a:accent2>
+        <a:srgbClr val="E97132"/>
+      </a:accent2>
+      <a:accent3>
+        <a:srgbClr val="196B24"/>
+      </a:accent3>
+      <a:accent4>
+        <a:srgbClr val="0F9ED5"/>
+      </a:accent4>
+      <a:accent5>
+        <a:srgbClr val="A02B93"/>
+      </a:accent5>
+      <a:accent6>
+        <a:srgbClr val="4EA72E"/>
+      </a:accent6>
+      <a:hlink>
+        <a:srgbClr val="467886"/>
+      </a:hlink>
+      <a:folHlink>
+        <a:srgbClr val="96607D"/>
+      </a:folHlink>
+    </a:clrScheme>
+    <a:fontScheme name="Office">
+      <a:majorFont>
+        <a:latin typeface="Aptos Display" panose="02110004020202020204"/>
+        <a:ea typeface=""/>
+        <a:cs typeface=""/>
+        <a:font script="Jpan" typeface="游ゴシック Light"/>
+        <a:font script="Hang" typeface="맑은 고딕"/>
+        <a:font script="Hans" typeface="等线 Light"/>
+        <a:font script="Hant" typeface="新細明體"/>
+        <a:font script="Arab" typeface="Times New Roman"/>
+        <a:font script="Hebr" typeface="Times New Roman"/>
+        <a:font script="Thai" typeface="Angsana New"/>
+        <a:font script="Ethi" typeface="Nyala"/>
+        <a:font script="Beng" typeface="Vrinda"/>
+        <a:font script="Gujr" typeface="Shruti"/>
+        <a:font script="Khmr" typeface="MoolBoran"/>
+        <a:font script="Knda" typeface="Tunga"/>
+        <a:font script="Guru" typeface="Raavi"/>
+        <a:font script="Cans" typeface="Euphemia"/>
+        <a:font script="Cher" typeface="Plantagenet Cherokee"/>
+        <a:font script="Yiii" typeface="Microsoft Yi Baiti"/>
+        <a:font script="Tibt" typeface="Microsoft Himalaya"/>
+        <a:font script="Thaa" typeface="MV Boli"/>
+        <a:font script="Deva" typeface="Mangal"/>
+        <a:font script="Telu" typeface="Gautami"/>
+        <a:font script="Taml" typeface="Latha"/>
+        <a:font script="Syrc" typeface="Estrangelo Edessa"/>
+        <a:font script="Orya" typeface="Kalinga"/>
+        <a:font script="Mlym" typeface="Kartika"/>
+        <a:font script="Laoo" typeface="DokChampa"/>
+        <a:font script="Sinh" typeface="Iskoola Pota"/>
+        <a:font script="Mong" typeface="Mongolian Baiti"/>
+        <a:font script="Viet" typeface="Times New Roman"/>
+        <a:font script="Uigh" typeface="Microsoft Uighur"/>
+        <a:font script="Geor" typeface="Sylfaen"/>
+        <a:font script="Armn" typeface="Arial"/>
+        <a:font script="Bugi" typeface="Leelawadee UI"/>
+        <a:font script="Bopo" typeface="Microsoft JhengHei"/>
+        <a:font script="Java" typeface="Javanese Text"/>
+        <a:font script="Lisu" typeface="Segoe UI"/>
+        <a:font script="Mymr" typeface="Myanmar Text"/>
+        <a:font script="Nkoo" typeface="Ebrima"/>
+        <a:font script="Olck" typeface="Nirmala UI"/>
+        <a:font script="Osma" typeface="Ebrima"/>
+        <a:font script="Phag" typeface="Phagspa"/>
+        <a:font script="Syrn" typeface="Estrangelo Edessa"/>
+        <a:font script="Syrj" typeface="Estrangelo Edessa"/>
+        <a:font script="Syre" typeface="Estrangelo Edessa"/>
+        <a:font script="Sora" typeface="Nirmala UI"/>
+        <a:font script="Tale" typeface="Microsoft Tai Le"/>
+        <a:font script="Talu" typeface="Microsoft New Tai Lue"/>
+        <a:font script="Tfng" typeface="Ebrima"/>
+      </a:majorFont>
+      <a:minorFont>
+        <a:latin typeface="Aptos" panose="02110004020202020204"/>
+        <a:ea typeface=""/>
+        <a:cs typeface=""/>
+        <a:font script="Jpan" typeface="游ゴシック"/>
+        <a:font script="Hang" typeface="맑은 고딕"/>
+        <a:font script="Hans" typeface="等线"/>
+        <a:font script="Hant" typeface="新細明體"/>
+        <a:font script="Arab" typeface="Arial"/>
+        <a:font script="Hebr" typeface="Arial"/>
+        <a:font script="Thai" typeface="Cordia New"/>
+        <a:font script="Ethi" typeface="Nyala"/>
+        <a:font script="Beng" typeface="Vrinda"/>
+        <a:font script="Gujr" typeface="Shruti"/>
+        <a:font script="Khmr" typeface="DaunPenh"/>
+        <a:font script="Knda" typeface="Tunga"/>
+        <a:font script="Guru" typeface="Raavi"/>
+        <a:font script="Cans" typeface="Euphemia"/>
+        <a:font script="Cher" typeface="Plantagenet Cherokee"/>
+        <a:font script="Yiii" typeface="Microsoft Yi Baiti"/>
+        <a:font script="Tibt" typeface="Microsoft Himalaya"/>
+        <a:font script="Thaa" typeface="MV Boli"/>
+        <a:font script="Deva" typeface="Mangal"/>
+        <a:font script="Telu" typeface="Gautami"/>
+        <a:font script="Taml" typeface="Latha"/>
+        <a:font script="Syrc" typeface="Estrangelo Edessa"/>
+        <a:font script="Orya" typeface="Kalinga"/>
+        <a:font script="Mlym" typeface="Kartika"/>
+        <a:font script="Laoo" typeface="DokChampa"/>
+        <a:font script="Sinh" typeface="Iskoola Pota"/>
+        <a:font script="Mong" typeface="Mongolian Baiti"/>
+        <a:font script="Viet" typeface="Arial"/>
+        <a:font script="Uigh" typeface="Microsoft Uighur"/>
+        <a:font script="Geor" typeface="Sylfaen"/>
+        <a:font script="Armn" typeface="Arial"/>
+        <a:font script="Bugi" typeface="Leelawadee UI"/>
+        <a:font script="Bopo" typeface="Microsoft JhengHei"/>
+        <a:font script="Java" typeface="Javanese Text"/>
+        <a:font script="Lisu" typeface="Segoe UI"/>
+        <a:font script="Mymr" typeface="Myanmar Text"/>
+        <a:font script="Nkoo" typeface="Ebrima"/>
+        <a:font script="Olck" typeface="Nirmala UI"/>
+        <a:font script="Osma" typeface="Ebrima"/>
+        <a:font script="Phag" typeface="Phagspa"/>
+        <a:font script="Syrn" typeface="Estrangelo Edessa"/>
+        <a:font script="Syrj" typeface="Estrangelo Edessa"/>
+        <a:font script="Syre" typeface="Estrangelo Edessa"/>
+        <a:font script="Sora" typeface="Nirmala UI"/>
+        <a:font script="Tale" typeface="Microsoft Tai Le"/>
+        <a:font script="Talu" typeface="Microsoft New Tai Lue"/>
+        <a:font script="Tfng" typeface="Ebrima"/>
+      </a:minorFont>
+    </a:fontScheme>
+    <a:fmtScheme name="Office">
+      <a:fillStyleLst>
+        <a:solidFill>
+          <a:schemeClr val="phClr"/>
+        </a:solidFill>
+        <a:gradFill rotWithShape="1">
+          <a:gsLst>
+            <a:gs pos="0">
+              <a:schemeClr val="phClr">
+                <a:lumMod val="110000"/>
+                <a:satMod val="105000"/>
+                <a:tint val="67000"/>
+              </a:schemeClr>
+            </a:gs>
+            <a:gs pos="50000">
+              <a:schemeClr val="phClr">
+                <a:lumMod val="105000"/>
+                <a:satMod val="103000"/>
+                <a:tint val="73000"/>
+              </a:schemeClr>
+            </a:gs>
+            <a:gs pos="100000">
+              <a:schemeClr val="phClr">
+                <a:lumMod val="105000"/>
+                <a:satMod val="109000"/>
+                <a:tint val="81000"/>
+              </a:schemeClr>
+            </a:gs>
+          </a:gsLst>
+          <a:lin ang="5400000" scaled="0"/>
+        </a:gradFill>
+        <a:gradFill rotWithShape="1">
+          <a:gsLst>
+            <a:gs pos="0">
+              <a:schemeClr val="phClr">
+                <a:satMod val="103000"/>
+                <a:lumMod val="102000"/>
+                <a:tint val="94000"/>
+              </a:schemeClr>
+            </a:gs>
+            <a:gs pos="50000">
+              <a:schemeClr val="phClr">
+                <a:satMod val="110000"/>
+                <a:lumMod val="100000"/>
+                <a:shade val="100000"/>
+              </a:schemeClr>
+            </a:gs>
+            <a:gs pos="100000">
+              <a:schemeClr val="phClr">
+                <a:lumMod val="99000"/>
+                <a:satMod val="120000"/>
+                <a:shade val="78000"/>
+              </a:schemeClr>
+            </a:gs>
+          </a:gsLst>
+          <a:lin ang="5400000" scaled="0"/>
+        </a:gradFill>
+      </a:fillStyleLst>
+      <a:lnStyleLst>
+        <a:ln w="12700" cap="flat" cmpd="sng" algn="ctr">
+          <a:solidFill>
+            <a:schemeClr val="phClr"/>
+          </a:solidFill>
+          <a:prstDash val="solid"/>
+          <a:miter lim="800000"/>
+        </a:ln>
+        <a:ln w="19050" cap="flat" cmpd="sng" algn="ctr">
+          <a:solidFill>
+            <a:schemeClr val="phClr"/>
+          </a:solidFill>
+          <a:prstDash val="solid"/>
+          <a:miter lim="800000"/>
+        </a:ln>
+        <a:ln w="25400" cap="flat" cmpd="sng" algn="ctr">
+          <a:solidFill>
+            <a:schemeClr val="phClr"/>
+          </a:solidFill>
+          <a:prstDash val="solid"/>
+          <a:miter lim="800000"/>
+        </a:ln>
+      </a:lnStyleLst>
+      <a:effectStyleLst>
+        <a:effectStyle>
+          <a:effectLst/>
+        </a:effectStyle>
+        <a:effectStyle>
+          <a:effectLst/>
+        </a:effectStyle>
+        <a:effectStyle>
+          <a:effectLst>
+            <a:outerShdw blurRad="57150" dist="19050" dir="5400000" algn="ctr" rotWithShape="0">
+              <a:srgbClr val="000000">
+                <a:alpha val="63000"/>
+              </a:srgbClr>
+            </a:outerShdw>
+          </a:effectLst>
+        </a:effectStyle>
+      </a:effectStyleLst>
+      <a:bgFillStyleLst>
+        <a:solidFill>
+          <a:schemeClr val="phClr"/>
+        </a:solidFill>
+        <a:solidFill>
+          <a:schemeClr val="phClr">
+            <a:tint val="95000"/>
+            <a:satMod val="170000"/>
+          </a:schemeClr>
+        </a:solidFill>
+        <a:gradFill rotWithShape="1">
+          <a:gsLst>
+            <a:gs pos="0">
+              <a:schemeClr val="phClr">
+                <a:tint val="93000"/>
+                <a:satMod val="150000"/>
+                <a:shade val="98000"/>
+                <a:lumMod val="102000"/>
+              </a:schemeClr>
+            </a:gs>
+            <a:gs pos="50000">
+              <a:schemeClr val="phClr">
+                <a:tint val="98000"/>
+                <a:satMod val="130000"/>
+                <a:shade val="90000"/>
+                <a:lumMod val="103000"/>
+              </a:schemeClr>
+            </a:gs>
+            <a:gs pos="100000">
+              <a:schemeClr val="phClr">
+                <a:shade val="63000"/>
+                <a:satMod val="120000"/>
+              </a:schemeClr>
+            </a:gs>
+          </a:gsLst>
+          <a:lin ang="5400000" scaled="0"/>
+        </a:gradFill>
+      </a:bgFillStyleLst>
+    </a:fmtScheme>
+  </a:themeElements>
+  <a:objectDefaults>
+    <a:lnDef>
+      <a:spPr/>
+      <a:bodyPr/>
+      <a:lstStyle/>
+      <a:style>
+        <a:lnRef idx="2">
+          <a:schemeClr val="accent1"/>
+        </a:lnRef>
+        <a:fillRef idx="0">
+          <a:schemeClr val="accent1"/>
+        </a:fillRef>
+        <a:effectRef idx="1">
+          <a:schemeClr val="accent1"/>
+        </a:effectRef>
+        <a:fontRef idx="minor">
+          <a:schemeClr val="tx1"/>
+        </a:fontRef>
+      </a:style>
+    </a:lnDef>
+  </a:objectDefaults>
+  <a:extraClrSchemeLst/>
+  <a:extLst>
+    <a:ext uri="{05A4C25C-085E-4340-85A3-A5531E510DB2}">
+      <thm15:themeFamily xmlns:thm15="http://schemas.microsoft.com/office/thememl/2012/main" name="Office Theme" id="{2E142A2C-CD16-42D6-873A-C26D2A0506FA}" vid="{1BDDFF52-6CD6-40A5-AB3C-68EB2F1E4D0A}"/>
+    </a:ext>
+  </a:extLst>
+</a:theme>
 </file>
</xml_diff>